<commit_message>
Updating slide order and formatting
</commit_message>
<xml_diff>
--- a/Slides/RPackageDevelopment_Slides.pptx
+++ b/Slides/RPackageDevelopment_Slides.pptx
@@ -16,11 +16,11 @@
     <p:sldId id="321" r:id="rId7"/>
     <p:sldId id="436" r:id="rId8"/>
     <p:sldId id="323" r:id="rId9"/>
-    <p:sldId id="450" r:id="rId10"/>
-    <p:sldId id="437" r:id="rId11"/>
-    <p:sldId id="406" r:id="rId12"/>
-    <p:sldId id="428" r:id="rId13"/>
-    <p:sldId id="429" r:id="rId14"/>
+    <p:sldId id="428" r:id="rId10"/>
+    <p:sldId id="429" r:id="rId11"/>
+    <p:sldId id="450" r:id="rId12"/>
+    <p:sldId id="437" r:id="rId13"/>
+    <p:sldId id="406" r:id="rId14"/>
     <p:sldId id="407" r:id="rId15"/>
     <p:sldId id="445" r:id="rId16"/>
     <p:sldId id="446" r:id="rId17"/>
@@ -167,7 +167,7 @@
 <file path=ppt/revisionInfo.xml><?xml version="1.0" encoding="utf-8"?>
 <p1510:revInfo xmlns:a="http://schemas.openxmlformats.org/drawingml/2006/main" xmlns:r="http://schemas.openxmlformats.org/officeDocument/2006/relationships" xmlns:p1510="http://schemas.microsoft.com/office/powerpoint/2015/10/main">
   <p1510:revLst>
-    <p1510:client id="{7B91186F-AFD7-4556-9E93-756AA89B05D5}" v="59" dt="2026-08-11T20:15:22.039"/>
+    <p1510:client id="{7B91186F-AFD7-4556-9E93-756AA89B05D5}" v="65" dt="2026-08-14T14:52:08.480"/>
   </p1510:revLst>
 </p1510:revInfo>
 </file>
@@ -181,13 +181,6 @@
       <pc:docMkLst>
         <pc:docMk/>
       </pc:docMkLst>
-      <pc:sldChg chg="add del ord">
-        <pc:chgData name="Adrien Osakwe" userId="7a3e290c-eb83-484b-8e3d-d46ef2333477" providerId="ADAL" clId="{09ABE13D-32B9-4646-8B10-CB7999C84D02}" dt="2026-07-14T20:18:16.032" v="63" actId="20578"/>
-        <pc:sldMkLst>
-          <pc:docMk/>
-          <pc:sldMk cId="3959237559" sldId="256"/>
-        </pc:sldMkLst>
-      </pc:sldChg>
       <pc:sldChg chg="modSp add mod ord">
         <pc:chgData name="Adrien Osakwe" userId="7a3e290c-eb83-484b-8e3d-d46ef2333477" providerId="ADAL" clId="{09ABE13D-32B9-4646-8B10-CB7999C84D02}" dt="2026-07-15T15:43:00.354" v="3307" actId="20577"/>
         <pc:sldMkLst>
@@ -202,13 +195,6 @@
             <ac:spMk id="2" creationId="{10C0557F-5508-20BC-7CF6-DF79F9930C8B}"/>
           </ac:spMkLst>
         </pc:spChg>
-      </pc:sldChg>
-      <pc:sldChg chg="add">
-        <pc:chgData name="Adrien Osakwe" userId="7a3e290c-eb83-484b-8e3d-d46ef2333477" providerId="ADAL" clId="{09ABE13D-32B9-4646-8B10-CB7999C84D02}" dt="2026-07-14T20:12:53.878" v="2"/>
-        <pc:sldMkLst>
-          <pc:docMk/>
-          <pc:sldMk cId="3735510520" sldId="260"/>
-        </pc:sldMkLst>
       </pc:sldChg>
       <pc:sldChg chg="modSp add mod ord">
         <pc:chgData name="Adrien Osakwe" userId="7a3e290c-eb83-484b-8e3d-d46ef2333477" providerId="ADAL" clId="{09ABE13D-32B9-4646-8B10-CB7999C84D02}" dt="2026-07-15T18:05:22.921" v="3312" actId="20577"/>
@@ -231,22 +217,6 @@
           <pc:docMk/>
           <pc:sldMk cId="3587535936" sldId="320"/>
         </pc:sldMkLst>
-        <pc:spChg chg="add mod">
-          <ac:chgData name="Adrien Osakwe" userId="7a3e290c-eb83-484b-8e3d-d46ef2333477" providerId="ADAL" clId="{09ABE13D-32B9-4646-8B10-CB7999C84D02}" dt="2026-07-14T20:19:01.144" v="100" actId="20577"/>
-          <ac:spMkLst>
-            <pc:docMk/>
-            <pc:sldMk cId="3587535936" sldId="320"/>
-            <ac:spMk id="3" creationId="{1A675FF3-F5C4-4D9D-72F6-339B99ED886F}"/>
-          </ac:spMkLst>
-        </pc:spChg>
-        <pc:spChg chg="add mod">
-          <ac:chgData name="Adrien Osakwe" userId="7a3e290c-eb83-484b-8e3d-d46ef2333477" providerId="ADAL" clId="{09ABE13D-32B9-4646-8B10-CB7999C84D02}" dt="2026-07-14T20:19:19.369" v="143" actId="20577"/>
-          <ac:spMkLst>
-            <pc:docMk/>
-            <pc:sldMk cId="3587535936" sldId="320"/>
-            <ac:spMk id="4" creationId="{5FC2150F-A588-4511-139C-D809D8400571}"/>
-          </ac:spMkLst>
-        </pc:spChg>
         <pc:picChg chg="add mod">
           <ac:chgData name="Adrien Osakwe" userId="7a3e290c-eb83-484b-8e3d-d46ef2333477" providerId="ADAL" clId="{09ABE13D-32B9-4646-8B10-CB7999C84D02}" dt="2026-07-15T15:46:41.284" v="3310" actId="14100"/>
           <ac:picMkLst>
@@ -257,72 +227,11 @@
         </pc:picChg>
       </pc:sldChg>
       <pc:sldChg chg="modSp new mod">
-        <pc:chgData name="Adrien Osakwe" userId="7a3e290c-eb83-484b-8e3d-d46ef2333477" providerId="ADAL" clId="{09ABE13D-32B9-4646-8B10-CB7999C84D02}" dt="2026-07-14T20:50:35.437" v="479" actId="20577"/>
-        <pc:sldMkLst>
-          <pc:docMk/>
-          <pc:sldMk cId="3602721871" sldId="321"/>
-        </pc:sldMkLst>
-        <pc:spChg chg="mod">
-          <ac:chgData name="Adrien Osakwe" userId="7a3e290c-eb83-484b-8e3d-d46ef2333477" providerId="ADAL" clId="{09ABE13D-32B9-4646-8B10-CB7999C84D02}" dt="2026-07-14T20:40:44.079" v="161" actId="20577"/>
-          <ac:spMkLst>
-            <pc:docMk/>
-            <pc:sldMk cId="3602721871" sldId="321"/>
-            <ac:spMk id="2" creationId="{617AD453-1B50-891F-EA57-93BE367EC635}"/>
-          </ac:spMkLst>
-        </pc:spChg>
-        <pc:spChg chg="mod">
-          <ac:chgData name="Adrien Osakwe" userId="7a3e290c-eb83-484b-8e3d-d46ef2333477" providerId="ADAL" clId="{09ABE13D-32B9-4646-8B10-CB7999C84D02}" dt="2026-07-14T20:50:35.437" v="479" actId="20577"/>
-          <ac:spMkLst>
-            <pc:docMk/>
-            <pc:sldMk cId="3602721871" sldId="321"/>
-            <ac:spMk id="3" creationId="{8296774D-2E53-E4B2-B8EA-360BC110FD38}"/>
-          </ac:spMkLst>
-        </pc:spChg>
-      </pc:sldChg>
-      <pc:sldChg chg="modSp add mod">
-        <pc:chgData name="Adrien Osakwe" userId="7a3e290c-eb83-484b-8e3d-d46ef2333477" providerId="ADAL" clId="{09ABE13D-32B9-4646-8B10-CB7999C84D02}" dt="2026-07-14T20:51:35.274" v="517" actId="20577"/>
-        <pc:sldMkLst>
-          <pc:docMk/>
-          <pc:sldMk cId="223915468" sldId="323"/>
-        </pc:sldMkLst>
-        <pc:spChg chg="mod">
-          <ac:chgData name="Adrien Osakwe" userId="7a3e290c-eb83-484b-8e3d-d46ef2333477" providerId="ADAL" clId="{09ABE13D-32B9-4646-8B10-CB7999C84D02}" dt="2026-07-14T20:51:35.274" v="517" actId="20577"/>
-          <ac:spMkLst>
-            <pc:docMk/>
-            <pc:sldMk cId="223915468" sldId="323"/>
-            <ac:spMk id="3" creationId="{6CF8068E-9C93-CB78-065E-0CAF6A6BF497}"/>
-          </ac:spMkLst>
-        </pc:spChg>
-      </pc:sldChg>
-      <pc:sldChg chg="modSp add mod">
-        <pc:chgData name="Adrien Osakwe" userId="7a3e290c-eb83-484b-8e3d-d46ef2333477" providerId="ADAL" clId="{09ABE13D-32B9-4646-8B10-CB7999C84D02}" dt="2026-07-14T20:52:29.099" v="575" actId="20577"/>
-        <pc:sldMkLst>
-          <pc:docMk/>
-          <pc:sldMk cId="2341505858" sldId="324"/>
-        </pc:sldMkLst>
-        <pc:spChg chg="mod">
-          <ac:chgData name="Adrien Osakwe" userId="7a3e290c-eb83-484b-8e3d-d46ef2333477" providerId="ADAL" clId="{09ABE13D-32B9-4646-8B10-CB7999C84D02}" dt="2026-07-14T20:52:29.099" v="575" actId="20577"/>
-          <ac:spMkLst>
-            <pc:docMk/>
-            <pc:sldMk cId="2341505858" sldId="324"/>
-            <ac:spMk id="3" creationId="{154509B3-1BE7-E9C4-5DF5-A583F50756B6}"/>
-          </ac:spMkLst>
-        </pc:spChg>
-      </pc:sldChg>
-      <pc:sldChg chg="modSp new mod">
         <pc:chgData name="Adrien Osakwe" userId="7a3e290c-eb83-484b-8e3d-d46ef2333477" providerId="ADAL" clId="{09ABE13D-32B9-4646-8B10-CB7999C84D02}" dt="2026-07-15T14:51:10.692" v="1997" actId="20577"/>
         <pc:sldMkLst>
           <pc:docMk/>
           <pc:sldMk cId="775350422" sldId="327"/>
         </pc:sldMkLst>
-        <pc:spChg chg="mod">
-          <ac:chgData name="Adrien Osakwe" userId="7a3e290c-eb83-484b-8e3d-d46ef2333477" providerId="ADAL" clId="{09ABE13D-32B9-4646-8B10-CB7999C84D02}" dt="2026-07-14T20:52:58.860" v="643" actId="20577"/>
-          <ac:spMkLst>
-            <pc:docMk/>
-            <pc:sldMk cId="775350422" sldId="327"/>
-            <ac:spMk id="2" creationId="{FE915632-C511-A9E9-D340-BEC667515236}"/>
-          </ac:spMkLst>
-        </pc:spChg>
         <pc:spChg chg="mod">
           <ac:chgData name="Adrien Osakwe" userId="7a3e290c-eb83-484b-8e3d-d46ef2333477" providerId="ADAL" clId="{09ABE13D-32B9-4646-8B10-CB7999C84D02}" dt="2026-07-15T14:51:10.692" v="1997" actId="20577"/>
           <ac:spMkLst>
@@ -332,43 +241,12 @@
           </ac:spMkLst>
         </pc:spChg>
       </pc:sldChg>
-      <pc:sldChg chg="modSp new mod">
-        <pc:chgData name="Adrien Osakwe" userId="7a3e290c-eb83-484b-8e3d-d46ef2333477" providerId="ADAL" clId="{09ABE13D-32B9-4646-8B10-CB7999C84D02}" dt="2026-07-14T20:54:58.987" v="879" actId="113"/>
-        <pc:sldMkLst>
-          <pc:docMk/>
-          <pc:sldMk cId="4003429187" sldId="328"/>
-        </pc:sldMkLst>
-        <pc:spChg chg="mod">
-          <ac:chgData name="Adrien Osakwe" userId="7a3e290c-eb83-484b-8e3d-d46ef2333477" providerId="ADAL" clId="{09ABE13D-32B9-4646-8B10-CB7999C84D02}" dt="2026-07-14T20:54:00.987" v="686" actId="20577"/>
-          <ac:spMkLst>
-            <pc:docMk/>
-            <pc:sldMk cId="4003429187" sldId="328"/>
-            <ac:spMk id="2" creationId="{74428F7B-DC2B-85A5-1C1F-AD0171621091}"/>
-          </ac:spMkLst>
-        </pc:spChg>
-        <pc:spChg chg="mod">
-          <ac:chgData name="Adrien Osakwe" userId="7a3e290c-eb83-484b-8e3d-d46ef2333477" providerId="ADAL" clId="{09ABE13D-32B9-4646-8B10-CB7999C84D02}" dt="2026-07-14T20:54:58.987" v="879" actId="113"/>
-          <ac:spMkLst>
-            <pc:docMk/>
-            <pc:sldMk cId="4003429187" sldId="328"/>
-            <ac:spMk id="3" creationId="{33D959FC-3BD5-F79B-6D54-99514B14242D}"/>
-          </ac:spMkLst>
-        </pc:spChg>
-      </pc:sldChg>
       <pc:sldChg chg="addSp modSp new mod">
         <pc:chgData name="Adrien Osakwe" userId="7a3e290c-eb83-484b-8e3d-d46ef2333477" providerId="ADAL" clId="{09ABE13D-32B9-4646-8B10-CB7999C84D02}" dt="2026-07-15T15:30:10.952" v="2730" actId="1037"/>
         <pc:sldMkLst>
           <pc:docMk/>
           <pc:sldMk cId="393444062" sldId="329"/>
         </pc:sldMkLst>
-        <pc:spChg chg="mod">
-          <ac:chgData name="Adrien Osakwe" userId="7a3e290c-eb83-484b-8e3d-d46ef2333477" providerId="ADAL" clId="{09ABE13D-32B9-4646-8B10-CB7999C84D02}" dt="2026-07-14T20:55:08.859" v="898" actId="20577"/>
-          <ac:spMkLst>
-            <pc:docMk/>
-            <pc:sldMk cId="393444062" sldId="329"/>
-            <ac:spMk id="2" creationId="{1CA3896D-A639-AB21-2F26-A2665F471F27}"/>
-          </ac:spMkLst>
-        </pc:spChg>
         <pc:spChg chg="mod">
           <ac:chgData name="Adrien Osakwe" userId="7a3e290c-eb83-484b-8e3d-d46ef2333477" providerId="ADAL" clId="{09ABE13D-32B9-4646-8B10-CB7999C84D02}" dt="2026-07-15T15:29:43.647" v="2719" actId="14100"/>
           <ac:spMkLst>
@@ -393,14 +271,6 @@
           <pc:sldMk cId="3227588993" sldId="330"/>
         </pc:sldMkLst>
         <pc:spChg chg="mod">
-          <ac:chgData name="Adrien Osakwe" userId="7a3e290c-eb83-484b-8e3d-d46ef2333477" providerId="ADAL" clId="{09ABE13D-32B9-4646-8B10-CB7999C84D02}" dt="2026-07-14T20:56:31.241" v="1212" actId="20577"/>
-          <ac:spMkLst>
-            <pc:docMk/>
-            <pc:sldMk cId="3227588993" sldId="330"/>
-            <ac:spMk id="2" creationId="{A456644B-FBEC-5421-3990-6EAEC51D647D}"/>
-          </ac:spMkLst>
-        </pc:spChg>
-        <pc:spChg chg="mod">
           <ac:chgData name="Adrien Osakwe" userId="7a3e290c-eb83-484b-8e3d-d46ef2333477" providerId="ADAL" clId="{09ABE13D-32B9-4646-8B10-CB7999C84D02}" dt="2026-07-15T15:34:33.295" v="3154" actId="5793"/>
           <ac:spMkLst>
             <pc:docMk/>
@@ -415,14 +285,6 @@
           <pc:docMk/>
           <pc:sldMk cId="3482164999" sldId="331"/>
         </pc:sldMkLst>
-        <pc:spChg chg="mod">
-          <ac:chgData name="Adrien Osakwe" userId="7a3e290c-eb83-484b-8e3d-d46ef2333477" providerId="ADAL" clId="{09ABE13D-32B9-4646-8B10-CB7999C84D02}" dt="2026-07-14T20:57:28.457" v="1464" actId="20577"/>
-          <ac:spMkLst>
-            <pc:docMk/>
-            <pc:sldMk cId="3482164999" sldId="331"/>
-            <ac:spMk id="2" creationId="{46FC251F-B5ED-1074-7347-BBF8BE63786F}"/>
-          </ac:spMkLst>
-        </pc:spChg>
         <pc:spChg chg="mod">
           <ac:chgData name="Adrien Osakwe" userId="7a3e290c-eb83-484b-8e3d-d46ef2333477" providerId="ADAL" clId="{09ABE13D-32B9-4646-8B10-CB7999C84D02}" dt="2026-07-15T15:31:46.805" v="3059" actId="20577"/>
           <ac:spMkLst>
@@ -617,98 +479,15 @@
           </ac:spMkLst>
         </pc:spChg>
       </pc:sldChg>
-      <pc:sldMasterChg chg="modSldLayout">
-        <pc:chgData name="Adrien Osakwe" userId="7a3e290c-eb83-484b-8e3d-d46ef2333477" providerId="ADAL" clId="{09ABE13D-32B9-4646-8B10-CB7999C84D02}" dt="2026-07-14T20:16:30.281" v="29" actId="478"/>
-        <pc:sldMasterMkLst>
-          <pc:docMk/>
-          <pc:sldMasterMk cId="1449374226" sldId="2147483660"/>
-        </pc:sldMasterMkLst>
-        <pc:sldLayoutChg chg="addSp delSp modSp mod">
-          <pc:chgData name="Adrien Osakwe" userId="7a3e290c-eb83-484b-8e3d-d46ef2333477" providerId="ADAL" clId="{09ABE13D-32B9-4646-8B10-CB7999C84D02}" dt="2026-07-14T20:16:30.281" v="29" actId="478"/>
-          <pc:sldLayoutMkLst>
-            <pc:docMk/>
-            <pc:sldMasterMk cId="1449374226" sldId="2147483660"/>
-            <pc:sldLayoutMk cId="3264083727" sldId="2147483661"/>
-          </pc:sldLayoutMkLst>
-          <pc:picChg chg="add mod">
-            <ac:chgData name="Adrien Osakwe" userId="7a3e290c-eb83-484b-8e3d-d46ef2333477" providerId="ADAL" clId="{09ABE13D-32B9-4646-8B10-CB7999C84D02}" dt="2026-07-14T20:15:50.424" v="24" actId="14100"/>
-            <ac:picMkLst>
-              <pc:docMk/>
-              <pc:sldMasterMk cId="1449374226" sldId="2147483660"/>
-              <pc:sldLayoutMk cId="3264083727" sldId="2147483661"/>
-              <ac:picMk id="4" creationId="{901F0B20-408F-2B4A-284C-54914990B943}"/>
-            </ac:picMkLst>
-          </pc:picChg>
-        </pc:sldLayoutChg>
-        <pc:sldLayoutChg chg="addSp modSp">
-          <pc:chgData name="Adrien Osakwe" userId="7a3e290c-eb83-484b-8e3d-d46ef2333477" providerId="ADAL" clId="{09ABE13D-32B9-4646-8B10-CB7999C84D02}" dt="2026-07-14T20:16:10.265" v="28" actId="1035"/>
-          <pc:sldLayoutMkLst>
-            <pc:docMk/>
-            <pc:sldMasterMk cId="1449374226" sldId="2147483660"/>
-            <pc:sldLayoutMk cId="322694191" sldId="2147483670"/>
-          </pc:sldLayoutMkLst>
-          <pc:picChg chg="add mod">
-            <ac:chgData name="Adrien Osakwe" userId="7a3e290c-eb83-484b-8e3d-d46ef2333477" providerId="ADAL" clId="{09ABE13D-32B9-4646-8B10-CB7999C84D02}" dt="2026-07-14T20:16:10.265" v="28" actId="1035"/>
-            <ac:picMkLst>
-              <pc:docMk/>
-              <pc:sldMasterMk cId="1449374226" sldId="2147483660"/>
-              <pc:sldLayoutMk cId="322694191" sldId="2147483670"/>
-              <ac:picMk id="2" creationId="{B4E0375E-06DE-CC3D-FC14-4D91EE6470F8}"/>
-            </ac:picMkLst>
-          </pc:picChg>
-          <pc:picChg chg="add mod">
-            <ac:chgData name="Adrien Osakwe" userId="7a3e290c-eb83-484b-8e3d-d46ef2333477" providerId="ADAL" clId="{09ABE13D-32B9-4646-8B10-CB7999C84D02}" dt="2026-07-14T20:16:10.265" v="28" actId="1035"/>
-            <ac:picMkLst>
-              <pc:docMk/>
-              <pc:sldMasterMk cId="1449374226" sldId="2147483660"/>
-              <pc:sldLayoutMk cId="322694191" sldId="2147483670"/>
-              <ac:picMk id="4" creationId="{48BA55F6-1EA5-F4BD-45AD-D7A800249734}"/>
-            </ac:picMkLst>
-          </pc:picChg>
-        </pc:sldLayoutChg>
-        <pc:sldLayoutChg chg="addSp delSp modSp mod">
-          <pc:chgData name="Adrien Osakwe" userId="7a3e290c-eb83-484b-8e3d-d46ef2333477" providerId="ADAL" clId="{09ABE13D-32B9-4646-8B10-CB7999C84D02}" dt="2026-07-14T20:15:29.417" v="19"/>
-          <pc:sldLayoutMkLst>
-            <pc:docMk/>
-            <pc:sldMasterMk cId="1449374226" sldId="2147483660"/>
-            <pc:sldLayoutMk cId="3350706779" sldId="2147483671"/>
-          </pc:sldLayoutMkLst>
-          <pc:picChg chg="add mod">
-            <ac:chgData name="Adrien Osakwe" userId="7a3e290c-eb83-484b-8e3d-d46ef2333477" providerId="ADAL" clId="{09ABE13D-32B9-4646-8B10-CB7999C84D02}" dt="2026-07-14T20:15:10.625" v="11" actId="1076"/>
-            <ac:picMkLst>
-              <pc:docMk/>
-              <pc:sldMasterMk cId="1449374226" sldId="2147483660"/>
-              <pc:sldLayoutMk cId="3350706779" sldId="2147483671"/>
-              <ac:picMk id="2" creationId="{F293AA35-39CA-D5AA-46B4-E32A7A3C2702}"/>
-            </ac:picMkLst>
-          </pc:picChg>
-          <pc:picChg chg="add mod">
-            <ac:chgData name="Adrien Osakwe" userId="7a3e290c-eb83-484b-8e3d-d46ef2333477" providerId="ADAL" clId="{09ABE13D-32B9-4646-8B10-CB7999C84D02}" dt="2026-07-14T20:15:24.202" v="15" actId="1076"/>
-            <ac:picMkLst>
-              <pc:docMk/>
-              <pc:sldMasterMk cId="1449374226" sldId="2147483660"/>
-              <pc:sldLayoutMk cId="3350706779" sldId="2147483671"/>
-              <ac:picMk id="4" creationId="{656DFE86-6EEA-995D-0B99-F99D01139386}"/>
-            </ac:picMkLst>
-          </pc:picChg>
-        </pc:sldLayoutChg>
-      </pc:sldMasterChg>
     </pc:docChg>
   </pc:docChgLst>
   <pc:docChgLst>
     <pc:chgData name="Adrien Osakwe" userId="7a3e290c-eb83-484b-8e3d-d46ef2333477" providerId="ADAL" clId="{516F4981-D9C8-4339-9685-B0B88EA45B28}"/>
     <pc:docChg chg="undo custSel addSld delSld modSld sldOrd">
-      <pc:chgData name="Adrien Osakwe" userId="7a3e290c-eb83-484b-8e3d-d46ef2333477" providerId="ADAL" clId="{516F4981-D9C8-4339-9685-B0B88EA45B28}" dt="2026-08-11T20:19:31.053" v="8251" actId="20577"/>
+      <pc:chgData name="Adrien Osakwe" userId="7a3e290c-eb83-484b-8e3d-d46ef2333477" providerId="ADAL" clId="{516F4981-D9C8-4339-9685-B0B88EA45B28}" dt="2026-08-14T15:07:57.734" v="8505" actId="313"/>
       <pc:docMkLst>
         <pc:docMk/>
       </pc:docMkLst>
-      <pc:sldChg chg="del">
-        <pc:chgData name="Adrien Osakwe" userId="7a3e290c-eb83-484b-8e3d-d46ef2333477" providerId="ADAL" clId="{516F4981-D9C8-4339-9685-B0B88EA45B28}" dt="2026-08-11T03:41:40.272" v="719" actId="47"/>
-        <pc:sldMkLst>
-          <pc:docMk/>
-          <pc:sldMk cId="3133242724" sldId="262"/>
-        </pc:sldMkLst>
-      </pc:sldChg>
       <pc:sldChg chg="addSp delSp modSp mod">
         <pc:chgData name="Adrien Osakwe" userId="7a3e290c-eb83-484b-8e3d-d46ef2333477" providerId="ADAL" clId="{516F4981-D9C8-4339-9685-B0B88EA45B28}" dt="2026-08-11T03:41:06.934" v="695" actId="6549"/>
         <pc:sldMkLst>
@@ -731,23 +510,15 @@
             <ac:spMk id="4" creationId="{5FC2150F-A588-4511-139C-D809D8400571}"/>
           </ac:spMkLst>
         </pc:spChg>
-        <pc:spChg chg="add del mod">
-          <ac:chgData name="Adrien Osakwe" userId="7a3e290c-eb83-484b-8e3d-d46ef2333477" providerId="ADAL" clId="{516F4981-D9C8-4339-9685-B0B88EA45B28}" dt="2026-08-11T03:31:11.615" v="2"/>
-          <ac:spMkLst>
-            <pc:docMk/>
-            <pc:sldMk cId="3587535936" sldId="320"/>
-            <ac:spMk id="5" creationId="{FF0E537B-23E9-775D-FB04-2EF0B8C1B4CF}"/>
-          </ac:spMkLst>
-        </pc:spChg>
       </pc:sldChg>
       <pc:sldChg chg="modSp mod">
-        <pc:chgData name="Adrien Osakwe" userId="7a3e290c-eb83-484b-8e3d-d46ef2333477" providerId="ADAL" clId="{516F4981-D9C8-4339-9685-B0B88EA45B28}" dt="2026-08-11T15:56:18.720" v="3770" actId="27636"/>
+        <pc:chgData name="Adrien Osakwe" userId="7a3e290c-eb83-484b-8e3d-d46ef2333477" providerId="ADAL" clId="{516F4981-D9C8-4339-9685-B0B88EA45B28}" dt="2026-08-14T13:52:45.622" v="8260" actId="27636"/>
         <pc:sldMkLst>
           <pc:docMk/>
           <pc:sldMk cId="3602721871" sldId="321"/>
         </pc:sldMkLst>
         <pc:spChg chg="mod">
-          <ac:chgData name="Adrien Osakwe" userId="7a3e290c-eb83-484b-8e3d-d46ef2333477" providerId="ADAL" clId="{516F4981-D9C8-4339-9685-B0B88EA45B28}" dt="2026-08-11T15:56:18.720" v="3770" actId="27636"/>
+          <ac:chgData name="Adrien Osakwe" userId="7a3e290c-eb83-484b-8e3d-d46ef2333477" providerId="ADAL" clId="{516F4981-D9C8-4339-9685-B0B88EA45B28}" dt="2026-08-14T13:52:45.622" v="8260" actId="27636"/>
           <ac:spMkLst>
             <pc:docMk/>
             <pc:sldMk cId="3602721871" sldId="321"/>
@@ -756,13 +527,13 @@
         </pc:spChg>
       </pc:sldChg>
       <pc:sldChg chg="modSp add mod">
-        <pc:chgData name="Adrien Osakwe" userId="7a3e290c-eb83-484b-8e3d-d46ef2333477" providerId="ADAL" clId="{516F4981-D9C8-4339-9685-B0B88EA45B28}" dt="2026-08-11T15:56:36.461" v="3774" actId="20577"/>
+        <pc:chgData name="Adrien Osakwe" userId="7a3e290c-eb83-484b-8e3d-d46ef2333477" providerId="ADAL" clId="{516F4981-D9C8-4339-9685-B0B88EA45B28}" dt="2026-08-14T14:52:25.006" v="8503" actId="20577"/>
         <pc:sldMkLst>
           <pc:docMk/>
           <pc:sldMk cId="72533941" sldId="322"/>
         </pc:sldMkLst>
         <pc:spChg chg="mod">
-          <ac:chgData name="Adrien Osakwe" userId="7a3e290c-eb83-484b-8e3d-d46ef2333477" providerId="ADAL" clId="{516F4981-D9C8-4339-9685-B0B88EA45B28}" dt="2026-08-11T15:56:36.461" v="3774" actId="20577"/>
+          <ac:chgData name="Adrien Osakwe" userId="7a3e290c-eb83-484b-8e3d-d46ef2333477" providerId="ADAL" clId="{516F4981-D9C8-4339-9685-B0B88EA45B28}" dt="2026-08-14T14:52:25.006" v="8503" actId="20577"/>
           <ac:spMkLst>
             <pc:docMk/>
             <pc:sldMk cId="72533941" sldId="322"/>
@@ -770,28 +541,14 @@
           </ac:spMkLst>
         </pc:spChg>
       </pc:sldChg>
-      <pc:sldChg chg="add del">
-        <pc:chgData name="Adrien Osakwe" userId="7a3e290c-eb83-484b-8e3d-d46ef2333477" providerId="ADAL" clId="{516F4981-D9C8-4339-9685-B0B88EA45B28}" dt="2026-08-11T15:56:30.309" v="3771" actId="2696"/>
-        <pc:sldMkLst>
-          <pc:docMk/>
-          <pc:sldMk cId="3545620837" sldId="322"/>
-        </pc:sldMkLst>
-      </pc:sldChg>
-      <pc:sldChg chg="del">
-        <pc:chgData name="Adrien Osakwe" userId="7a3e290c-eb83-484b-8e3d-d46ef2333477" providerId="ADAL" clId="{516F4981-D9C8-4339-9685-B0B88EA45B28}" dt="2026-08-11T15:44:18.947" v="3521" actId="2696"/>
-        <pc:sldMkLst>
-          <pc:docMk/>
-          <pc:sldMk cId="4028967058" sldId="322"/>
-        </pc:sldMkLst>
-      </pc:sldChg>
       <pc:sldChg chg="modSp mod">
-        <pc:chgData name="Adrien Osakwe" userId="7a3e290c-eb83-484b-8e3d-d46ef2333477" providerId="ADAL" clId="{516F4981-D9C8-4339-9685-B0B88EA45B28}" dt="2026-08-11T15:56:40.688" v="3776" actId="20577"/>
+        <pc:chgData name="Adrien Osakwe" userId="7a3e290c-eb83-484b-8e3d-d46ef2333477" providerId="ADAL" clId="{516F4981-D9C8-4339-9685-B0B88EA45B28}" dt="2026-08-14T14:52:29.856" v="8504" actId="20577"/>
         <pc:sldMkLst>
           <pc:docMk/>
           <pc:sldMk cId="2341505858" sldId="324"/>
         </pc:sldMkLst>
         <pc:spChg chg="mod">
-          <ac:chgData name="Adrien Osakwe" userId="7a3e290c-eb83-484b-8e3d-d46ef2333477" providerId="ADAL" clId="{516F4981-D9C8-4339-9685-B0B88EA45B28}" dt="2026-08-11T15:56:40.688" v="3776" actId="20577"/>
+          <ac:chgData name="Adrien Osakwe" userId="7a3e290c-eb83-484b-8e3d-d46ef2333477" providerId="ADAL" clId="{516F4981-D9C8-4339-9685-B0B88EA45B28}" dt="2026-08-14T14:52:29.856" v="8504" actId="20577"/>
           <ac:spMkLst>
             <pc:docMk/>
             <pc:sldMk cId="2341505858" sldId="324"/>
@@ -799,37 +556,14 @@
           </ac:spMkLst>
         </pc:spChg>
       </pc:sldChg>
-      <pc:sldChg chg="modSp del mod">
-        <pc:chgData name="Adrien Osakwe" userId="7a3e290c-eb83-484b-8e3d-d46ef2333477" providerId="ADAL" clId="{516F4981-D9C8-4339-9685-B0B88EA45B28}" dt="2026-08-11T20:16:25.082" v="7780" actId="47"/>
-        <pc:sldMkLst>
-          <pc:docMk/>
-          <pc:sldMk cId="940167082" sldId="326"/>
-        </pc:sldMkLst>
-        <pc:spChg chg="mod">
-          <ac:chgData name="Adrien Osakwe" userId="7a3e290c-eb83-484b-8e3d-d46ef2333477" providerId="ADAL" clId="{516F4981-D9C8-4339-9685-B0B88EA45B28}" dt="2026-08-11T03:32:10.734" v="37" actId="20577"/>
-          <ac:spMkLst>
-            <pc:docMk/>
-            <pc:sldMk cId="940167082" sldId="326"/>
-            <ac:spMk id="3" creationId="{74130F42-8D26-FE92-B842-3D5721CA7F7D}"/>
-          </ac:spMkLst>
-        </pc:spChg>
-        <pc:spChg chg="mod">
-          <ac:chgData name="Adrien Osakwe" userId="7a3e290c-eb83-484b-8e3d-d46ef2333477" providerId="ADAL" clId="{516F4981-D9C8-4339-9685-B0B88EA45B28}" dt="2026-08-11T03:32:28.460" v="46" actId="20577"/>
-          <ac:spMkLst>
-            <pc:docMk/>
-            <pc:sldMk cId="940167082" sldId="326"/>
-            <ac:spMk id="4" creationId="{51138A0C-5E7B-B43A-A677-D0F279CA3B78}"/>
-          </ac:spMkLst>
-        </pc:spChg>
-      </pc:sldChg>
       <pc:sldChg chg="addSp modSp mod">
-        <pc:chgData name="Adrien Osakwe" userId="7a3e290c-eb83-484b-8e3d-d46ef2333477" providerId="ADAL" clId="{516F4981-D9C8-4339-9685-B0B88EA45B28}" dt="2026-08-11T03:57:28.642" v="1679" actId="1076"/>
+        <pc:chgData name="Adrien Osakwe" userId="7a3e290c-eb83-484b-8e3d-d46ef2333477" providerId="ADAL" clId="{516F4981-D9C8-4339-9685-B0B88EA45B28}" dt="2026-08-14T14:51:54.445" v="8501" actId="1076"/>
         <pc:sldMkLst>
           <pc:docMk/>
           <pc:sldMk cId="775350422" sldId="327"/>
         </pc:sldMkLst>
         <pc:spChg chg="mod">
-          <ac:chgData name="Adrien Osakwe" userId="7a3e290c-eb83-484b-8e3d-d46ef2333477" providerId="ADAL" clId="{516F4981-D9C8-4339-9685-B0B88EA45B28}" dt="2026-08-11T03:57:24.649" v="1677" actId="27636"/>
+          <ac:chgData name="Adrien Osakwe" userId="7a3e290c-eb83-484b-8e3d-d46ef2333477" providerId="ADAL" clId="{516F4981-D9C8-4339-9685-B0B88EA45B28}" dt="2026-08-14T14:51:50.672" v="8500" actId="20577"/>
           <ac:spMkLst>
             <pc:docMk/>
             <pc:sldMk cId="775350422" sldId="327"/>
@@ -837,7 +571,7 @@
           </ac:spMkLst>
         </pc:spChg>
         <pc:picChg chg="add mod">
-          <ac:chgData name="Adrien Osakwe" userId="7a3e290c-eb83-484b-8e3d-d46ef2333477" providerId="ADAL" clId="{516F4981-D9C8-4339-9685-B0B88EA45B28}" dt="2026-08-11T03:57:28.642" v="1679" actId="1076"/>
+          <ac:chgData name="Adrien Osakwe" userId="7a3e290c-eb83-484b-8e3d-d46ef2333477" providerId="ADAL" clId="{516F4981-D9C8-4339-9685-B0B88EA45B28}" dt="2026-08-14T14:51:54.445" v="8501" actId="1076"/>
           <ac:picMkLst>
             <pc:docMk/>
             <pc:sldMk cId="775350422" sldId="327"/>
@@ -859,14 +593,6 @@
             <ac:spMk id="3" creationId="{33D959FC-3BD5-F79B-6D54-99514B14242D}"/>
           </ac:spMkLst>
         </pc:spChg>
-        <pc:picChg chg="add del mod">
-          <ac:chgData name="Adrien Osakwe" userId="7a3e290c-eb83-484b-8e3d-d46ef2333477" providerId="ADAL" clId="{516F4981-D9C8-4339-9685-B0B88EA45B28}" dt="2026-08-11T15:46:13.504" v="3526" actId="478"/>
-          <ac:picMkLst>
-            <pc:docMk/>
-            <pc:sldMk cId="4003429187" sldId="328"/>
-            <ac:picMk id="5" creationId="{5CBD1747-2E4F-2EE3-CB18-9C562FDAC872}"/>
-          </ac:picMkLst>
-        </pc:picChg>
         <pc:picChg chg="add mod modCrop">
           <ac:chgData name="Adrien Osakwe" userId="7a3e290c-eb83-484b-8e3d-d46ef2333477" providerId="ADAL" clId="{516F4981-D9C8-4339-9685-B0B88EA45B28}" dt="2026-08-11T15:47:15.727" v="3548" actId="14100"/>
           <ac:picMkLst>
@@ -953,39 +679,11 @@
           </ac:picMkLst>
         </pc:picChg>
       </pc:sldChg>
-      <pc:sldChg chg="del">
-        <pc:chgData name="Adrien Osakwe" userId="7a3e290c-eb83-484b-8e3d-d46ef2333477" providerId="ADAL" clId="{516F4981-D9C8-4339-9685-B0B88EA45B28}" dt="2026-08-11T15:44:18.947" v="3521" actId="2696"/>
-        <pc:sldMkLst>
-          <pc:docMk/>
-          <pc:sldMk cId="620605204" sldId="333"/>
-        </pc:sldMkLst>
-      </pc:sldChg>
-      <pc:sldChg chg="add del">
-        <pc:chgData name="Adrien Osakwe" userId="7a3e290c-eb83-484b-8e3d-d46ef2333477" providerId="ADAL" clId="{516F4981-D9C8-4339-9685-B0B88EA45B28}" dt="2026-08-11T15:56:30.309" v="3771" actId="2696"/>
-        <pc:sldMkLst>
-          <pc:docMk/>
-          <pc:sldMk cId="2559881902" sldId="333"/>
-        </pc:sldMkLst>
-      </pc:sldChg>
       <pc:sldChg chg="add">
         <pc:chgData name="Adrien Osakwe" userId="7a3e290c-eb83-484b-8e3d-d46ef2333477" providerId="ADAL" clId="{516F4981-D9C8-4339-9685-B0B88EA45B28}" dt="2026-08-11T15:56:33.735" v="3772"/>
         <pc:sldMkLst>
           <pc:docMk/>
           <pc:sldMk cId="3906011366" sldId="333"/>
-        </pc:sldMkLst>
-      </pc:sldChg>
-      <pc:sldChg chg="del">
-        <pc:chgData name="Adrien Osakwe" userId="7a3e290c-eb83-484b-8e3d-d46ef2333477" providerId="ADAL" clId="{516F4981-D9C8-4339-9685-B0B88EA45B28}" dt="2026-08-11T15:44:18.947" v="3521" actId="2696"/>
-        <pc:sldMkLst>
-          <pc:docMk/>
-          <pc:sldMk cId="533136476" sldId="355"/>
-        </pc:sldMkLst>
-      </pc:sldChg>
-      <pc:sldChg chg="add del">
-        <pc:chgData name="Adrien Osakwe" userId="7a3e290c-eb83-484b-8e3d-d46ef2333477" providerId="ADAL" clId="{516F4981-D9C8-4339-9685-B0B88EA45B28}" dt="2026-08-11T15:56:30.309" v="3771" actId="2696"/>
-        <pc:sldMkLst>
-          <pc:docMk/>
-          <pc:sldMk cId="1048594591" sldId="355"/>
         </pc:sldMkLst>
       </pc:sldChg>
       <pc:sldChg chg="add">
@@ -995,39 +693,11 @@
           <pc:sldMk cId="3898672664" sldId="355"/>
         </pc:sldMkLst>
       </pc:sldChg>
-      <pc:sldChg chg="del">
-        <pc:chgData name="Adrien Osakwe" userId="7a3e290c-eb83-484b-8e3d-d46ef2333477" providerId="ADAL" clId="{516F4981-D9C8-4339-9685-B0B88EA45B28}" dt="2026-08-11T15:44:18.947" v="3521" actId="2696"/>
-        <pc:sldMkLst>
-          <pc:docMk/>
-          <pc:sldMk cId="83320364" sldId="356"/>
-        </pc:sldMkLst>
-      </pc:sldChg>
       <pc:sldChg chg="add">
         <pc:chgData name="Adrien Osakwe" userId="7a3e290c-eb83-484b-8e3d-d46ef2333477" providerId="ADAL" clId="{516F4981-D9C8-4339-9685-B0B88EA45B28}" dt="2026-08-11T15:56:33.735" v="3772"/>
         <pc:sldMkLst>
           <pc:docMk/>
           <pc:sldMk cId="824051499" sldId="356"/>
-        </pc:sldMkLst>
-      </pc:sldChg>
-      <pc:sldChg chg="add del">
-        <pc:chgData name="Adrien Osakwe" userId="7a3e290c-eb83-484b-8e3d-d46ef2333477" providerId="ADAL" clId="{516F4981-D9C8-4339-9685-B0B88EA45B28}" dt="2026-08-11T15:56:30.309" v="3771" actId="2696"/>
-        <pc:sldMkLst>
-          <pc:docMk/>
-          <pc:sldMk cId="2551635768" sldId="356"/>
-        </pc:sldMkLst>
-      </pc:sldChg>
-      <pc:sldChg chg="del">
-        <pc:chgData name="Adrien Osakwe" userId="7a3e290c-eb83-484b-8e3d-d46ef2333477" providerId="ADAL" clId="{516F4981-D9C8-4339-9685-B0B88EA45B28}" dt="2026-08-11T15:44:18.947" v="3521" actId="2696"/>
-        <pc:sldMkLst>
-          <pc:docMk/>
-          <pc:sldMk cId="541003190" sldId="402"/>
-        </pc:sldMkLst>
-      </pc:sldChg>
-      <pc:sldChg chg="add del">
-        <pc:chgData name="Adrien Osakwe" userId="7a3e290c-eb83-484b-8e3d-d46ef2333477" providerId="ADAL" clId="{516F4981-D9C8-4339-9685-B0B88EA45B28}" dt="2026-08-11T15:56:30.309" v="3771" actId="2696"/>
-        <pc:sldMkLst>
-          <pc:docMk/>
-          <pc:sldMk cId="1029211281" sldId="402"/>
         </pc:sldMkLst>
       </pc:sldChg>
       <pc:sldChg chg="add">
@@ -1037,20 +707,6 @@
           <pc:sldMk cId="4141671523" sldId="402"/>
         </pc:sldMkLst>
       </pc:sldChg>
-      <pc:sldChg chg="del">
-        <pc:chgData name="Adrien Osakwe" userId="7a3e290c-eb83-484b-8e3d-d46ef2333477" providerId="ADAL" clId="{516F4981-D9C8-4339-9685-B0B88EA45B28}" dt="2026-08-11T15:44:18.947" v="3521" actId="2696"/>
-        <pc:sldMkLst>
-          <pc:docMk/>
-          <pc:sldMk cId="1247047046" sldId="403"/>
-        </pc:sldMkLst>
-      </pc:sldChg>
-      <pc:sldChg chg="add del">
-        <pc:chgData name="Adrien Osakwe" userId="7a3e290c-eb83-484b-8e3d-d46ef2333477" providerId="ADAL" clId="{516F4981-D9C8-4339-9685-B0B88EA45B28}" dt="2026-08-11T15:56:30.309" v="3771" actId="2696"/>
-        <pc:sldMkLst>
-          <pc:docMk/>
-          <pc:sldMk cId="2647634623" sldId="403"/>
-        </pc:sldMkLst>
-      </pc:sldChg>
       <pc:sldChg chg="add">
         <pc:chgData name="Adrien Osakwe" userId="7a3e290c-eb83-484b-8e3d-d46ef2333477" providerId="ADAL" clId="{516F4981-D9C8-4339-9685-B0B88EA45B28}" dt="2026-08-11T15:56:33.735" v="3772"/>
         <pc:sldMkLst>
@@ -1058,39 +714,11 @@
           <pc:sldMk cId="3428118430" sldId="403"/>
         </pc:sldMkLst>
       </pc:sldChg>
-      <pc:sldChg chg="add del">
-        <pc:chgData name="Adrien Osakwe" userId="7a3e290c-eb83-484b-8e3d-d46ef2333477" providerId="ADAL" clId="{516F4981-D9C8-4339-9685-B0B88EA45B28}" dt="2026-08-11T15:56:30.309" v="3771" actId="2696"/>
-        <pc:sldMkLst>
-          <pc:docMk/>
-          <pc:sldMk cId="67142368" sldId="404"/>
-        </pc:sldMkLst>
-      </pc:sldChg>
       <pc:sldChg chg="add">
         <pc:chgData name="Adrien Osakwe" userId="7a3e290c-eb83-484b-8e3d-d46ef2333477" providerId="ADAL" clId="{516F4981-D9C8-4339-9685-B0B88EA45B28}" dt="2026-08-11T15:56:33.735" v="3772"/>
         <pc:sldMkLst>
           <pc:docMk/>
           <pc:sldMk cId="2159578298" sldId="404"/>
-        </pc:sldMkLst>
-      </pc:sldChg>
-      <pc:sldChg chg="del">
-        <pc:chgData name="Adrien Osakwe" userId="7a3e290c-eb83-484b-8e3d-d46ef2333477" providerId="ADAL" clId="{516F4981-D9C8-4339-9685-B0B88EA45B28}" dt="2026-08-11T15:44:18.947" v="3521" actId="2696"/>
-        <pc:sldMkLst>
-          <pc:docMk/>
-          <pc:sldMk cId="3081280313" sldId="404"/>
-        </pc:sldMkLst>
-      </pc:sldChg>
-      <pc:sldChg chg="add del">
-        <pc:chgData name="Adrien Osakwe" userId="7a3e290c-eb83-484b-8e3d-d46ef2333477" providerId="ADAL" clId="{516F4981-D9C8-4339-9685-B0B88EA45B28}" dt="2026-08-11T15:56:30.309" v="3771" actId="2696"/>
-        <pc:sldMkLst>
-          <pc:docMk/>
-          <pc:sldMk cId="2374838861" sldId="405"/>
-        </pc:sldMkLst>
-      </pc:sldChg>
-      <pc:sldChg chg="del">
-        <pc:chgData name="Adrien Osakwe" userId="7a3e290c-eb83-484b-8e3d-d46ef2333477" providerId="ADAL" clId="{516F4981-D9C8-4339-9685-B0B88EA45B28}" dt="2026-08-11T15:44:18.947" v="3521" actId="2696"/>
-        <pc:sldMkLst>
-          <pc:docMk/>
-          <pc:sldMk cId="2860464347" sldId="405"/>
         </pc:sldMkLst>
       </pc:sldChg>
       <pc:sldChg chg="add">
@@ -1101,13 +729,13 @@
         </pc:sldMkLst>
       </pc:sldChg>
       <pc:sldChg chg="addSp modSp mod">
-        <pc:chgData name="Adrien Osakwe" userId="7a3e290c-eb83-484b-8e3d-d46ef2333477" providerId="ADAL" clId="{516F4981-D9C8-4339-9685-B0B88EA45B28}" dt="2026-08-11T04:06:02.891" v="1885" actId="1076"/>
+        <pc:chgData name="Adrien Osakwe" userId="7a3e290c-eb83-484b-8e3d-d46ef2333477" providerId="ADAL" clId="{516F4981-D9C8-4339-9685-B0B88EA45B28}" dt="2026-08-14T14:30:23.839" v="8452" actId="1076"/>
         <pc:sldMkLst>
           <pc:docMk/>
           <pc:sldMk cId="4107645974" sldId="406"/>
         </pc:sldMkLst>
         <pc:spChg chg="mod">
-          <ac:chgData name="Adrien Osakwe" userId="7a3e290c-eb83-484b-8e3d-d46ef2333477" providerId="ADAL" clId="{516F4981-D9C8-4339-9685-B0B88EA45B28}" dt="2026-08-11T04:05:53.130" v="1883" actId="6549"/>
+          <ac:chgData name="Adrien Osakwe" userId="7a3e290c-eb83-484b-8e3d-d46ef2333477" providerId="ADAL" clId="{516F4981-D9C8-4339-9685-B0B88EA45B28}" dt="2026-08-14T14:30:19.854" v="8451" actId="14100"/>
           <ac:spMkLst>
             <pc:docMk/>
             <pc:sldMk cId="4107645974" sldId="406"/>
@@ -1115,7 +743,7 @@
           </ac:spMkLst>
         </pc:spChg>
         <pc:picChg chg="add mod modCrop">
-          <ac:chgData name="Adrien Osakwe" userId="7a3e290c-eb83-484b-8e3d-d46ef2333477" providerId="ADAL" clId="{516F4981-D9C8-4339-9685-B0B88EA45B28}" dt="2026-08-11T04:05:56.935" v="1884" actId="1076"/>
+          <ac:chgData name="Adrien Osakwe" userId="7a3e290c-eb83-484b-8e3d-d46ef2333477" providerId="ADAL" clId="{516F4981-D9C8-4339-9685-B0B88EA45B28}" dt="2026-08-14T14:30:23.839" v="8452" actId="1076"/>
           <ac:picMkLst>
             <pc:docMk/>
             <pc:sldMk cId="4107645974" sldId="406"/>
@@ -1162,51 +790,12 @@
           </ac:picMkLst>
         </pc:picChg>
       </pc:sldChg>
-      <pc:sldChg chg="modSp del mod">
-        <pc:chgData name="Adrien Osakwe" userId="7a3e290c-eb83-484b-8e3d-d46ef2333477" providerId="ADAL" clId="{516F4981-D9C8-4339-9685-B0B88EA45B28}" dt="2026-08-11T04:08:49.584" v="2088" actId="47"/>
-        <pc:sldMkLst>
-          <pc:docMk/>
-          <pc:sldMk cId="3153814840" sldId="408"/>
-        </pc:sldMkLst>
-        <pc:spChg chg="mod">
-          <ac:chgData name="Adrien Osakwe" userId="7a3e290c-eb83-484b-8e3d-d46ef2333477" providerId="ADAL" clId="{516F4981-D9C8-4339-9685-B0B88EA45B28}" dt="2026-08-11T04:08:37.998" v="2080" actId="21"/>
-          <ac:spMkLst>
-            <pc:docMk/>
-            <pc:sldMk cId="3153814840" sldId="408"/>
-            <ac:spMk id="2" creationId="{168557DF-C670-BB63-1A98-E92279E25631}"/>
-          </ac:spMkLst>
-        </pc:spChg>
-        <pc:spChg chg="mod">
-          <ac:chgData name="Adrien Osakwe" userId="7a3e290c-eb83-484b-8e3d-d46ef2333477" providerId="ADAL" clId="{516F4981-D9C8-4339-9685-B0B88EA45B28}" dt="2026-08-11T04:08:43.837" v="2082" actId="21"/>
-          <ac:spMkLst>
-            <pc:docMk/>
-            <pc:sldMk cId="3153814840" sldId="408"/>
-            <ac:spMk id="3" creationId="{AB27973F-38C9-227B-CB7C-B3594BC15340}"/>
-          </ac:spMkLst>
-        </pc:spChg>
-      </pc:sldChg>
       <pc:sldChg chg="addSp delSp modSp mod">
-        <pc:chgData name="Adrien Osakwe" userId="7a3e290c-eb83-484b-8e3d-d46ef2333477" providerId="ADAL" clId="{516F4981-D9C8-4339-9685-B0B88EA45B28}" dt="2026-08-11T16:48:20.397" v="5281" actId="1076"/>
+        <pc:chgData name="Adrien Osakwe" userId="7a3e290c-eb83-484b-8e3d-d46ef2333477" providerId="ADAL" clId="{516F4981-D9C8-4339-9685-B0B88EA45B28}" dt="2026-08-14T14:47:24.320" v="8458" actId="1076"/>
         <pc:sldMkLst>
           <pc:docMk/>
           <pc:sldMk cId="604635962" sldId="409"/>
         </pc:sldMkLst>
-        <pc:spChg chg="del">
-          <ac:chgData name="Adrien Osakwe" userId="7a3e290c-eb83-484b-8e3d-d46ef2333477" providerId="ADAL" clId="{516F4981-D9C8-4339-9685-B0B88EA45B28}" dt="2026-08-11T03:50:44.209" v="1165" actId="478"/>
-          <ac:spMkLst>
-            <pc:docMk/>
-            <pc:sldMk cId="604635962" sldId="409"/>
-            <ac:spMk id="3" creationId="{0A2F44FD-8BC2-5366-A460-E2D717E68A8F}"/>
-          </ac:spMkLst>
-        </pc:spChg>
-        <pc:spChg chg="del">
-          <ac:chgData name="Adrien Osakwe" userId="7a3e290c-eb83-484b-8e3d-d46ef2333477" providerId="ADAL" clId="{516F4981-D9C8-4339-9685-B0B88EA45B28}" dt="2026-08-11T03:50:45.114" v="1166" actId="478"/>
-          <ac:spMkLst>
-            <pc:docMk/>
-            <pc:sldMk cId="604635962" sldId="409"/>
-            <ac:spMk id="4" creationId="{97C619F2-BF84-BD40-C738-EEC5CA56153D}"/>
-          </ac:spMkLst>
-        </pc:spChg>
         <pc:spChg chg="add mod">
           <ac:chgData name="Adrien Osakwe" userId="7a3e290c-eb83-484b-8e3d-d46ef2333477" providerId="ADAL" clId="{516F4981-D9C8-4339-9685-B0B88EA45B28}" dt="2026-08-11T16:48:17.076" v="5279" actId="1076"/>
           <ac:spMkLst>
@@ -1224,7 +813,7 @@
           </ac:picMkLst>
         </pc:picChg>
         <pc:picChg chg="add mod">
-          <ac:chgData name="Adrien Osakwe" userId="7a3e290c-eb83-484b-8e3d-d46ef2333477" providerId="ADAL" clId="{516F4981-D9C8-4339-9685-B0B88EA45B28}" dt="2026-08-11T16:48:10.458" v="5276" actId="14100"/>
+          <ac:chgData name="Adrien Osakwe" userId="7a3e290c-eb83-484b-8e3d-d46ef2333477" providerId="ADAL" clId="{516F4981-D9C8-4339-9685-B0B88EA45B28}" dt="2026-08-14T14:47:24.320" v="8458" actId="1076"/>
           <ac:picMkLst>
             <pc:docMk/>
             <pc:sldMk cId="604635962" sldId="409"/>
@@ -1252,14 +841,6 @@
             <pc:docMk/>
             <pc:sldMk cId="981103045" sldId="410"/>
             <ac:spMk id="3" creationId="{311A497D-7B3A-420F-9347-CF4D7D0528AA}"/>
-          </ac:spMkLst>
-        </pc:spChg>
-        <pc:spChg chg="del mod">
-          <ac:chgData name="Adrien Osakwe" userId="7a3e290c-eb83-484b-8e3d-d46ef2333477" providerId="ADAL" clId="{516F4981-D9C8-4339-9685-B0B88EA45B28}" dt="2026-08-11T03:55:45.111" v="1596" actId="478"/>
-          <ac:spMkLst>
-            <pc:docMk/>
-            <pc:sldMk cId="981103045" sldId="410"/>
-            <ac:spMk id="4" creationId="{1D0FF61C-E3B4-EFBC-AB33-F434CCAFF490}"/>
           </ac:spMkLst>
         </pc:spChg>
         <pc:spChg chg="add mod">
@@ -1309,44 +890,6 @@
             <ac:spMk id="3" creationId="{46798B0B-5D5D-D6AE-7CE9-0D0F9134C1AA}"/>
           </ac:spMkLst>
         </pc:spChg>
-        <pc:spChg chg="del">
-          <ac:chgData name="Adrien Osakwe" userId="7a3e290c-eb83-484b-8e3d-d46ef2333477" providerId="ADAL" clId="{516F4981-D9C8-4339-9685-B0B88EA45B28}" dt="2026-08-11T03:46:44.250" v="733" actId="478"/>
-          <ac:spMkLst>
-            <pc:docMk/>
-            <pc:sldMk cId="37029868" sldId="413"/>
-            <ac:spMk id="4" creationId="{2210F72E-F74F-F77F-BFBA-11A42F6D9677}"/>
-          </ac:spMkLst>
-        </pc:spChg>
-        <pc:picChg chg="add del mod">
-          <ac:chgData name="Adrien Osakwe" userId="7a3e290c-eb83-484b-8e3d-d46ef2333477" providerId="ADAL" clId="{516F4981-D9C8-4339-9685-B0B88EA45B28}" dt="2026-08-11T16:48:04.797" v="5273" actId="21"/>
-          <ac:picMkLst>
-            <pc:docMk/>
-            <pc:sldMk cId="37029868" sldId="413"/>
-            <ac:picMk id="5" creationId="{D6410C9F-D36D-F231-CA6D-DA25435615C2}"/>
-          </ac:picMkLst>
-        </pc:picChg>
-      </pc:sldChg>
-      <pc:sldChg chg="modSp del mod">
-        <pc:chgData name="Adrien Osakwe" userId="7a3e290c-eb83-484b-8e3d-d46ef2333477" providerId="ADAL" clId="{516F4981-D9C8-4339-9685-B0B88EA45B28}" dt="2026-08-11T03:45:02.394" v="732" actId="47"/>
-        <pc:sldMkLst>
-          <pc:docMk/>
-          <pc:sldMk cId="2087459769" sldId="414"/>
-        </pc:sldMkLst>
-        <pc:spChg chg="mod">
-          <ac:chgData name="Adrien Osakwe" userId="7a3e290c-eb83-484b-8e3d-d46ef2333477" providerId="ADAL" clId="{516F4981-D9C8-4339-9685-B0B88EA45B28}" dt="2026-08-11T03:44:59.455" v="731" actId="1076"/>
-          <ac:spMkLst>
-            <pc:docMk/>
-            <pc:sldMk cId="2087459769" sldId="414"/>
-            <ac:spMk id="3" creationId="{26143BDB-1110-0E87-4DCE-2BD98F7F5DBE}"/>
-          </ac:spMkLst>
-        </pc:spChg>
-      </pc:sldChg>
-      <pc:sldChg chg="new del ord">
-        <pc:chgData name="Adrien Osakwe" userId="7a3e290c-eb83-484b-8e3d-d46ef2333477" providerId="ADAL" clId="{516F4981-D9C8-4339-9685-B0B88EA45B28}" dt="2026-08-11T03:35:58.556" v="371" actId="47"/>
-        <pc:sldMkLst>
-          <pc:docMk/>
-          <pc:sldMk cId="1688643550" sldId="415"/>
-        </pc:sldMkLst>
       </pc:sldChg>
       <pc:sldChg chg="modSp new mod">
         <pc:chgData name="Adrien Osakwe" userId="7a3e290c-eb83-484b-8e3d-d46ef2333477" providerId="ADAL" clId="{516F4981-D9C8-4339-9685-B0B88EA45B28}" dt="2026-08-11T03:55:31.645" v="1577" actId="20577"/>
@@ -1368,110 +911,6 @@
             <pc:docMk/>
             <pc:sldMk cId="2950609981" sldId="415"/>
             <ac:spMk id="3" creationId="{7827244C-619B-07FE-BD5D-98C98E898AE4}"/>
-          </ac:spMkLst>
-        </pc:spChg>
-      </pc:sldChg>
-      <pc:sldChg chg="new del">
-        <pc:chgData name="Adrien Osakwe" userId="7a3e290c-eb83-484b-8e3d-d46ef2333477" providerId="ADAL" clId="{516F4981-D9C8-4339-9685-B0B88EA45B28}" dt="2026-08-11T03:38:37.853" v="608" actId="47"/>
-        <pc:sldMkLst>
-          <pc:docMk/>
-          <pc:sldMk cId="1388726675" sldId="416"/>
-        </pc:sldMkLst>
-      </pc:sldChg>
-      <pc:sldChg chg="modSp new del mod">
-        <pc:chgData name="Adrien Osakwe" userId="7a3e290c-eb83-484b-8e3d-d46ef2333477" providerId="ADAL" clId="{516F4981-D9C8-4339-9685-B0B88EA45B28}" dt="2026-08-11T19:55:16.910" v="5886" actId="47"/>
-        <pc:sldMkLst>
-          <pc:docMk/>
-          <pc:sldMk cId="4034011448" sldId="416"/>
-        </pc:sldMkLst>
-        <pc:spChg chg="mod">
-          <ac:chgData name="Adrien Osakwe" userId="7a3e290c-eb83-484b-8e3d-d46ef2333477" providerId="ADAL" clId="{516F4981-D9C8-4339-9685-B0B88EA45B28}" dt="2026-08-11T16:01:55.609" v="4393" actId="1076"/>
-          <ac:spMkLst>
-            <pc:docMk/>
-            <pc:sldMk cId="4034011448" sldId="416"/>
-            <ac:spMk id="2" creationId="{A49566BD-568F-BE0D-05BE-B8FED9C6F115}"/>
-          </ac:spMkLst>
-        </pc:spChg>
-      </pc:sldChg>
-      <pc:sldChg chg="modSp add del mod">
-        <pc:chgData name="Adrien Osakwe" userId="7a3e290c-eb83-484b-8e3d-d46ef2333477" providerId="ADAL" clId="{516F4981-D9C8-4339-9685-B0B88EA45B28}" dt="2026-08-11T19:57:59.823" v="6337" actId="47"/>
-        <pc:sldMkLst>
-          <pc:docMk/>
-          <pc:sldMk cId="3381146445" sldId="417"/>
-        </pc:sldMkLst>
-        <pc:spChg chg="mod">
-          <ac:chgData name="Adrien Osakwe" userId="7a3e290c-eb83-484b-8e3d-d46ef2333477" providerId="ADAL" clId="{516F4981-D9C8-4339-9685-B0B88EA45B28}" dt="2026-08-11T16:01:40.697" v="4353" actId="1076"/>
-          <ac:spMkLst>
-            <pc:docMk/>
-            <pc:sldMk cId="3381146445" sldId="417"/>
-            <ac:spMk id="2" creationId="{B627E931-4B2C-12CE-3BC3-6A5246120671}"/>
-          </ac:spMkLst>
-        </pc:spChg>
-      </pc:sldChg>
-      <pc:sldChg chg="modSp add del mod">
-        <pc:chgData name="Adrien Osakwe" userId="7a3e290c-eb83-484b-8e3d-d46ef2333477" providerId="ADAL" clId="{516F4981-D9C8-4339-9685-B0B88EA45B28}" dt="2026-08-11T19:59:34.278" v="6529" actId="47"/>
-        <pc:sldMkLst>
-          <pc:docMk/>
-          <pc:sldMk cId="2443216682" sldId="418"/>
-        </pc:sldMkLst>
-        <pc:spChg chg="mod">
-          <ac:chgData name="Adrien Osakwe" userId="7a3e290c-eb83-484b-8e3d-d46ef2333477" providerId="ADAL" clId="{516F4981-D9C8-4339-9685-B0B88EA45B28}" dt="2026-08-11T16:03:17.576" v="4536" actId="1076"/>
-          <ac:spMkLst>
-            <pc:docMk/>
-            <pc:sldMk cId="2443216682" sldId="418"/>
-            <ac:spMk id="2" creationId="{34D3CBAE-FCA6-56FF-4630-BA76ACB49392}"/>
-          </ac:spMkLst>
-        </pc:spChg>
-      </pc:sldChg>
-      <pc:sldChg chg="add del">
-        <pc:chgData name="Adrien Osakwe" userId="7a3e290c-eb83-484b-8e3d-d46ef2333477" providerId="ADAL" clId="{516F4981-D9C8-4339-9685-B0B88EA45B28}" dt="2026-08-11T16:03:27.556" v="4538" actId="47"/>
-        <pc:sldMkLst>
-          <pc:docMk/>
-          <pc:sldMk cId="2255428838" sldId="419"/>
-        </pc:sldMkLst>
-      </pc:sldChg>
-      <pc:sldChg chg="modSp add del mod">
-        <pc:chgData name="Adrien Osakwe" userId="7a3e290c-eb83-484b-8e3d-d46ef2333477" providerId="ADAL" clId="{516F4981-D9C8-4339-9685-B0B88EA45B28}" dt="2026-08-11T20:03:33.221" v="7052" actId="47"/>
-        <pc:sldMkLst>
-          <pc:docMk/>
-          <pc:sldMk cId="1724832574" sldId="420"/>
-        </pc:sldMkLst>
-        <pc:spChg chg="mod">
-          <ac:chgData name="Adrien Osakwe" userId="7a3e290c-eb83-484b-8e3d-d46ef2333477" providerId="ADAL" clId="{516F4981-D9C8-4339-9685-B0B88EA45B28}" dt="2026-08-11T16:05:08.973" v="4706" actId="14100"/>
-          <ac:spMkLst>
-            <pc:docMk/>
-            <pc:sldMk cId="1724832574" sldId="420"/>
-            <ac:spMk id="2" creationId="{1DC661F8-D6E6-38C4-D1F5-3004261B6511}"/>
-          </ac:spMkLst>
-        </pc:spChg>
-      </pc:sldChg>
-      <pc:sldChg chg="modSp add del mod">
-        <pc:chgData name="Adrien Osakwe" userId="7a3e290c-eb83-484b-8e3d-d46ef2333477" providerId="ADAL" clId="{516F4981-D9C8-4339-9685-B0B88EA45B28}" dt="2026-08-11T19:53:20.675" v="5543" actId="47"/>
-        <pc:sldMkLst>
-          <pc:docMk/>
-          <pc:sldMk cId="1414395029" sldId="421"/>
-        </pc:sldMkLst>
-        <pc:spChg chg="mod">
-          <ac:chgData name="Adrien Osakwe" userId="7a3e290c-eb83-484b-8e3d-d46ef2333477" providerId="ADAL" clId="{516F4981-D9C8-4339-9685-B0B88EA45B28}" dt="2026-08-11T16:05:32.827" v="4729" actId="1076"/>
-          <ac:spMkLst>
-            <pc:docMk/>
-            <pc:sldMk cId="1414395029" sldId="421"/>
-            <ac:spMk id="2" creationId="{D78E5005-F04A-59B4-AAE1-2B9524068593}"/>
-          </ac:spMkLst>
-        </pc:spChg>
-      </pc:sldChg>
-      <pc:sldChg chg="modSp add del mod">
-        <pc:chgData name="Adrien Osakwe" userId="7a3e290c-eb83-484b-8e3d-d46ef2333477" providerId="ADAL" clId="{516F4981-D9C8-4339-9685-B0B88EA45B28}" dt="2026-08-11T19:54:13.596" v="5808" actId="47"/>
-        <pc:sldMkLst>
-          <pc:docMk/>
-          <pc:sldMk cId="509037345" sldId="422"/>
-        </pc:sldMkLst>
-        <pc:spChg chg="mod">
-          <ac:chgData name="Adrien Osakwe" userId="7a3e290c-eb83-484b-8e3d-d46ef2333477" providerId="ADAL" clId="{516F4981-D9C8-4339-9685-B0B88EA45B28}" dt="2026-08-11T16:05:52.358" v="4774" actId="1076"/>
-          <ac:spMkLst>
-            <pc:docMk/>
-            <pc:sldMk cId="509037345" sldId="422"/>
-            <ac:spMk id="2" creationId="{3B0854C0-59B7-A945-9FA0-E6D642120E02}"/>
           </ac:spMkLst>
         </pc:spChg>
       </pc:sldChg>
@@ -1521,43 +960,6 @@
           </ac:picMkLst>
         </pc:picChg>
       </pc:sldChg>
-      <pc:sldChg chg="modSp new del mod">
-        <pc:chgData name="Adrien Osakwe" userId="7a3e290c-eb83-484b-8e3d-d46ef2333477" providerId="ADAL" clId="{516F4981-D9C8-4339-9685-B0B88EA45B28}" dt="2026-08-11T19:58:12.354" v="6340" actId="47"/>
-        <pc:sldMkLst>
-          <pc:docMk/>
-          <pc:sldMk cId="2814879043" sldId="425"/>
-        </pc:sldMkLst>
-        <pc:spChg chg="mod">
-          <ac:chgData name="Adrien Osakwe" userId="7a3e290c-eb83-484b-8e3d-d46ef2333477" providerId="ADAL" clId="{516F4981-D9C8-4339-9685-B0B88EA45B28}" dt="2026-08-11T16:00:34.285" v="4199" actId="207"/>
-          <ac:spMkLst>
-            <pc:docMk/>
-            <pc:sldMk cId="2814879043" sldId="425"/>
-            <ac:spMk id="2" creationId="{E6E06B3D-D697-AE59-116F-D558C5EC8756}"/>
-          </ac:spMkLst>
-        </pc:spChg>
-        <pc:spChg chg="mod">
-          <ac:chgData name="Adrien Osakwe" userId="7a3e290c-eb83-484b-8e3d-d46ef2333477" providerId="ADAL" clId="{516F4981-D9C8-4339-9685-B0B88EA45B28}" dt="2026-08-11T19:58:10.823" v="6339" actId="27636"/>
-          <ac:spMkLst>
-            <pc:docMk/>
-            <pc:sldMk cId="2814879043" sldId="425"/>
-            <ac:spMk id="3" creationId="{71618A3D-D3F3-3F32-8304-7A72C05319EB}"/>
-          </ac:spMkLst>
-        </pc:spChg>
-      </pc:sldChg>
-      <pc:sldChg chg="new del">
-        <pc:chgData name="Adrien Osakwe" userId="7a3e290c-eb83-484b-8e3d-d46ef2333477" providerId="ADAL" clId="{516F4981-D9C8-4339-9685-B0B88EA45B28}" dt="2026-08-11T04:07:56.684" v="2077" actId="47"/>
-        <pc:sldMkLst>
-          <pc:docMk/>
-          <pc:sldMk cId="3509885090" sldId="425"/>
-        </pc:sldMkLst>
-      </pc:sldChg>
-      <pc:sldChg chg="new del">
-        <pc:chgData name="Adrien Osakwe" userId="7a3e290c-eb83-484b-8e3d-d46ef2333477" providerId="ADAL" clId="{516F4981-D9C8-4339-9685-B0B88EA45B28}" dt="2026-08-11T04:08:21.417" v="2078" actId="47"/>
-        <pc:sldMkLst>
-          <pc:docMk/>
-          <pc:sldMk cId="921941797" sldId="426"/>
-        </pc:sldMkLst>
-      </pc:sldChg>
       <pc:sldChg chg="addSp modSp new mod ord">
         <pc:chgData name="Adrien Osakwe" userId="7a3e290c-eb83-484b-8e3d-d46ef2333477" providerId="ADAL" clId="{516F4981-D9C8-4339-9685-B0B88EA45B28}" dt="2026-08-11T04:17:04.221" v="2804" actId="20577"/>
         <pc:sldMkLst>
@@ -1597,22 +999,8 @@
           </ac:picMkLst>
         </pc:picChg>
       </pc:sldChg>
-      <pc:sldChg chg="new del">
-        <pc:chgData name="Adrien Osakwe" userId="7a3e290c-eb83-484b-8e3d-d46ef2333477" providerId="ADAL" clId="{516F4981-D9C8-4339-9685-B0B88EA45B28}" dt="2026-08-11T04:14:08.511" v="2724" actId="47"/>
-        <pc:sldMkLst>
-          <pc:docMk/>
-          <pc:sldMk cId="2916505771" sldId="427"/>
-        </pc:sldMkLst>
-      </pc:sldChg>
-      <pc:sldChg chg="new del">
-        <pc:chgData name="Adrien Osakwe" userId="7a3e290c-eb83-484b-8e3d-d46ef2333477" providerId="ADAL" clId="{516F4981-D9C8-4339-9685-B0B88EA45B28}" dt="2026-08-11T15:15:02.402" v="2807" actId="47"/>
-        <pc:sldMkLst>
-          <pc:docMk/>
-          <pc:sldMk cId="4113372773" sldId="427"/>
-        </pc:sldMkLst>
-      </pc:sldChg>
-      <pc:sldChg chg="addSp modSp new mod">
-        <pc:chgData name="Adrien Osakwe" userId="7a3e290c-eb83-484b-8e3d-d46ef2333477" providerId="ADAL" clId="{516F4981-D9C8-4339-9685-B0B88EA45B28}" dt="2026-08-11T16:48:36.807" v="5284" actId="20577"/>
+      <pc:sldChg chg="addSp modSp new mod ord">
+        <pc:chgData name="Adrien Osakwe" userId="7a3e290c-eb83-484b-8e3d-d46ef2333477" providerId="ADAL" clId="{516F4981-D9C8-4339-9685-B0B88EA45B28}" dt="2026-08-14T14:09:37.224" v="8345"/>
         <pc:sldMkLst>
           <pc:docMk/>
           <pc:sldMk cId="998501193" sldId="428"/>
@@ -1658,14 +1046,22 @@
           </ac:picMkLst>
         </pc:picChg>
       </pc:sldChg>
-      <pc:sldChg chg="modSp add mod">
-        <pc:chgData name="Adrien Osakwe" userId="7a3e290c-eb83-484b-8e3d-d46ef2333477" providerId="ADAL" clId="{516F4981-D9C8-4339-9685-B0B88EA45B28}" dt="2026-08-11T15:21:56.642" v="3357" actId="14"/>
+      <pc:sldChg chg="modSp add mod ord">
+        <pc:chgData name="Adrien Osakwe" userId="7a3e290c-eb83-484b-8e3d-d46ef2333477" providerId="ADAL" clId="{516F4981-D9C8-4339-9685-B0B88EA45B28}" dt="2026-08-14T14:24:24.956" v="8385" actId="20577"/>
         <pc:sldMkLst>
           <pc:docMk/>
           <pc:sldMk cId="452007840" sldId="429"/>
         </pc:sldMkLst>
         <pc:spChg chg="mod">
-          <ac:chgData name="Adrien Osakwe" userId="7a3e290c-eb83-484b-8e3d-d46ef2333477" providerId="ADAL" clId="{516F4981-D9C8-4339-9685-B0B88EA45B28}" dt="2026-08-11T15:21:56.642" v="3357" actId="14"/>
+          <ac:chgData name="Adrien Osakwe" userId="7a3e290c-eb83-484b-8e3d-d46ef2333477" providerId="ADAL" clId="{516F4981-D9C8-4339-9685-B0B88EA45B28}" dt="2026-08-14T14:24:24.956" v="8385" actId="20577"/>
+          <ac:spMkLst>
+            <pc:docMk/>
+            <pc:sldMk cId="452007840" sldId="429"/>
+            <ac:spMk id="2" creationId="{C84E3522-BB7F-C1AA-3AE9-C6A40BDF8ACE}"/>
+          </ac:spMkLst>
+        </pc:spChg>
+        <pc:spChg chg="mod">
+          <ac:chgData name="Adrien Osakwe" userId="7a3e290c-eb83-484b-8e3d-d46ef2333477" providerId="ADAL" clId="{516F4981-D9C8-4339-9685-B0B88EA45B28}" dt="2026-08-14T14:23:53.373" v="8382" actId="20577"/>
           <ac:spMkLst>
             <pc:docMk/>
             <pc:sldMk cId="452007840" sldId="429"/>
@@ -1673,23 +1069,8 @@
           </ac:spMkLst>
         </pc:spChg>
       </pc:sldChg>
-      <pc:sldChg chg="modSp add del mod">
-        <pc:chgData name="Adrien Osakwe" userId="7a3e290c-eb83-484b-8e3d-d46ef2333477" providerId="ADAL" clId="{516F4981-D9C8-4339-9685-B0B88EA45B28}" dt="2026-08-11T19:58:18.378" v="6343" actId="47"/>
-        <pc:sldMkLst>
-          <pc:docMk/>
-          <pc:sldMk cId="1861850653" sldId="430"/>
-        </pc:sldMkLst>
-        <pc:spChg chg="mod">
-          <ac:chgData name="Adrien Osakwe" userId="7a3e290c-eb83-484b-8e3d-d46ef2333477" providerId="ADAL" clId="{516F4981-D9C8-4339-9685-B0B88EA45B28}" dt="2026-08-11T16:02:52.572" v="4466" actId="1076"/>
-          <ac:spMkLst>
-            <pc:docMk/>
-            <pc:sldMk cId="1861850653" sldId="430"/>
-            <ac:spMk id="2" creationId="{4FBA878A-0055-6E6A-ED8B-DFB2AA8B40A0}"/>
-          </ac:spMkLst>
-        </pc:spChg>
-      </pc:sldChg>
       <pc:sldChg chg="addSp modSp new mod">
-        <pc:chgData name="Adrien Osakwe" userId="7a3e290c-eb83-484b-8e3d-d46ef2333477" providerId="ADAL" clId="{516F4981-D9C8-4339-9685-B0B88EA45B28}" dt="2026-08-11T15:58:56.329" v="4076" actId="1076"/>
+        <pc:chgData name="Adrien Osakwe" userId="7a3e290c-eb83-484b-8e3d-d46ef2333477" providerId="ADAL" clId="{516F4981-D9C8-4339-9685-B0B88EA45B28}" dt="2026-08-14T14:52:18.370" v="8502" actId="14100"/>
         <pc:sldMkLst>
           <pc:docMk/>
           <pc:sldMk cId="3455883294" sldId="431"/>
@@ -1719,28 +1100,13 @@
           </ac:spMkLst>
         </pc:spChg>
         <pc:picChg chg="add mod">
-          <ac:chgData name="Adrien Osakwe" userId="7a3e290c-eb83-484b-8e3d-d46ef2333477" providerId="ADAL" clId="{516F4981-D9C8-4339-9685-B0B88EA45B28}" dt="2026-08-11T15:58:53.356" v="4075" actId="1076"/>
+          <ac:chgData name="Adrien Osakwe" userId="7a3e290c-eb83-484b-8e3d-d46ef2333477" providerId="ADAL" clId="{516F4981-D9C8-4339-9685-B0B88EA45B28}" dt="2026-08-14T14:52:18.370" v="8502" actId="14100"/>
           <ac:picMkLst>
             <pc:docMk/>
             <pc:sldMk cId="3455883294" sldId="431"/>
             <ac:picMk id="4" creationId="{7F110F65-334D-C636-D4FD-B16599FD997B}"/>
           </ac:picMkLst>
         </pc:picChg>
-      </pc:sldChg>
-      <pc:sldChg chg="modSp add del mod">
-        <pc:chgData name="Adrien Osakwe" userId="7a3e290c-eb83-484b-8e3d-d46ef2333477" providerId="ADAL" clId="{516F4981-D9C8-4339-9685-B0B88EA45B28}" dt="2026-08-11T20:02:20.076" v="6792" actId="47"/>
-        <pc:sldMkLst>
-          <pc:docMk/>
-          <pc:sldMk cId="259435353" sldId="432"/>
-        </pc:sldMkLst>
-        <pc:spChg chg="mod">
-          <ac:chgData name="Adrien Osakwe" userId="7a3e290c-eb83-484b-8e3d-d46ef2333477" providerId="ADAL" clId="{516F4981-D9C8-4339-9685-B0B88EA45B28}" dt="2026-08-11T16:52:56.431" v="5349" actId="20577"/>
-          <ac:spMkLst>
-            <pc:docMk/>
-            <pc:sldMk cId="259435353" sldId="432"/>
-            <ac:spMk id="2" creationId="{F0809F7C-8E31-F82F-2BE8-1063529E5A6E}"/>
-          </ac:spMkLst>
-        </pc:spChg>
       </pc:sldChg>
       <pc:sldChg chg="modSp new mod">
         <pc:chgData name="Adrien Osakwe" userId="7a3e290c-eb83-484b-8e3d-d46ef2333477" providerId="ADAL" clId="{516F4981-D9C8-4339-9685-B0B88EA45B28}" dt="2026-08-11T16:06:01.328" v="4786" actId="20577"/>
@@ -1756,13 +1122,6 @@
             <ac:spMk id="2" creationId="{53D5D50F-4F28-B4DF-B643-598DE496FEDD}"/>
           </ac:spMkLst>
         </pc:spChg>
-      </pc:sldChg>
-      <pc:sldChg chg="new del">
-        <pc:chgData name="Adrien Osakwe" userId="7a3e290c-eb83-484b-8e3d-d46ef2333477" providerId="ADAL" clId="{516F4981-D9C8-4339-9685-B0B88EA45B28}" dt="2026-08-11T16:06:08.207" v="4789" actId="47"/>
-        <pc:sldMkLst>
-          <pc:docMk/>
-          <pc:sldMk cId="2430473963" sldId="434"/>
-        </pc:sldMkLst>
       </pc:sldChg>
       <pc:sldChg chg="addSp modSp new mod">
         <pc:chgData name="Adrien Osakwe" userId="7a3e290c-eb83-484b-8e3d-d46ef2333477" providerId="ADAL" clId="{516F4981-D9C8-4339-9685-B0B88EA45B28}" dt="2026-08-11T19:51:06.236" v="5400" actId="20577"/>
@@ -1835,13 +1194,13 @@
         </pc:picChg>
       </pc:sldChg>
       <pc:sldChg chg="addSp modSp new mod">
-        <pc:chgData name="Adrien Osakwe" userId="7a3e290c-eb83-484b-8e3d-d46ef2333477" providerId="ADAL" clId="{516F4981-D9C8-4339-9685-B0B88EA45B28}" dt="2026-08-11T19:55:48.364" v="6009" actId="20577"/>
+        <pc:chgData name="Adrien Osakwe" userId="7a3e290c-eb83-484b-8e3d-d46ef2333477" providerId="ADAL" clId="{516F4981-D9C8-4339-9685-B0B88EA45B28}" dt="2026-08-14T13:56:29.847" v="8343" actId="114"/>
         <pc:sldMkLst>
           <pc:docMk/>
           <pc:sldMk cId="680839714" sldId="437"/>
         </pc:sldMkLst>
         <pc:spChg chg="mod">
-          <ac:chgData name="Adrien Osakwe" userId="7a3e290c-eb83-484b-8e3d-d46ef2333477" providerId="ADAL" clId="{516F4981-D9C8-4339-9685-B0B88EA45B28}" dt="2026-08-11T19:55:48.364" v="6009" actId="20577"/>
+          <ac:chgData name="Adrien Osakwe" userId="7a3e290c-eb83-484b-8e3d-d46ef2333477" providerId="ADAL" clId="{516F4981-D9C8-4339-9685-B0B88EA45B28}" dt="2026-08-14T13:56:29.847" v="8343" actId="114"/>
           <ac:spMkLst>
             <pc:docMk/>
             <pc:sldMk cId="680839714" sldId="437"/>
@@ -1873,17 +1232,25 @@
         </pc:spChg>
       </pc:sldChg>
       <pc:sldChg chg="modSp add mod">
-        <pc:chgData name="Adrien Osakwe" userId="7a3e290c-eb83-484b-8e3d-d46ef2333477" providerId="ADAL" clId="{516F4981-D9C8-4339-9685-B0B88EA45B28}" dt="2026-08-11T19:58:40.728" v="6391" actId="20577"/>
+        <pc:chgData name="Adrien Osakwe" userId="7a3e290c-eb83-484b-8e3d-d46ef2333477" providerId="ADAL" clId="{516F4981-D9C8-4339-9685-B0B88EA45B28}" dt="2026-08-14T14:47:18.527" v="8457" actId="1076"/>
         <pc:sldMkLst>
           <pc:docMk/>
           <pc:sldMk cId="390538586" sldId="439"/>
         </pc:sldMkLst>
         <pc:spChg chg="mod">
-          <ac:chgData name="Adrien Osakwe" userId="7a3e290c-eb83-484b-8e3d-d46ef2333477" providerId="ADAL" clId="{516F4981-D9C8-4339-9685-B0B88EA45B28}" dt="2026-08-11T19:58:40.728" v="6391" actId="20577"/>
+          <ac:chgData name="Adrien Osakwe" userId="7a3e290c-eb83-484b-8e3d-d46ef2333477" providerId="ADAL" clId="{516F4981-D9C8-4339-9685-B0B88EA45B28}" dt="2026-08-14T14:47:18.527" v="8457" actId="1076"/>
           <ac:spMkLst>
             <pc:docMk/>
             <pc:sldMk cId="390538586" sldId="439"/>
             <ac:spMk id="2" creationId="{7B68F2FA-D711-4EB3-2861-17288F46576A}"/>
+          </ac:spMkLst>
+        </pc:spChg>
+        <pc:spChg chg="mod">
+          <ac:chgData name="Adrien Osakwe" userId="7a3e290c-eb83-484b-8e3d-d46ef2333477" providerId="ADAL" clId="{516F4981-D9C8-4339-9685-B0B88EA45B28}" dt="2026-08-14T14:47:16.383" v="8456" actId="1076"/>
+          <ac:spMkLst>
+            <pc:docMk/>
+            <pc:sldMk cId="390538586" sldId="439"/>
+            <ac:spMk id="3" creationId="{3735B5E2-545E-865E-6211-22F2D6D53839}"/>
           </ac:spMkLst>
         </pc:spChg>
       </pc:sldChg>
@@ -1948,13 +1315,13 @@
         </pc:spChg>
       </pc:sldChg>
       <pc:sldChg chg="modSp add mod">
-        <pc:chgData name="Adrien Osakwe" userId="7a3e290c-eb83-484b-8e3d-d46ef2333477" providerId="ADAL" clId="{516F4981-D9C8-4339-9685-B0B88EA45B28}" dt="2026-08-11T19:54:11.315" v="5807" actId="20577"/>
+        <pc:chgData name="Adrien Osakwe" userId="7a3e290c-eb83-484b-8e3d-d46ef2333477" providerId="ADAL" clId="{516F4981-D9C8-4339-9685-B0B88EA45B28}" dt="2026-08-14T15:07:57.734" v="8505" actId="313"/>
         <pc:sldMkLst>
           <pc:docMk/>
           <pc:sldMk cId="224817830" sldId="444"/>
         </pc:sldMkLst>
         <pc:spChg chg="mod">
-          <ac:chgData name="Adrien Osakwe" userId="7a3e290c-eb83-484b-8e3d-d46ef2333477" providerId="ADAL" clId="{516F4981-D9C8-4339-9685-B0B88EA45B28}" dt="2026-08-11T19:54:11.315" v="5807" actId="20577"/>
+          <ac:chgData name="Adrien Osakwe" userId="7a3e290c-eb83-484b-8e3d-d46ef2333477" providerId="ADAL" clId="{516F4981-D9C8-4339-9685-B0B88EA45B28}" dt="2026-08-14T15:07:57.734" v="8505" actId="313"/>
           <ac:spMkLst>
             <pc:docMk/>
             <pc:sldMk cId="224817830" sldId="444"/>
@@ -2000,21 +1367,6 @@
           </ac:picMkLst>
         </pc:picChg>
       </pc:sldChg>
-      <pc:sldChg chg="modSp new del mod">
-        <pc:chgData name="Adrien Osakwe" userId="7a3e290c-eb83-484b-8e3d-d46ef2333477" providerId="ADAL" clId="{516F4981-D9C8-4339-9685-B0B88EA45B28}" dt="2026-08-11T20:10:50.166" v="7519" actId="47"/>
-        <pc:sldMkLst>
-          <pc:docMk/>
-          <pc:sldMk cId="3914752990" sldId="447"/>
-        </pc:sldMkLst>
-        <pc:spChg chg="mod">
-          <ac:chgData name="Adrien Osakwe" userId="7a3e290c-eb83-484b-8e3d-d46ef2333477" providerId="ADAL" clId="{516F4981-D9C8-4339-9685-B0B88EA45B28}" dt="2026-08-11T20:10:48.118" v="7518" actId="21"/>
-          <ac:spMkLst>
-            <pc:docMk/>
-            <pc:sldMk cId="3914752990" sldId="447"/>
-            <ac:spMk id="3" creationId="{AD2328D3-67DF-83B5-804E-3E886493FCC8}"/>
-          </ac:spMkLst>
-        </pc:spChg>
-      </pc:sldChg>
       <pc:sldChg chg="modSp add mod">
         <pc:chgData name="Adrien Osakwe" userId="7a3e290c-eb83-484b-8e3d-d46ef2333477" providerId="ADAL" clId="{516F4981-D9C8-4339-9685-B0B88EA45B28}" dt="2026-08-11T20:11:58.588" v="7673" actId="20577"/>
         <pc:sldMkLst>
@@ -2038,47 +1390,8 @@
           </ac:grpSpMkLst>
         </pc:grpChg>
       </pc:sldChg>
-      <pc:sldChg chg="addSp modSp add del mod">
-        <pc:chgData name="Adrien Osakwe" userId="7a3e290c-eb83-484b-8e3d-d46ef2333477" providerId="ADAL" clId="{516F4981-D9C8-4339-9685-B0B88EA45B28}" dt="2026-08-11T20:16:22.899" v="7779" actId="47"/>
-        <pc:sldMkLst>
-          <pc:docMk/>
-          <pc:sldMk cId="3038641811" sldId="449"/>
-        </pc:sldMkLst>
-        <pc:spChg chg="mod">
-          <ac:chgData name="Adrien Osakwe" userId="7a3e290c-eb83-484b-8e3d-d46ef2333477" providerId="ADAL" clId="{516F4981-D9C8-4339-9685-B0B88EA45B28}" dt="2026-08-11T20:15:19.943" v="7714" actId="14100"/>
-          <ac:spMkLst>
-            <pc:docMk/>
-            <pc:sldMk cId="3038641811" sldId="449"/>
-            <ac:spMk id="3" creationId="{4D86081A-388F-0A32-810C-A7A5D2816ED5}"/>
-          </ac:spMkLst>
-        </pc:spChg>
-        <pc:spChg chg="mod">
-          <ac:chgData name="Adrien Osakwe" userId="7a3e290c-eb83-484b-8e3d-d46ef2333477" providerId="ADAL" clId="{516F4981-D9C8-4339-9685-B0B88EA45B28}" dt="2026-08-11T20:15:19.943" v="7714" actId="14100"/>
-          <ac:spMkLst>
-            <pc:docMk/>
-            <pc:sldMk cId="3038641811" sldId="449"/>
-            <ac:spMk id="4" creationId="{F4B55E28-0E6D-D360-CB34-664881A3F542}"/>
-          </ac:spMkLst>
-        </pc:spChg>
-        <pc:spChg chg="add mod">
-          <ac:chgData name="Adrien Osakwe" userId="7a3e290c-eb83-484b-8e3d-d46ef2333477" providerId="ADAL" clId="{516F4981-D9C8-4339-9685-B0B88EA45B28}" dt="2026-08-11T20:16:04.344" v="7747" actId="122"/>
-          <ac:spMkLst>
-            <pc:docMk/>
-            <pc:sldMk cId="3038641811" sldId="449"/>
-            <ac:spMk id="5" creationId="{D767EF7F-846D-6AA0-AEB3-5F0493576B07}"/>
-          </ac:spMkLst>
-        </pc:spChg>
-        <pc:spChg chg="add mod">
-          <ac:chgData name="Adrien Osakwe" userId="7a3e290c-eb83-484b-8e3d-d46ef2333477" providerId="ADAL" clId="{516F4981-D9C8-4339-9685-B0B88EA45B28}" dt="2026-08-11T20:15:52.012" v="7727" actId="1076"/>
-          <ac:spMkLst>
-            <pc:docMk/>
-            <pc:sldMk cId="3038641811" sldId="449"/>
-            <ac:spMk id="6" creationId="{DBFA2468-F089-2C73-D50F-8E31C66D5113}"/>
-          </ac:spMkLst>
-        </pc:spChg>
-      </pc:sldChg>
-      <pc:sldChg chg="addSp delSp modSp new mod">
-        <pc:chgData name="Adrien Osakwe" userId="7a3e290c-eb83-484b-8e3d-d46ef2333477" providerId="ADAL" clId="{516F4981-D9C8-4339-9685-B0B88EA45B28}" dt="2026-08-11T20:19:31.053" v="8251" actId="20577"/>
+      <pc:sldChg chg="addSp delSp modSp new mod modAnim">
+        <pc:chgData name="Adrien Osakwe" userId="7a3e290c-eb83-484b-8e3d-d46ef2333477" providerId="ADAL" clId="{516F4981-D9C8-4339-9685-B0B88EA45B28}" dt="2026-08-14T13:53:35.799" v="8264"/>
         <pc:sldMkLst>
           <pc:docMk/>
           <pc:sldMk cId="3567545301" sldId="450"/>
@@ -2099,14 +1412,6 @@
             <ac:spMk id="3" creationId="{F9D67DD5-AD34-86CF-5CE0-F971881A1045}"/>
           </ac:spMkLst>
         </pc:spChg>
-        <pc:graphicFrameChg chg="add del mod ord modGraphic">
-          <ac:chgData name="Adrien Osakwe" userId="7a3e290c-eb83-484b-8e3d-d46ef2333477" providerId="ADAL" clId="{516F4981-D9C8-4339-9685-B0B88EA45B28}" dt="2026-08-11T20:16:40.244" v="7791" actId="3680"/>
-          <ac:graphicFrameMkLst>
-            <pc:docMk/>
-            <pc:sldMk cId="3567545301" sldId="450"/>
-            <ac:graphicFrameMk id="4" creationId="{0EF09418-258F-6ECD-82D9-EC7C7EA86AA6}"/>
-          </ac:graphicFrameMkLst>
-        </pc:graphicFrameChg>
       </pc:sldChg>
     </pc:docChg>
   </pc:docChgLst>
@@ -2195,7 +1500,7 @@
           <a:p>
             <a:fld id="{217E5156-1B5D-054E-B5B2-E1B1BA160252}" type="datetimeFigureOut">
               <a:rPr lang="fr-FR" smtClean="0"/>
-              <a:t>11/08/2026</a:t>
+              <a:t>14/08/2026</a:t>
             </a:fld>
             <a:endParaRPr lang="fr-FR"/>
           </a:p>
@@ -2465,6 +1770,13 @@
           </p:nvPr>
         </p:nvSpPr>
         <p:spPr/>
+        <p:txBody>
+          <a:bodyPr/>
+          <a:lstStyle/>
+          <a:p>
+            <a:endParaRPr lang="en-CA"/>
+          </a:p>
+        </p:txBody>
       </p:sp>
       <p:sp>
         <p:nvSpPr>
@@ -2561,6 +1873,13 @@
           </p:nvPr>
         </p:nvSpPr>
         <p:spPr/>
+        <p:txBody>
+          <a:bodyPr/>
+          <a:lstStyle/>
+          <a:p>
+            <a:endParaRPr lang="en-CA"/>
+          </a:p>
+        </p:txBody>
       </p:sp>
       <p:sp>
         <p:nvSpPr>
@@ -2663,6 +1982,13 @@
           </p:nvPr>
         </p:nvSpPr>
         <p:spPr/>
+        <p:txBody>
+          <a:bodyPr/>
+          <a:lstStyle/>
+          <a:p>
+            <a:endParaRPr lang="en-CA"/>
+          </a:p>
+        </p:txBody>
       </p:sp>
       <p:sp>
         <p:nvSpPr>
@@ -2747,6 +2073,13 @@
           </p:nvPr>
         </p:nvSpPr>
         <p:spPr/>
+        <p:txBody>
+          <a:bodyPr/>
+          <a:lstStyle/>
+          <a:p>
+            <a:endParaRPr lang="en-CA"/>
+          </a:p>
+        </p:txBody>
       </p:sp>
       <p:sp>
         <p:nvSpPr>
@@ -2831,6 +2164,13 @@
           </p:nvPr>
         </p:nvSpPr>
         <p:spPr/>
+        <p:txBody>
+          <a:bodyPr/>
+          <a:lstStyle/>
+          <a:p>
+            <a:endParaRPr lang="en-CA"/>
+          </a:p>
+        </p:txBody>
       </p:sp>
       <p:sp>
         <p:nvSpPr>
@@ -2915,6 +2255,13 @@
           </p:nvPr>
         </p:nvSpPr>
         <p:spPr/>
+        <p:txBody>
+          <a:bodyPr/>
+          <a:lstStyle/>
+          <a:p>
+            <a:endParaRPr lang="en-CA"/>
+          </a:p>
+        </p:txBody>
       </p:sp>
       <p:sp>
         <p:nvSpPr>
@@ -2999,6 +2346,13 @@
           </p:nvPr>
         </p:nvSpPr>
         <p:spPr/>
+        <p:txBody>
+          <a:bodyPr/>
+          <a:lstStyle/>
+          <a:p>
+            <a:endParaRPr lang="en-CA"/>
+          </a:p>
+        </p:txBody>
       </p:sp>
       <p:sp>
         <p:nvSpPr>
@@ -3083,6 +2437,13 @@
           </p:nvPr>
         </p:nvSpPr>
         <p:spPr/>
+        <p:txBody>
+          <a:bodyPr/>
+          <a:lstStyle/>
+          <a:p>
+            <a:endParaRPr lang="en-CA"/>
+          </a:p>
+        </p:txBody>
       </p:sp>
       <p:sp>
         <p:nvSpPr>
@@ -3167,6 +2528,13 @@
           </p:nvPr>
         </p:nvSpPr>
         <p:spPr/>
+        <p:txBody>
+          <a:bodyPr/>
+          <a:lstStyle/>
+          <a:p>
+            <a:endParaRPr lang="en-CA"/>
+          </a:p>
+        </p:txBody>
       </p:sp>
       <p:sp>
         <p:nvSpPr>
@@ -3269,6 +2637,13 @@
           </p:nvPr>
         </p:nvSpPr>
         <p:spPr/>
+        <p:txBody>
+          <a:bodyPr/>
+          <a:lstStyle/>
+          <a:p>
+            <a:endParaRPr lang="en-CA"/>
+          </a:p>
+        </p:txBody>
       </p:sp>
       <p:sp>
         <p:nvSpPr>
@@ -3383,6 +2758,13 @@
           </p:nvPr>
         </p:nvSpPr>
         <p:spPr/>
+        <p:txBody>
+          <a:bodyPr/>
+          <a:lstStyle/>
+          <a:p>
+            <a:endParaRPr lang="en-CA"/>
+          </a:p>
+        </p:txBody>
       </p:sp>
       <p:sp>
         <p:nvSpPr>
@@ -3497,6 +2879,13 @@
           </p:nvPr>
         </p:nvSpPr>
         <p:spPr/>
+        <p:txBody>
+          <a:bodyPr/>
+          <a:lstStyle/>
+          <a:p>
+            <a:endParaRPr lang="en-CA"/>
+          </a:p>
+        </p:txBody>
       </p:sp>
       <p:sp>
         <p:nvSpPr>
@@ -4239,7 +3628,7 @@
           <a:p>
             <a:fld id="{287C9ABC-0C1C-4801-85B9-12829D42DDA4}" type="datetimeFigureOut">
               <a:rPr lang="en-AU" smtClean="0"/>
-              <a:t>11/08/2026</a:t>
+              <a:t>14/08/2026</a:t>
             </a:fld>
             <a:endParaRPr lang="en-AU"/>
           </a:p>
@@ -6398,579 +5787,6 @@
   <p:cSld>
     <p:spTree>
       <p:nvGrpSpPr>
-        <p:cNvPr id="1" name=""/>
-        <p:cNvGrpSpPr/>
-        <p:nvPr/>
-      </p:nvGrpSpPr>
-      <p:grpSpPr>
-        <a:xfrm>
-          <a:off x="0" y="0"/>
-          <a:ext cx="0" cy="0"/>
-          <a:chOff x="0" y="0"/>
-          <a:chExt cx="0" cy="0"/>
-        </a:xfrm>
-      </p:grpSpPr>
-      <p:sp>
-        <p:nvSpPr>
-          <p:cNvPr id="2" name="Text Placeholder 1">
-            <a:extLst>
-              <a:ext uri="{FF2B5EF4-FFF2-40B4-BE49-F238E27FC236}">
-                <a16:creationId xmlns:a16="http://schemas.microsoft.com/office/drawing/2014/main" id="{9B245876-087E-37FF-2A45-491803B93EF5}"/>
-              </a:ext>
-            </a:extLst>
-          </p:cNvPr>
-          <p:cNvSpPr>
-            <a:spLocks noGrp="1"/>
-          </p:cNvSpPr>
-          <p:nvPr>
-            <p:ph type="body" sz="quarter" idx="10"/>
-          </p:nvPr>
-        </p:nvSpPr>
-        <p:spPr>
-          <a:xfrm>
-            <a:off x="242372" y="2940626"/>
-            <a:ext cx="8658743" cy="3437951"/>
-          </a:xfrm>
-        </p:spPr>
-        <p:txBody>
-          <a:bodyPr/>
-          <a:lstStyle/>
-          <a:p>
-            <a:r>
-              <a:rPr lang="en-CA" dirty="0"/>
-              <a:t>Explore the 1_Simple_Scripts folder</a:t>
-            </a:r>
-          </a:p>
-          <a:p>
-            <a:endParaRPr lang="en-CA" dirty="0"/>
-          </a:p>
-          <a:p>
-            <a:r>
-              <a:rPr lang="en-CA" dirty="0"/>
-              <a:t>Try running the code</a:t>
-            </a:r>
-          </a:p>
-          <a:p>
-            <a:endParaRPr lang="en-CA" dirty="0"/>
-          </a:p>
-          <a:p>
-            <a:r>
-              <a:rPr lang="en-CA" dirty="0"/>
-              <a:t>What would happen if you wanted to run this in a different folder?</a:t>
-            </a:r>
-          </a:p>
-        </p:txBody>
-      </p:sp>
-      <p:sp>
-        <p:nvSpPr>
-          <p:cNvPr id="3" name="Title 1">
-            <a:extLst>
-              <a:ext uri="{FF2B5EF4-FFF2-40B4-BE49-F238E27FC236}">
-                <a16:creationId xmlns:a16="http://schemas.microsoft.com/office/drawing/2014/main" id="{D0AE3FC0-C652-C431-6A10-987A06B22130}"/>
-              </a:ext>
-            </a:extLst>
-          </p:cNvPr>
-          <p:cNvSpPr txBox="1">
-            <a:spLocks/>
-          </p:cNvSpPr>
-          <p:nvPr/>
-        </p:nvSpPr>
-        <p:spPr>
-          <a:xfrm>
-            <a:off x="242372" y="1558637"/>
-            <a:ext cx="8658743" cy="1007918"/>
-          </a:xfrm>
-          <a:prstGeom prst="rect">
-            <a:avLst/>
-          </a:prstGeom>
-        </p:spPr>
-        <p:txBody>
-          <a:bodyPr>
-            <a:noAutofit/>
-          </a:bodyPr>
-          <a:lstStyle>
-            <a:lvl1pPr algn="l" defTabSz="914175" rtl="0" eaLnBrk="1" latinLnBrk="0" hangingPunct="1">
-              <a:lnSpc>
-                <a:spcPct val="90000"/>
-              </a:lnSpc>
-              <a:spcBef>
-                <a:spcPct val="0"/>
-              </a:spcBef>
-              <a:buNone/>
-              <a:defRPr sz="4403" kern="1200">
-                <a:solidFill>
-                  <a:schemeClr val="tx1"/>
-                </a:solidFill>
-                <a:latin typeface="+mj-lt"/>
-                <a:ea typeface="+mj-ea"/>
-                <a:cs typeface="+mj-cs"/>
-              </a:defRPr>
-            </a:lvl1pPr>
-          </a:lstStyle>
-          <a:p>
-            <a:pPr algn="ctr"/>
-            <a:r>
-              <a:rPr lang="en-CA" sz="7200" dirty="0"/>
-              <a:t>Exercise</a:t>
-            </a:r>
-          </a:p>
-        </p:txBody>
-      </p:sp>
-    </p:spTree>
-    <p:extLst>
-      <p:ext uri="{BB962C8B-B14F-4D97-AF65-F5344CB8AC3E}">
-        <p14:creationId xmlns:p14="http://schemas.microsoft.com/office/powerpoint/2010/main" val="680839714"/>
-      </p:ext>
-    </p:extLst>
-  </p:cSld>
-  <p:clrMapOvr>
-    <a:masterClrMapping/>
-  </p:clrMapOvr>
-</p:sld>
-</file>
-
-<file path=ppt/slides/slide11.xml><?xml version="1.0" encoding="utf-8"?>
-<p:sld xmlns:a="http://schemas.openxmlformats.org/drawingml/2006/main" xmlns:r="http://schemas.openxmlformats.org/officeDocument/2006/relationships" xmlns:p="http://schemas.openxmlformats.org/presentationml/2006/main">
-  <p:cSld>
-    <p:spTree>
-      <p:nvGrpSpPr>
-        <p:cNvPr id="1" name=""/>
-        <p:cNvGrpSpPr/>
-        <p:nvPr/>
-      </p:nvGrpSpPr>
-      <p:grpSpPr>
-        <a:xfrm>
-          <a:off x="0" y="0"/>
-          <a:ext cx="0" cy="0"/>
-          <a:chOff x="0" y="0"/>
-          <a:chExt cx="0" cy="0"/>
-        </a:xfrm>
-      </p:grpSpPr>
-      <p:sp>
-        <p:nvSpPr>
-          <p:cNvPr id="2" name="Title 1">
-            <a:extLst>
-              <a:ext uri="{FF2B5EF4-FFF2-40B4-BE49-F238E27FC236}">
-                <a16:creationId xmlns:a16="http://schemas.microsoft.com/office/drawing/2014/main" id="{22643326-375A-A79A-4BC9-E08429337A85}"/>
-              </a:ext>
-            </a:extLst>
-          </p:cNvPr>
-          <p:cNvSpPr>
-            <a:spLocks noGrp="1"/>
-          </p:cNvSpPr>
-          <p:nvPr>
-            <p:ph type="title"/>
-          </p:nvPr>
-        </p:nvSpPr>
-        <p:spPr/>
-        <p:txBody>
-          <a:bodyPr/>
-          <a:lstStyle/>
-          <a:p>
-            <a:r>
-              <a:rPr lang="en-US" dirty="0"/>
-              <a:t>What is a package?</a:t>
-            </a:r>
-          </a:p>
-        </p:txBody>
-      </p:sp>
-      <p:sp>
-        <p:nvSpPr>
-          <p:cNvPr id="3" name="Content Placeholder 2">
-            <a:extLst>
-              <a:ext uri="{FF2B5EF4-FFF2-40B4-BE49-F238E27FC236}">
-                <a16:creationId xmlns:a16="http://schemas.microsoft.com/office/drawing/2014/main" id="{ACB875C8-BD73-F266-4045-06FC436A35AA}"/>
-              </a:ext>
-            </a:extLst>
-          </p:cNvPr>
-          <p:cNvSpPr>
-            <a:spLocks noGrp="1"/>
-          </p:cNvSpPr>
-          <p:nvPr>
-            <p:ph sz="half" idx="1"/>
-          </p:nvPr>
-        </p:nvSpPr>
-        <p:spPr>
-          <a:xfrm>
-            <a:off x="628649" y="1825627"/>
-            <a:ext cx="4504459" cy="4351335"/>
-          </a:xfrm>
-        </p:spPr>
-        <p:txBody>
-          <a:bodyPr>
-            <a:normAutofit/>
-          </a:bodyPr>
-          <a:lstStyle/>
-          <a:p>
-            <a:r>
-              <a:rPr lang="en-CA" dirty="0"/>
-              <a:t>Set of reusable functions</a:t>
-            </a:r>
-          </a:p>
-          <a:p>
-            <a:endParaRPr lang="en-CA" dirty="0"/>
-          </a:p>
-          <a:p>
-            <a:r>
-              <a:rPr lang="en-CA" dirty="0"/>
-              <a:t>Standardized formatting</a:t>
-            </a:r>
-          </a:p>
-          <a:p>
-            <a:r>
-              <a:rPr lang="en-CA" dirty="0"/>
-              <a:t>No file path needed</a:t>
-            </a:r>
-          </a:p>
-          <a:p>
-            <a:endParaRPr lang="en-CA" dirty="0"/>
-          </a:p>
-          <a:p>
-            <a:r>
-              <a:rPr lang="en-CA" dirty="0"/>
-              <a:t>Facilitates installation</a:t>
-            </a:r>
-          </a:p>
-          <a:p>
-            <a:r>
-              <a:rPr lang="en-CA" dirty="0"/>
-              <a:t>Automates dependencies</a:t>
-            </a:r>
-          </a:p>
-        </p:txBody>
-      </p:sp>
-      <p:pic>
-        <p:nvPicPr>
-          <p:cNvPr id="1028" name="Picture 4" descr="Top 9 R packages (that every Data Scientist must know)">
-            <a:extLst>
-              <a:ext uri="{FF2B5EF4-FFF2-40B4-BE49-F238E27FC236}">
-                <a16:creationId xmlns:a16="http://schemas.microsoft.com/office/drawing/2014/main" id="{C0119C7F-7394-3714-73BC-BFB0C9254886}"/>
-              </a:ext>
-            </a:extLst>
-          </p:cNvPr>
-          <p:cNvPicPr>
-            <a:picLocks noChangeAspect="1" noChangeArrowheads="1"/>
-          </p:cNvPicPr>
-          <p:nvPr/>
-        </p:nvPicPr>
-        <p:blipFill>
-          <a:blip r:embed="rId2">
-            <a:extLst>
-              <a:ext uri="{28A0092B-C50C-407E-A947-70E740481C1C}">
-                <a14:useLocalDpi xmlns:a14="http://schemas.microsoft.com/office/drawing/2010/main" val="0"/>
-              </a:ext>
-            </a:extLst>
-          </a:blip>
-          <a:srcRect/>
-          <a:stretch>
-            <a:fillRect/>
-          </a:stretch>
-        </p:blipFill>
-        <p:spPr bwMode="auto">
-          <a:xfrm>
-            <a:off x="4653173" y="2432497"/>
-            <a:ext cx="4355359" cy="2388643"/>
-          </a:xfrm>
-          <a:prstGeom prst="rect">
-            <a:avLst/>
-          </a:prstGeom>
-          <a:noFill/>
-          <a:extLst>
-            <a:ext uri="{909E8E84-426E-40DD-AFC4-6F175D3DCCD1}">
-              <a14:hiddenFill xmlns:a14="http://schemas.microsoft.com/office/drawing/2010/main">
-                <a:solidFill>
-                  <a:srgbClr val="FFFFFF"/>
-                </a:solidFill>
-              </a14:hiddenFill>
-            </a:ext>
-          </a:extLst>
-        </p:spPr>
-      </p:pic>
-      <p:pic>
-        <p:nvPicPr>
-          <p:cNvPr id="5" name="Picture 4">
-            <a:extLst>
-              <a:ext uri="{FF2B5EF4-FFF2-40B4-BE49-F238E27FC236}">
-                <a16:creationId xmlns:a16="http://schemas.microsoft.com/office/drawing/2014/main" id="{EA0355F1-DDBE-FD70-D0E2-5E76497DC699}"/>
-              </a:ext>
-            </a:extLst>
-          </p:cNvPr>
-          <p:cNvPicPr>
-            <a:picLocks noChangeAspect="1"/>
-          </p:cNvPicPr>
-          <p:nvPr/>
-        </p:nvPicPr>
-        <p:blipFill>
-          <a:blip r:embed="rId3"/>
-          <a:srcRect l="19390" t="43434" r="16684" b="37472"/>
-          <a:stretch>
-            <a:fillRect/>
-          </a:stretch>
-        </p:blipFill>
-        <p:spPr>
-          <a:xfrm>
-            <a:off x="628649" y="5428010"/>
-            <a:ext cx="4213514" cy="883891"/>
-          </a:xfrm>
-          <a:prstGeom prst="rect">
-            <a:avLst/>
-          </a:prstGeom>
-        </p:spPr>
-      </p:pic>
-    </p:spTree>
-    <p:extLst>
-      <p:ext uri="{BB962C8B-B14F-4D97-AF65-F5344CB8AC3E}">
-        <p14:creationId xmlns:p14="http://schemas.microsoft.com/office/powerpoint/2010/main" val="4107645974"/>
-      </p:ext>
-    </p:extLst>
-  </p:cSld>
-  <p:clrMapOvr>
-    <a:masterClrMapping/>
-  </p:clrMapOvr>
-</p:sld>
-</file>
-
-<file path=ppt/slides/slide12.xml><?xml version="1.0" encoding="utf-8"?>
-<p:sld xmlns:a="http://schemas.openxmlformats.org/drawingml/2006/main" xmlns:r="http://schemas.openxmlformats.org/officeDocument/2006/relationships" xmlns:p="http://schemas.openxmlformats.org/presentationml/2006/main">
-  <p:cSld>
-    <p:spTree>
-      <p:nvGrpSpPr>
-        <p:cNvPr id="1" name=""/>
-        <p:cNvGrpSpPr/>
-        <p:nvPr/>
-      </p:nvGrpSpPr>
-      <p:grpSpPr>
-        <a:xfrm>
-          <a:off x="0" y="0"/>
-          <a:ext cx="0" cy="0"/>
-          <a:chOff x="0" y="0"/>
-          <a:chExt cx="0" cy="0"/>
-        </a:xfrm>
-      </p:grpSpPr>
-      <p:sp>
-        <p:nvSpPr>
-          <p:cNvPr id="2" name="Title 1">
-            <a:extLst>
-              <a:ext uri="{FF2B5EF4-FFF2-40B4-BE49-F238E27FC236}">
-                <a16:creationId xmlns:a16="http://schemas.microsoft.com/office/drawing/2014/main" id="{98205D2F-58F2-9087-C234-C1A51D2DE352}"/>
-              </a:ext>
-            </a:extLst>
-          </p:cNvPr>
-          <p:cNvSpPr>
-            <a:spLocks noGrp="1"/>
-          </p:cNvSpPr>
-          <p:nvPr>
-            <p:ph type="title"/>
-          </p:nvPr>
-        </p:nvSpPr>
-        <p:spPr/>
-        <p:txBody>
-          <a:bodyPr/>
-          <a:lstStyle/>
-          <a:p>
-            <a:r>
-              <a:rPr lang="en-CA" dirty="0"/>
-              <a:t>Today’s Example: </a:t>
-            </a:r>
-            <a:r>
-              <a:rPr lang="en-CA" dirty="0" err="1"/>
-              <a:t>bioNMF</a:t>
-            </a:r>
-            <a:r>
-              <a:rPr lang="en-CA" dirty="0"/>
-              <a:t> Package</a:t>
-            </a:r>
-          </a:p>
-        </p:txBody>
-      </p:sp>
-      <p:sp>
-        <p:nvSpPr>
-          <p:cNvPr id="3" name="Content Placeholder 2">
-            <a:extLst>
-              <a:ext uri="{FF2B5EF4-FFF2-40B4-BE49-F238E27FC236}">
-                <a16:creationId xmlns:a16="http://schemas.microsoft.com/office/drawing/2014/main" id="{E5040FA8-5BD8-7184-15EB-808A3AE6A056}"/>
-              </a:ext>
-            </a:extLst>
-          </p:cNvPr>
-          <p:cNvSpPr>
-            <a:spLocks noGrp="1"/>
-          </p:cNvSpPr>
-          <p:nvPr>
-            <p:ph idx="1"/>
-          </p:nvPr>
-        </p:nvSpPr>
-        <p:spPr/>
-        <p:txBody>
-          <a:bodyPr/>
-          <a:lstStyle/>
-          <a:p>
-            <a:r>
-              <a:rPr lang="en-CA" dirty="0"/>
-              <a:t>We will be working on a </a:t>
-            </a:r>
-            <a:r>
-              <a:rPr lang="en-CA" b="1" dirty="0"/>
-              <a:t>non-negative matrix factorization (NMF)</a:t>
-            </a:r>
-            <a:r>
-              <a:rPr lang="en-CA" dirty="0"/>
-              <a:t> package</a:t>
-            </a:r>
-          </a:p>
-          <a:p>
-            <a:r>
-              <a:rPr lang="en-CA" dirty="0"/>
-              <a:t>NMF decomposes data into </a:t>
-            </a:r>
-            <a:r>
-              <a:rPr lang="en-CA" b="1" dirty="0"/>
-              <a:t>clusters </a:t>
-            </a:r>
-            <a:r>
-              <a:rPr lang="en-CA" dirty="0"/>
-              <a:t>(r dimension)</a:t>
-            </a:r>
-          </a:p>
-          <a:p>
-            <a:r>
-              <a:rPr lang="en-CA" dirty="0"/>
-              <a:t>Common for count data (gene expression)</a:t>
-            </a:r>
-          </a:p>
-          <a:p>
-            <a:endParaRPr lang="en-CA" dirty="0"/>
-          </a:p>
-          <a:p>
-            <a:r>
-              <a:rPr lang="en-CA" dirty="0"/>
-              <a:t>Samples (patients) – n</a:t>
-            </a:r>
-          </a:p>
-          <a:p>
-            <a:r>
-              <a:rPr lang="en-CA" dirty="0"/>
-              <a:t>Features (genes) – p</a:t>
-            </a:r>
-          </a:p>
-          <a:p>
-            <a:r>
-              <a:rPr lang="en-CA" dirty="0"/>
-              <a:t>Clusters (programs) – r</a:t>
-            </a:r>
-          </a:p>
-          <a:p>
-            <a:endParaRPr lang="en-CA" dirty="0"/>
-          </a:p>
-        </p:txBody>
-      </p:sp>
-      <p:grpSp>
-        <p:nvGrpSpPr>
-          <p:cNvPr id="6" name="Group 5">
-            <a:extLst>
-              <a:ext uri="{FF2B5EF4-FFF2-40B4-BE49-F238E27FC236}">
-                <a16:creationId xmlns:a16="http://schemas.microsoft.com/office/drawing/2014/main" id="{55CF7EE0-9283-0D3D-0FF8-DB1D3BE0E505}"/>
-              </a:ext>
-            </a:extLst>
-          </p:cNvPr>
-          <p:cNvGrpSpPr/>
-          <p:nvPr/>
-        </p:nvGrpSpPr>
-        <p:grpSpPr>
-          <a:xfrm>
-            <a:off x="4416137" y="3844636"/>
-            <a:ext cx="4613564" cy="3013364"/>
-            <a:chOff x="824012" y="3674928"/>
-            <a:chExt cx="3935816" cy="2214411"/>
-          </a:xfrm>
-        </p:grpSpPr>
-        <p:pic>
-          <p:nvPicPr>
-            <p:cNvPr id="4" name="Picture 3" descr="Non-negative Matrix Factorization (Part 1): Understanding Its Importance  and Applications">
-              <a:extLst>
-                <a:ext uri="{FF2B5EF4-FFF2-40B4-BE49-F238E27FC236}">
-                  <a16:creationId xmlns:a16="http://schemas.microsoft.com/office/drawing/2014/main" id="{4A89B8C9-C236-A3EB-95C8-643E9A3C5CF1}"/>
-                </a:ext>
-              </a:extLst>
-            </p:cNvPr>
-            <p:cNvPicPr>
-              <a:picLocks noChangeAspect="1"/>
-            </p:cNvPicPr>
-            <p:nvPr/>
-          </p:nvPicPr>
-          <p:blipFill>
-            <a:blip r:embed="rId2"/>
-            <a:srcRect l="4525" r="4304"/>
-            <a:stretch>
-              <a:fillRect/>
-            </a:stretch>
-          </p:blipFill>
-          <p:spPr>
-            <a:xfrm>
-              <a:off x="824012" y="3674928"/>
-              <a:ext cx="3935816" cy="1782172"/>
-            </a:xfrm>
-            <a:prstGeom prst="rect">
-              <a:avLst/>
-            </a:prstGeom>
-          </p:spPr>
-        </p:pic>
-        <p:sp>
-          <p:nvSpPr>
-            <p:cNvPr id="5" name="TextBox 4">
-              <a:extLst>
-                <a:ext uri="{FF2B5EF4-FFF2-40B4-BE49-F238E27FC236}">
-                  <a16:creationId xmlns:a16="http://schemas.microsoft.com/office/drawing/2014/main" id="{EBB307C6-CD8E-A0BE-F92E-FBFC0373D618}"/>
-                </a:ext>
-              </a:extLst>
-            </p:cNvPr>
-            <p:cNvSpPr txBox="1"/>
-            <p:nvPr/>
-          </p:nvSpPr>
-          <p:spPr>
-            <a:xfrm>
-              <a:off x="2371518" y="5519879"/>
-              <a:ext cx="831272" cy="369460"/>
-            </a:xfrm>
-            <a:prstGeom prst="rect">
-              <a:avLst/>
-            </a:prstGeom>
-            <a:noFill/>
-          </p:spPr>
-          <p:txBody>
-            <a:bodyPr wrap="square" rtlCol="0">
-              <a:spAutoFit/>
-            </a:bodyPr>
-            <a:lstStyle/>
-            <a:p>
-              <a:r>
-                <a:rPr lang="en-CA" dirty="0">
-                  <a:hlinkClick r:id="rId3"/>
-                </a:rPr>
-                <a:t>Source</a:t>
-              </a:r>
-              <a:endParaRPr lang="en-CA" dirty="0"/>
-            </a:p>
-          </p:txBody>
-        </p:sp>
-      </p:grpSp>
-    </p:spTree>
-    <p:extLst>
-      <p:ext uri="{BB962C8B-B14F-4D97-AF65-F5344CB8AC3E}">
-        <p14:creationId xmlns:p14="http://schemas.microsoft.com/office/powerpoint/2010/main" val="998501193"/>
-      </p:ext>
-    </p:extLst>
-  </p:cSld>
-  <p:clrMapOvr>
-    <a:masterClrMapping/>
-  </p:clrMapOvr>
-</p:sld>
-</file>
-
-<file path=ppt/slides/slide13.xml><?xml version="1.0" encoding="utf-8"?>
-<p:sld xmlns:a="http://schemas.openxmlformats.org/drawingml/2006/main" xmlns:r="http://schemas.openxmlformats.org/officeDocument/2006/relationships" xmlns:p="http://schemas.openxmlformats.org/presentationml/2006/main">
-  <p:cSld>
-    <p:spTree>
-      <p:nvGrpSpPr>
         <p:cNvPr id="1" name="">
           <a:extLst>
             <a:ext uri="{FF2B5EF4-FFF2-40B4-BE49-F238E27FC236}">
@@ -7012,7 +5828,15 @@
           <a:p>
             <a:r>
               <a:rPr lang="en-CA" dirty="0"/>
-              <a:t>Today’s Example: NMF Package</a:t>
+              <a:t>Today’s Example: </a:t>
+            </a:r>
+            <a:r>
+              <a:rPr lang="en-CA" dirty="0" err="1"/>
+              <a:t>bioNMF</a:t>
+            </a:r>
+            <a:r>
+              <a:rPr lang="en-CA" dirty="0"/>
+              <a:t> Package</a:t>
             </a:r>
           </a:p>
         </p:txBody>
@@ -7033,7 +5857,12 @@
             <p:ph idx="1"/>
           </p:nvPr>
         </p:nvSpPr>
-        <p:spPr/>
+        <p:spPr>
+          <a:xfrm>
+            <a:off x="477982" y="1825627"/>
+            <a:ext cx="6369627" cy="4351335"/>
+          </a:xfrm>
+        </p:spPr>
         <p:txBody>
           <a:bodyPr/>
           <a:lstStyle/>
@@ -7049,6 +5878,15 @@
           <a:p>
             <a:r>
               <a:rPr lang="en-CA" dirty="0"/>
+              <a:t>Load datasets</a:t>
+            </a:r>
+          </a:p>
+          <a:p>
+            <a:endParaRPr lang="en-CA" dirty="0"/>
+          </a:p>
+          <a:p>
+            <a:r>
+              <a:rPr lang="en-CA" dirty="0"/>
               <a:t>Train an NMF model</a:t>
             </a:r>
           </a:p>
@@ -7056,7 +5894,7 @@
             <a:pPr lvl="1"/>
             <a:r>
               <a:rPr lang="en-CA" dirty="0"/>
-              <a:t>Takes X as input, returns W and H</a:t>
+              <a:t>Takes X as input, returns			W and H</a:t>
             </a:r>
           </a:p>
           <a:p>
@@ -7183,6 +6021,735 @@
 </p:sld>
 </file>
 
+<file path=ppt/slides/slide11.xml><?xml version="1.0" encoding="utf-8"?>
+<p:sld xmlns:a="http://schemas.openxmlformats.org/drawingml/2006/main" xmlns:r="http://schemas.openxmlformats.org/officeDocument/2006/relationships" xmlns:p="http://schemas.openxmlformats.org/presentationml/2006/main">
+  <p:cSld>
+    <p:spTree>
+      <p:nvGrpSpPr>
+        <p:cNvPr id="1" name=""/>
+        <p:cNvGrpSpPr/>
+        <p:nvPr/>
+      </p:nvGrpSpPr>
+      <p:grpSpPr>
+        <a:xfrm>
+          <a:off x="0" y="0"/>
+          <a:ext cx="0" cy="0"/>
+          <a:chOff x="0" y="0"/>
+          <a:chExt cx="0" cy="0"/>
+        </a:xfrm>
+      </p:grpSpPr>
+      <p:sp>
+        <p:nvSpPr>
+          <p:cNvPr id="2" name="Title 1">
+            <a:extLst>
+              <a:ext uri="{FF2B5EF4-FFF2-40B4-BE49-F238E27FC236}">
+                <a16:creationId xmlns:a16="http://schemas.microsoft.com/office/drawing/2014/main" id="{931D2992-2D2C-03B2-20A7-FA3CFD5F72E8}"/>
+              </a:ext>
+            </a:extLst>
+          </p:cNvPr>
+          <p:cNvSpPr>
+            <a:spLocks noGrp="1"/>
+          </p:cNvSpPr>
+          <p:nvPr>
+            <p:ph type="title"/>
+          </p:nvPr>
+        </p:nvSpPr>
+        <p:spPr/>
+        <p:txBody>
+          <a:bodyPr/>
+          <a:lstStyle/>
+          <a:p>
+            <a:r>
+              <a:rPr lang="en-CA" dirty="0"/>
+              <a:t>Why bother with packages?</a:t>
+            </a:r>
+          </a:p>
+        </p:txBody>
+      </p:sp>
+      <p:sp>
+        <p:nvSpPr>
+          <p:cNvPr id="3" name="Content Placeholder 2">
+            <a:extLst>
+              <a:ext uri="{FF2B5EF4-FFF2-40B4-BE49-F238E27FC236}">
+                <a16:creationId xmlns:a16="http://schemas.microsoft.com/office/drawing/2014/main" id="{F9D67DD5-AD34-86CF-5CE0-F971881A1045}"/>
+              </a:ext>
+            </a:extLst>
+          </p:cNvPr>
+          <p:cNvSpPr>
+            <a:spLocks noGrp="1"/>
+          </p:cNvSpPr>
+          <p:nvPr>
+            <p:ph idx="1"/>
+          </p:nvPr>
+        </p:nvSpPr>
+        <p:spPr/>
+        <p:txBody>
+          <a:bodyPr>
+            <a:normAutofit lnSpcReduction="10000"/>
+          </a:bodyPr>
+          <a:lstStyle/>
+          <a:p>
+            <a:r>
+              <a:rPr lang="en-CA" dirty="0"/>
+              <a:t>“Works on my machine”</a:t>
+            </a:r>
+          </a:p>
+          <a:p>
+            <a:pPr lvl="1"/>
+            <a:r>
+              <a:rPr lang="en-CA" dirty="0"/>
+              <a:t>What about other users?</a:t>
+            </a:r>
+          </a:p>
+          <a:p>
+            <a:pPr lvl="1"/>
+            <a:endParaRPr lang="en-CA" dirty="0"/>
+          </a:p>
+          <a:p>
+            <a:r>
+              <a:rPr lang="en-CA" dirty="0"/>
+              <a:t>“Using different scripts with source() is enough”</a:t>
+            </a:r>
+          </a:p>
+          <a:p>
+            <a:pPr lvl="1"/>
+            <a:r>
+              <a:rPr lang="en-CA" dirty="0"/>
+              <a:t>How do you handle file paths in different projects?</a:t>
+            </a:r>
+          </a:p>
+          <a:p>
+            <a:pPr lvl="1"/>
+            <a:endParaRPr lang="en-CA" dirty="0"/>
+          </a:p>
+          <a:p>
+            <a:r>
+              <a:rPr lang="en-CA" dirty="0"/>
+              <a:t>“I already have all the packages installed”</a:t>
+            </a:r>
+          </a:p>
+          <a:p>
+            <a:pPr lvl="1"/>
+            <a:r>
+              <a:rPr lang="en-CA" dirty="0"/>
+              <a:t>Can you ensure reproducibility?</a:t>
+            </a:r>
+          </a:p>
+          <a:p>
+            <a:pPr lvl="1"/>
+            <a:endParaRPr lang="en-CA" dirty="0"/>
+          </a:p>
+          <a:p>
+            <a:r>
+              <a:rPr lang="en-CA" dirty="0"/>
+              <a:t>“I still have features to add”</a:t>
+            </a:r>
+          </a:p>
+          <a:p>
+            <a:pPr lvl="1"/>
+            <a:r>
+              <a:rPr lang="en-CA" dirty="0"/>
+              <a:t>What if the code breaks? Will you know if it does?</a:t>
+            </a:r>
+          </a:p>
+          <a:p>
+            <a:pPr lvl="1"/>
+            <a:endParaRPr lang="en-CA" dirty="0"/>
+          </a:p>
+        </p:txBody>
+      </p:sp>
+    </p:spTree>
+    <p:extLst>
+      <p:ext uri="{BB962C8B-B14F-4D97-AF65-F5344CB8AC3E}">
+        <p14:creationId xmlns:p14="http://schemas.microsoft.com/office/powerpoint/2010/main" val="3567545301"/>
+      </p:ext>
+    </p:extLst>
+  </p:cSld>
+  <p:clrMapOvr>
+    <a:masterClrMapping/>
+  </p:clrMapOvr>
+  <p:timing>
+    <p:tnLst>
+      <p:par>
+        <p:cTn id="1" dur="indefinite" restart="never" nodeType="tmRoot">
+          <p:childTnLst>
+            <p:seq concurrent="1" nextAc="seek">
+              <p:cTn id="2" dur="indefinite" nodeType="mainSeq">
+                <p:childTnLst>
+                  <p:par>
+                    <p:cTn id="3" fill="hold">
+                      <p:stCondLst>
+                        <p:cond delay="indefinite"/>
+                      </p:stCondLst>
+                      <p:childTnLst>
+                        <p:par>
+                          <p:cTn id="4" fill="hold">
+                            <p:stCondLst>
+                              <p:cond delay="0"/>
+                            </p:stCondLst>
+                            <p:childTnLst>
+                              <p:par>
+                                <p:cTn id="5" presetID="1" presetClass="entr" presetSubtype="0" fill="hold" nodeType="clickEffect">
+                                  <p:stCondLst>
+                                    <p:cond delay="0"/>
+                                  </p:stCondLst>
+                                  <p:childTnLst>
+                                    <p:set>
+                                      <p:cBhvr>
+                                        <p:cTn id="6" dur="1" fill="hold">
+                                          <p:stCondLst>
+                                            <p:cond delay="0"/>
+                                          </p:stCondLst>
+                                        </p:cTn>
+                                        <p:tgtEl>
+                                          <p:spTgt spid="3">
+                                            <p:txEl>
+                                              <p:pRg st="1" end="1"/>
+                                            </p:txEl>
+                                          </p:spTgt>
+                                        </p:tgtEl>
+                                        <p:attrNameLst>
+                                          <p:attrName>style.visibility</p:attrName>
+                                        </p:attrNameLst>
+                                      </p:cBhvr>
+                                      <p:to>
+                                        <p:strVal val="visible"/>
+                                      </p:to>
+                                    </p:set>
+                                  </p:childTnLst>
+                                </p:cTn>
+                              </p:par>
+                            </p:childTnLst>
+                          </p:cTn>
+                        </p:par>
+                      </p:childTnLst>
+                    </p:cTn>
+                  </p:par>
+                  <p:par>
+                    <p:cTn id="7" fill="hold">
+                      <p:stCondLst>
+                        <p:cond delay="indefinite"/>
+                      </p:stCondLst>
+                      <p:childTnLst>
+                        <p:par>
+                          <p:cTn id="8" fill="hold">
+                            <p:stCondLst>
+                              <p:cond delay="0"/>
+                            </p:stCondLst>
+                            <p:childTnLst>
+                              <p:par>
+                                <p:cTn id="9" presetID="1" presetClass="entr" presetSubtype="0" fill="hold" nodeType="clickEffect">
+                                  <p:stCondLst>
+                                    <p:cond delay="0"/>
+                                  </p:stCondLst>
+                                  <p:childTnLst>
+                                    <p:set>
+                                      <p:cBhvr>
+                                        <p:cTn id="10" dur="1" fill="hold">
+                                          <p:stCondLst>
+                                            <p:cond delay="0"/>
+                                          </p:stCondLst>
+                                        </p:cTn>
+                                        <p:tgtEl>
+                                          <p:spTgt spid="3">
+                                            <p:txEl>
+                                              <p:pRg st="4" end="4"/>
+                                            </p:txEl>
+                                          </p:spTgt>
+                                        </p:tgtEl>
+                                        <p:attrNameLst>
+                                          <p:attrName>style.visibility</p:attrName>
+                                        </p:attrNameLst>
+                                      </p:cBhvr>
+                                      <p:to>
+                                        <p:strVal val="visible"/>
+                                      </p:to>
+                                    </p:set>
+                                  </p:childTnLst>
+                                </p:cTn>
+                              </p:par>
+                            </p:childTnLst>
+                          </p:cTn>
+                        </p:par>
+                      </p:childTnLst>
+                    </p:cTn>
+                  </p:par>
+                  <p:par>
+                    <p:cTn id="11" fill="hold">
+                      <p:stCondLst>
+                        <p:cond delay="indefinite"/>
+                      </p:stCondLst>
+                      <p:childTnLst>
+                        <p:par>
+                          <p:cTn id="12" fill="hold">
+                            <p:stCondLst>
+                              <p:cond delay="0"/>
+                            </p:stCondLst>
+                            <p:childTnLst>
+                              <p:par>
+                                <p:cTn id="13" presetID="1" presetClass="entr" presetSubtype="0" fill="hold" nodeType="clickEffect">
+                                  <p:stCondLst>
+                                    <p:cond delay="0"/>
+                                  </p:stCondLst>
+                                  <p:childTnLst>
+                                    <p:set>
+                                      <p:cBhvr>
+                                        <p:cTn id="14" dur="1" fill="hold">
+                                          <p:stCondLst>
+                                            <p:cond delay="0"/>
+                                          </p:stCondLst>
+                                        </p:cTn>
+                                        <p:tgtEl>
+                                          <p:spTgt spid="3">
+                                            <p:txEl>
+                                              <p:pRg st="7" end="7"/>
+                                            </p:txEl>
+                                          </p:spTgt>
+                                        </p:tgtEl>
+                                        <p:attrNameLst>
+                                          <p:attrName>style.visibility</p:attrName>
+                                        </p:attrNameLst>
+                                      </p:cBhvr>
+                                      <p:to>
+                                        <p:strVal val="visible"/>
+                                      </p:to>
+                                    </p:set>
+                                  </p:childTnLst>
+                                </p:cTn>
+                              </p:par>
+                            </p:childTnLst>
+                          </p:cTn>
+                        </p:par>
+                      </p:childTnLst>
+                    </p:cTn>
+                  </p:par>
+                  <p:par>
+                    <p:cTn id="15" fill="hold">
+                      <p:stCondLst>
+                        <p:cond delay="indefinite"/>
+                      </p:stCondLst>
+                      <p:childTnLst>
+                        <p:par>
+                          <p:cTn id="16" fill="hold">
+                            <p:stCondLst>
+                              <p:cond delay="0"/>
+                            </p:stCondLst>
+                            <p:childTnLst>
+                              <p:par>
+                                <p:cTn id="17" presetID="1" presetClass="entr" presetSubtype="0" fill="hold" nodeType="clickEffect">
+                                  <p:stCondLst>
+                                    <p:cond delay="0"/>
+                                  </p:stCondLst>
+                                  <p:childTnLst>
+                                    <p:set>
+                                      <p:cBhvr>
+                                        <p:cTn id="18" dur="1" fill="hold">
+                                          <p:stCondLst>
+                                            <p:cond delay="0"/>
+                                          </p:stCondLst>
+                                        </p:cTn>
+                                        <p:tgtEl>
+                                          <p:spTgt spid="3">
+                                            <p:txEl>
+                                              <p:pRg st="10" end="10"/>
+                                            </p:txEl>
+                                          </p:spTgt>
+                                        </p:tgtEl>
+                                        <p:attrNameLst>
+                                          <p:attrName>style.visibility</p:attrName>
+                                        </p:attrNameLst>
+                                      </p:cBhvr>
+                                      <p:to>
+                                        <p:strVal val="visible"/>
+                                      </p:to>
+                                    </p:set>
+                                  </p:childTnLst>
+                                </p:cTn>
+                              </p:par>
+                            </p:childTnLst>
+                          </p:cTn>
+                        </p:par>
+                      </p:childTnLst>
+                    </p:cTn>
+                  </p:par>
+                </p:childTnLst>
+              </p:cTn>
+              <p:prevCondLst>
+                <p:cond evt="onPrev" delay="0">
+                  <p:tgtEl>
+                    <p:sldTgt/>
+                  </p:tgtEl>
+                </p:cond>
+              </p:prevCondLst>
+              <p:nextCondLst>
+                <p:cond evt="onNext" delay="0">
+                  <p:tgtEl>
+                    <p:sldTgt/>
+                  </p:tgtEl>
+                </p:cond>
+              </p:nextCondLst>
+            </p:seq>
+          </p:childTnLst>
+        </p:cTn>
+      </p:par>
+    </p:tnLst>
+  </p:timing>
+</p:sld>
+</file>
+
+<file path=ppt/slides/slide12.xml><?xml version="1.0" encoding="utf-8"?>
+<p:sld xmlns:a="http://schemas.openxmlformats.org/drawingml/2006/main" xmlns:r="http://schemas.openxmlformats.org/officeDocument/2006/relationships" xmlns:p="http://schemas.openxmlformats.org/presentationml/2006/main">
+  <p:cSld>
+    <p:spTree>
+      <p:nvGrpSpPr>
+        <p:cNvPr id="1" name=""/>
+        <p:cNvGrpSpPr/>
+        <p:nvPr/>
+      </p:nvGrpSpPr>
+      <p:grpSpPr>
+        <a:xfrm>
+          <a:off x="0" y="0"/>
+          <a:ext cx="0" cy="0"/>
+          <a:chOff x="0" y="0"/>
+          <a:chExt cx="0" cy="0"/>
+        </a:xfrm>
+      </p:grpSpPr>
+      <p:sp>
+        <p:nvSpPr>
+          <p:cNvPr id="2" name="Text Placeholder 1">
+            <a:extLst>
+              <a:ext uri="{FF2B5EF4-FFF2-40B4-BE49-F238E27FC236}">
+                <a16:creationId xmlns:a16="http://schemas.microsoft.com/office/drawing/2014/main" id="{9B245876-087E-37FF-2A45-491803B93EF5}"/>
+              </a:ext>
+            </a:extLst>
+          </p:cNvPr>
+          <p:cNvSpPr>
+            <a:spLocks noGrp="1"/>
+          </p:cNvSpPr>
+          <p:nvPr>
+            <p:ph type="body" sz="quarter" idx="10"/>
+          </p:nvPr>
+        </p:nvSpPr>
+        <p:spPr>
+          <a:xfrm>
+            <a:off x="242372" y="2940626"/>
+            <a:ext cx="8658743" cy="3437951"/>
+          </a:xfrm>
+        </p:spPr>
+        <p:txBody>
+          <a:bodyPr>
+            <a:normAutofit/>
+          </a:bodyPr>
+          <a:lstStyle/>
+          <a:p>
+            <a:r>
+              <a:rPr lang="en-CA" dirty="0"/>
+              <a:t>Explore the 1_Simple_Scripts folder 			     (open the project with the </a:t>
+            </a:r>
+            <a:r>
+              <a:rPr lang="en-CA" i="1" dirty="0"/>
+              <a:t>1_Simple_Scripts.Rproj</a:t>
+            </a:r>
+            <a:r>
+              <a:rPr lang="en-CA" dirty="0"/>
+              <a:t> file)</a:t>
+            </a:r>
+          </a:p>
+          <a:p>
+            <a:endParaRPr lang="en-CA" dirty="0"/>
+          </a:p>
+          <a:p>
+            <a:r>
+              <a:rPr lang="en-CA" dirty="0"/>
+              <a:t>Try running the code</a:t>
+            </a:r>
+          </a:p>
+          <a:p>
+            <a:endParaRPr lang="en-CA" dirty="0"/>
+          </a:p>
+          <a:p>
+            <a:r>
+              <a:rPr lang="en-CA" dirty="0"/>
+              <a:t>What would happen if you wanted to run this in a different folder?</a:t>
+            </a:r>
+          </a:p>
+        </p:txBody>
+      </p:sp>
+      <p:sp>
+        <p:nvSpPr>
+          <p:cNvPr id="3" name="Title 1">
+            <a:extLst>
+              <a:ext uri="{FF2B5EF4-FFF2-40B4-BE49-F238E27FC236}">
+                <a16:creationId xmlns:a16="http://schemas.microsoft.com/office/drawing/2014/main" id="{D0AE3FC0-C652-C431-6A10-987A06B22130}"/>
+              </a:ext>
+            </a:extLst>
+          </p:cNvPr>
+          <p:cNvSpPr txBox="1">
+            <a:spLocks/>
+          </p:cNvSpPr>
+          <p:nvPr/>
+        </p:nvSpPr>
+        <p:spPr>
+          <a:xfrm>
+            <a:off x="242372" y="1558637"/>
+            <a:ext cx="8658743" cy="1007918"/>
+          </a:xfrm>
+          <a:prstGeom prst="rect">
+            <a:avLst/>
+          </a:prstGeom>
+        </p:spPr>
+        <p:txBody>
+          <a:bodyPr>
+            <a:noAutofit/>
+          </a:bodyPr>
+          <a:lstStyle>
+            <a:lvl1pPr algn="l" defTabSz="914175" rtl="0" eaLnBrk="1" latinLnBrk="0" hangingPunct="1">
+              <a:lnSpc>
+                <a:spcPct val="90000"/>
+              </a:lnSpc>
+              <a:spcBef>
+                <a:spcPct val="0"/>
+              </a:spcBef>
+              <a:buNone/>
+              <a:defRPr sz="4403" kern="1200">
+                <a:solidFill>
+                  <a:schemeClr val="tx1"/>
+                </a:solidFill>
+                <a:latin typeface="+mj-lt"/>
+                <a:ea typeface="+mj-ea"/>
+                <a:cs typeface="+mj-cs"/>
+              </a:defRPr>
+            </a:lvl1pPr>
+          </a:lstStyle>
+          <a:p>
+            <a:pPr algn="ctr"/>
+            <a:r>
+              <a:rPr lang="en-CA" sz="7200" dirty="0"/>
+              <a:t>Exercise</a:t>
+            </a:r>
+          </a:p>
+        </p:txBody>
+      </p:sp>
+    </p:spTree>
+    <p:extLst>
+      <p:ext uri="{BB962C8B-B14F-4D97-AF65-F5344CB8AC3E}">
+        <p14:creationId xmlns:p14="http://schemas.microsoft.com/office/powerpoint/2010/main" val="680839714"/>
+      </p:ext>
+    </p:extLst>
+  </p:cSld>
+  <p:clrMapOvr>
+    <a:masterClrMapping/>
+  </p:clrMapOvr>
+</p:sld>
+</file>
+
+<file path=ppt/slides/slide13.xml><?xml version="1.0" encoding="utf-8"?>
+<p:sld xmlns:a="http://schemas.openxmlformats.org/drawingml/2006/main" xmlns:r="http://schemas.openxmlformats.org/officeDocument/2006/relationships" xmlns:p="http://schemas.openxmlformats.org/presentationml/2006/main">
+  <p:cSld>
+    <p:spTree>
+      <p:nvGrpSpPr>
+        <p:cNvPr id="1" name=""/>
+        <p:cNvGrpSpPr/>
+        <p:nvPr/>
+      </p:nvGrpSpPr>
+      <p:grpSpPr>
+        <a:xfrm>
+          <a:off x="0" y="0"/>
+          <a:ext cx="0" cy="0"/>
+          <a:chOff x="0" y="0"/>
+          <a:chExt cx="0" cy="0"/>
+        </a:xfrm>
+      </p:grpSpPr>
+      <p:sp>
+        <p:nvSpPr>
+          <p:cNvPr id="2" name="Title 1">
+            <a:extLst>
+              <a:ext uri="{FF2B5EF4-FFF2-40B4-BE49-F238E27FC236}">
+                <a16:creationId xmlns:a16="http://schemas.microsoft.com/office/drawing/2014/main" id="{22643326-375A-A79A-4BC9-E08429337A85}"/>
+              </a:ext>
+            </a:extLst>
+          </p:cNvPr>
+          <p:cNvSpPr>
+            <a:spLocks noGrp="1"/>
+          </p:cNvSpPr>
+          <p:nvPr>
+            <p:ph type="title"/>
+          </p:nvPr>
+        </p:nvSpPr>
+        <p:spPr/>
+        <p:txBody>
+          <a:bodyPr/>
+          <a:lstStyle/>
+          <a:p>
+            <a:r>
+              <a:rPr lang="en-US" dirty="0"/>
+              <a:t>What is a package?</a:t>
+            </a:r>
+          </a:p>
+        </p:txBody>
+      </p:sp>
+      <p:sp>
+        <p:nvSpPr>
+          <p:cNvPr id="3" name="Content Placeholder 2">
+            <a:extLst>
+              <a:ext uri="{FF2B5EF4-FFF2-40B4-BE49-F238E27FC236}">
+                <a16:creationId xmlns:a16="http://schemas.microsoft.com/office/drawing/2014/main" id="{ACB875C8-BD73-F266-4045-06FC436A35AA}"/>
+              </a:ext>
+            </a:extLst>
+          </p:cNvPr>
+          <p:cNvSpPr>
+            <a:spLocks noGrp="1"/>
+          </p:cNvSpPr>
+          <p:nvPr>
+            <p:ph sz="half" idx="1"/>
+          </p:nvPr>
+        </p:nvSpPr>
+        <p:spPr>
+          <a:xfrm>
+            <a:off x="628649" y="1825627"/>
+            <a:ext cx="4743451" cy="4907682"/>
+          </a:xfrm>
+        </p:spPr>
+        <p:txBody>
+          <a:bodyPr>
+            <a:normAutofit/>
+          </a:bodyPr>
+          <a:lstStyle/>
+          <a:p>
+            <a:r>
+              <a:rPr lang="en-CA" dirty="0"/>
+              <a:t>Set of reusable functions</a:t>
+            </a:r>
+          </a:p>
+          <a:p>
+            <a:endParaRPr lang="en-CA" dirty="0"/>
+          </a:p>
+          <a:p>
+            <a:r>
+              <a:rPr lang="en-CA" dirty="0"/>
+              <a:t>Standardized formatting</a:t>
+            </a:r>
+          </a:p>
+          <a:p>
+            <a:r>
+              <a:rPr lang="en-CA" dirty="0"/>
+              <a:t>No file path needed</a:t>
+            </a:r>
+          </a:p>
+          <a:p>
+            <a:endParaRPr lang="en-CA" dirty="0"/>
+          </a:p>
+          <a:p>
+            <a:r>
+              <a:rPr lang="en-CA" dirty="0"/>
+              <a:t>Facilitates installation</a:t>
+            </a:r>
+          </a:p>
+          <a:p>
+            <a:r>
+              <a:rPr lang="en-CA" dirty="0"/>
+              <a:t>Automates dependencies</a:t>
+            </a:r>
+          </a:p>
+          <a:p>
+            <a:r>
+              <a:rPr lang="en-CA" dirty="0"/>
+              <a:t>Easy documentation interface</a:t>
+            </a:r>
+          </a:p>
+        </p:txBody>
+      </p:sp>
+      <p:pic>
+        <p:nvPicPr>
+          <p:cNvPr id="1028" name="Picture 4" descr="Top 9 R packages (that every Data Scientist must know)">
+            <a:extLst>
+              <a:ext uri="{FF2B5EF4-FFF2-40B4-BE49-F238E27FC236}">
+                <a16:creationId xmlns:a16="http://schemas.microsoft.com/office/drawing/2014/main" id="{C0119C7F-7394-3714-73BC-BFB0C9254886}"/>
+              </a:ext>
+            </a:extLst>
+          </p:cNvPr>
+          <p:cNvPicPr>
+            <a:picLocks noChangeAspect="1" noChangeArrowheads="1"/>
+          </p:cNvPicPr>
+          <p:nvPr/>
+        </p:nvPicPr>
+        <p:blipFill>
+          <a:blip r:embed="rId2">
+            <a:extLst>
+              <a:ext uri="{28A0092B-C50C-407E-A947-70E740481C1C}">
+                <a14:useLocalDpi xmlns:a14="http://schemas.microsoft.com/office/drawing/2010/main" val="0"/>
+              </a:ext>
+            </a:extLst>
+          </a:blip>
+          <a:srcRect/>
+          <a:stretch>
+            <a:fillRect/>
+          </a:stretch>
+        </p:blipFill>
+        <p:spPr bwMode="auto">
+          <a:xfrm>
+            <a:off x="4653173" y="2432497"/>
+            <a:ext cx="4355359" cy="2388643"/>
+          </a:xfrm>
+          <a:prstGeom prst="rect">
+            <a:avLst/>
+          </a:prstGeom>
+          <a:noFill/>
+          <a:extLst>
+            <a:ext uri="{909E8E84-426E-40DD-AFC4-6F175D3DCCD1}">
+              <a14:hiddenFill xmlns:a14="http://schemas.microsoft.com/office/drawing/2010/main">
+                <a:solidFill>
+                  <a:srgbClr val="FFFFFF"/>
+                </a:solidFill>
+              </a14:hiddenFill>
+            </a:ext>
+          </a:extLst>
+        </p:spPr>
+      </p:pic>
+      <p:pic>
+        <p:nvPicPr>
+          <p:cNvPr id="5" name="Picture 4">
+            <a:extLst>
+              <a:ext uri="{FF2B5EF4-FFF2-40B4-BE49-F238E27FC236}">
+                <a16:creationId xmlns:a16="http://schemas.microsoft.com/office/drawing/2014/main" id="{EA0355F1-DDBE-FD70-D0E2-5E76497DC699}"/>
+              </a:ext>
+            </a:extLst>
+          </p:cNvPr>
+          <p:cNvPicPr>
+            <a:picLocks noChangeAspect="1"/>
+          </p:cNvPicPr>
+          <p:nvPr/>
+        </p:nvPicPr>
+        <p:blipFill>
+          <a:blip r:embed="rId3"/>
+          <a:srcRect l="19390" t="43434" r="16684" b="37472"/>
+          <a:stretch>
+            <a:fillRect/>
+          </a:stretch>
+        </p:blipFill>
+        <p:spPr>
+          <a:xfrm>
+            <a:off x="893617" y="5849418"/>
+            <a:ext cx="4213514" cy="883891"/>
+          </a:xfrm>
+          <a:prstGeom prst="rect">
+            <a:avLst/>
+          </a:prstGeom>
+        </p:spPr>
+      </p:pic>
+    </p:spTree>
+    <p:extLst>
+      <p:ext uri="{BB962C8B-B14F-4D97-AF65-F5344CB8AC3E}">
+        <p14:creationId xmlns:p14="http://schemas.microsoft.com/office/powerpoint/2010/main" val="4107645974"/>
+      </p:ext>
+    </p:extLst>
+  </p:cSld>
+  <p:clrMapOvr>
+    <a:masterClrMapping/>
+  </p:clrMapOvr>
+</p:sld>
+</file>
+
 <file path=ppt/slides/slide14.xml><?xml version="1.0" encoding="utf-8"?>
 <p:sld xmlns:a="http://schemas.openxmlformats.org/drawingml/2006/main" xmlns:r="http://schemas.openxmlformats.org/officeDocument/2006/relationships" xmlns:p="http://schemas.openxmlformats.org/presentationml/2006/main">
   <p:cSld>
@@ -7947,13 +7514,13 @@
         </p:nvSpPr>
         <p:spPr>
           <a:xfrm>
-            <a:off x="242372" y="2639291"/>
+            <a:off x="242372" y="2389909"/>
             <a:ext cx="8658743" cy="4031673"/>
           </a:xfrm>
         </p:spPr>
         <p:txBody>
           <a:bodyPr>
-            <a:normAutofit fontScale="85000" lnSpcReduction="20000"/>
+            <a:normAutofit fontScale="92500" lnSpcReduction="20000"/>
           </a:bodyPr>
           <a:lstStyle/>
           <a:p>
@@ -7964,13 +7531,6 @@
             <a:r>
               <a:rPr lang="en-US" dirty="0"/>
               <a:t>Create a new R project a select the package template</a:t>
-            </a:r>
-          </a:p>
-          <a:p>
-            <a:pPr lvl="1"/>
-            <a:r>
-              <a:rPr lang="en-US" dirty="0"/>
-              <a:t>Include roxygen2 option</a:t>
             </a:r>
           </a:p>
           <a:p>
@@ -8074,7 +7634,7 @@
         </p:nvSpPr>
         <p:spPr>
           <a:xfrm>
-            <a:off x="242372" y="1558637"/>
+            <a:off x="242372" y="1444337"/>
             <a:ext cx="8658743" cy="1007918"/>
           </a:xfrm>
           <a:prstGeom prst="rect">
@@ -8288,7 +7848,7 @@
         </p:blipFill>
         <p:spPr>
           <a:xfrm>
-            <a:off x="7562229" y="0"/>
+            <a:off x="7338828" y="160616"/>
             <a:ext cx="1581771" cy="1825627"/>
           </a:xfrm>
           <a:prstGeom prst="rect">
@@ -10504,13 +10064,8 @@
             <a:pPr lvl="1"/>
             <a:r>
               <a:rPr lang="en-US" dirty="0"/>
-              <a:t>Helps ensure sufficiently correct </a:t>
-            </a:r>
-            <a:r>
-              <a:rPr lang="en-US" dirty="0" err="1"/>
-              <a:t>behaviour</a:t>
-            </a:r>
-            <a:endParaRPr lang="en-US" dirty="0"/>
+              <a:t>Helps ensure sufficiently correct behaviour</a:t>
+            </a:r>
           </a:p>
           <a:p>
             <a:pPr lvl="1"/>
@@ -10562,7 +10117,7 @@
         </p:blipFill>
         <p:spPr>
           <a:xfrm>
-            <a:off x="7211291" y="4465493"/>
+            <a:off x="7338580" y="4605771"/>
             <a:ext cx="1805420" cy="1805420"/>
           </a:xfrm>
           <a:prstGeom prst="rect">
@@ -10634,7 +10189,7 @@
           <a:p>
             <a:r>
               <a:rPr lang="en-US" dirty="0"/>
-              <a:t>2. Git Refresher</a:t>
+              <a:t>0. Git Refresher</a:t>
             </a:r>
           </a:p>
         </p:txBody>
@@ -10976,8 +10531,8 @@
         </p:blipFill>
         <p:spPr>
           <a:xfrm>
-            <a:off x="3135303" y="4707082"/>
-            <a:ext cx="2652432" cy="2049607"/>
+            <a:off x="3283221" y="4821382"/>
+            <a:ext cx="2504514" cy="1935307"/>
           </a:xfrm>
           <a:prstGeom prst="rect">
             <a:avLst/>
@@ -19799,7 +19354,7 @@
           <a:p>
             <a:r>
               <a:rPr lang="en-US" dirty="0"/>
-              <a:t>3. GitHub Actions</a:t>
+              <a:t>2. GitHub Actions</a:t>
             </a:r>
           </a:p>
         </p:txBody>
@@ -20892,15 +20447,7 @@
           <a:p>
             <a:r>
               <a:rPr lang="en-CA" dirty="0"/>
-              <a:t>In your own fork of the </a:t>
-            </a:r>
-            <a:r>
-              <a:rPr lang="en-CA" dirty="0" err="1"/>
-              <a:t>github</a:t>
-            </a:r>
-            <a:r>
-              <a:rPr lang="en-CA" dirty="0"/>
-              <a:t> repository, make a change to files in the 3_Actions_Package folder</a:t>
+              <a:t>In your own fork of the GitHub repository, make a change to files in the 3_Actions_Package folder</a:t>
             </a:r>
           </a:p>
           <a:p>
@@ -21913,14 +21460,14 @@
             <a:pPr lvl="1"/>
             <a:r>
               <a:rPr lang="en-US" dirty="0"/>
+              <a:t>Handling Issues &amp; Pull requests</a:t>
+            </a:r>
+          </a:p>
+          <a:p>
+            <a:pPr lvl="1"/>
+            <a:r>
+              <a:rPr lang="en-US" dirty="0"/>
               <a:t>Installation &amp; Testing workflow</a:t>
-            </a:r>
-          </a:p>
-          <a:p>
-            <a:pPr lvl="1"/>
-            <a:r>
-              <a:rPr lang="en-US" dirty="0"/>
-              <a:t>Handling Issues &amp; Pull requests</a:t>
             </a:r>
           </a:p>
         </p:txBody>
@@ -22404,7 +21951,7 @@
           <p:cNvPr id="2" name="Title 1">
             <a:extLst>
               <a:ext uri="{FF2B5EF4-FFF2-40B4-BE49-F238E27FC236}">
-                <a16:creationId xmlns:a16="http://schemas.microsoft.com/office/drawing/2014/main" id="{931D2992-2D2C-03B2-20A7-FA3CFD5F72E8}"/>
+                <a16:creationId xmlns:a16="http://schemas.microsoft.com/office/drawing/2014/main" id="{98205D2F-58F2-9087-C234-C1A51D2DE352}"/>
               </a:ext>
             </a:extLst>
           </p:cNvPr>
@@ -22422,7 +21969,15 @@
           <a:p>
             <a:r>
               <a:rPr lang="en-CA" dirty="0"/>
-              <a:t>Why bother with packages?</a:t>
+              <a:t>Today’s Example: </a:t>
+            </a:r>
+            <a:r>
+              <a:rPr lang="en-CA" dirty="0" err="1"/>
+              <a:t>bioNMF</a:t>
+            </a:r>
+            <a:r>
+              <a:rPr lang="en-CA" dirty="0"/>
+              <a:t> Package</a:t>
             </a:r>
           </a:p>
         </p:txBody>
@@ -22432,7 +21987,7 @@
           <p:cNvPr id="3" name="Content Placeholder 2">
             <a:extLst>
               <a:ext uri="{FF2B5EF4-FFF2-40B4-BE49-F238E27FC236}">
-                <a16:creationId xmlns:a16="http://schemas.microsoft.com/office/drawing/2014/main" id="{F9D67DD5-AD34-86CF-5CE0-F971881A1045}"/>
+                <a16:creationId xmlns:a16="http://schemas.microsoft.com/office/drawing/2014/main" id="{E5040FA8-5BD8-7184-15EB-808A3AE6A056}"/>
               </a:ext>
             </a:extLst>
           </p:cNvPr>
@@ -22445,84 +22000,162 @@
         </p:nvSpPr>
         <p:spPr/>
         <p:txBody>
-          <a:bodyPr>
-            <a:normAutofit lnSpcReduction="10000"/>
-          </a:bodyPr>
+          <a:bodyPr/>
           <a:lstStyle/>
           <a:p>
             <a:r>
               <a:rPr lang="en-CA" dirty="0"/>
-              <a:t>“Works on my machine”</a:t>
-            </a:r>
-          </a:p>
-          <a:p>
-            <a:pPr lvl="1"/>
+              <a:t>We will be working on a </a:t>
+            </a:r>
+            <a:r>
+              <a:rPr lang="en-CA" b="1" dirty="0"/>
+              <a:t>non-negative matrix factorization (NMF)</a:t>
+            </a:r>
             <a:r>
               <a:rPr lang="en-CA" dirty="0"/>
-              <a:t>What about other users?</a:t>
-            </a:r>
-          </a:p>
-          <a:p>
-            <a:pPr lvl="1"/>
+              <a:t> package</a:t>
+            </a:r>
+          </a:p>
+          <a:p>
+            <a:r>
+              <a:rPr lang="en-CA" dirty="0"/>
+              <a:t>NMF decomposes data into </a:t>
+            </a:r>
+            <a:r>
+              <a:rPr lang="en-CA" b="1" dirty="0"/>
+              <a:t>clusters </a:t>
+            </a:r>
+            <a:r>
+              <a:rPr lang="en-CA" dirty="0"/>
+              <a:t>(r dimension)</a:t>
+            </a:r>
+          </a:p>
+          <a:p>
+            <a:r>
+              <a:rPr lang="en-CA" dirty="0"/>
+              <a:t>Common for count data (gene expression)</a:t>
+            </a:r>
+          </a:p>
+          <a:p>
             <a:endParaRPr lang="en-CA" dirty="0"/>
           </a:p>
           <a:p>
             <a:r>
               <a:rPr lang="en-CA" dirty="0"/>
-              <a:t>“Using different scripts with source() is enough”</a:t>
-            </a:r>
-          </a:p>
-          <a:p>
-            <a:pPr lvl="1"/>
+              <a:t>Samples (patients) – n</a:t>
+            </a:r>
+          </a:p>
+          <a:p>
             <a:r>
               <a:rPr lang="en-CA" dirty="0"/>
-              <a:t>How do you handle file paths in different projects?</a:t>
-            </a:r>
-          </a:p>
-          <a:p>
-            <a:pPr lvl="1"/>
+              <a:t>Features (genes) – p</a:t>
+            </a:r>
+          </a:p>
+          <a:p>
+            <a:r>
+              <a:rPr lang="en-CA" dirty="0"/>
+              <a:t>Clusters (programs) – r</a:t>
+            </a:r>
+          </a:p>
+          <a:p>
             <a:endParaRPr lang="en-CA" dirty="0"/>
           </a:p>
-          <a:p>
-            <a:r>
-              <a:rPr lang="en-CA" dirty="0"/>
-              <a:t>“I already have all the packages installed”</a:t>
-            </a:r>
-          </a:p>
-          <a:p>
-            <a:pPr lvl="1"/>
-            <a:r>
-              <a:rPr lang="en-CA" dirty="0"/>
-              <a:t>Can you ensure reproducibility?</a:t>
-            </a:r>
-          </a:p>
-          <a:p>
-            <a:pPr lvl="1"/>
-            <a:endParaRPr lang="en-CA" dirty="0"/>
-          </a:p>
-          <a:p>
-            <a:r>
-              <a:rPr lang="en-CA" dirty="0"/>
-              <a:t>“I still have features to add”</a:t>
-            </a:r>
-          </a:p>
-          <a:p>
-            <a:pPr lvl="1"/>
-            <a:r>
-              <a:rPr lang="en-CA" dirty="0"/>
-              <a:t>What if the code breaks? Will you know if it does?</a:t>
-            </a:r>
-          </a:p>
-          <a:p>
-            <a:pPr lvl="1"/>
-            <a:endParaRPr lang="en-CA" dirty="0"/>
-          </a:p>
-        </p:txBody>
-      </p:sp>
+        </p:txBody>
+      </p:sp>
+      <p:grpSp>
+        <p:nvGrpSpPr>
+          <p:cNvPr id="6" name="Group 5">
+            <a:extLst>
+              <a:ext uri="{FF2B5EF4-FFF2-40B4-BE49-F238E27FC236}">
+                <a16:creationId xmlns:a16="http://schemas.microsoft.com/office/drawing/2014/main" id="{55CF7EE0-9283-0D3D-0FF8-DB1D3BE0E505}"/>
+              </a:ext>
+            </a:extLst>
+          </p:cNvPr>
+          <p:cNvGrpSpPr/>
+          <p:nvPr/>
+        </p:nvGrpSpPr>
+        <p:grpSpPr>
+          <a:xfrm>
+            <a:off x="4416137" y="3844636"/>
+            <a:ext cx="4613564" cy="3013364"/>
+            <a:chOff x="824012" y="3674928"/>
+            <a:chExt cx="3935816" cy="2214411"/>
+          </a:xfrm>
+        </p:grpSpPr>
+        <p:pic>
+          <p:nvPicPr>
+            <p:cNvPr id="4" name="Picture 3" descr="Non-negative Matrix Factorization (Part 1): Understanding Its Importance  and Applications">
+              <a:extLst>
+                <a:ext uri="{FF2B5EF4-FFF2-40B4-BE49-F238E27FC236}">
+                  <a16:creationId xmlns:a16="http://schemas.microsoft.com/office/drawing/2014/main" id="{4A89B8C9-C236-A3EB-95C8-643E9A3C5CF1}"/>
+                </a:ext>
+              </a:extLst>
+            </p:cNvPr>
+            <p:cNvPicPr>
+              <a:picLocks noChangeAspect="1"/>
+            </p:cNvPicPr>
+            <p:nvPr/>
+          </p:nvPicPr>
+          <p:blipFill>
+            <a:blip r:embed="rId2"/>
+            <a:srcRect l="4525" r="4304"/>
+            <a:stretch>
+              <a:fillRect/>
+            </a:stretch>
+          </p:blipFill>
+          <p:spPr>
+            <a:xfrm>
+              <a:off x="824012" y="3674928"/>
+              <a:ext cx="3935816" cy="1782172"/>
+            </a:xfrm>
+            <a:prstGeom prst="rect">
+              <a:avLst/>
+            </a:prstGeom>
+          </p:spPr>
+        </p:pic>
+        <p:sp>
+          <p:nvSpPr>
+            <p:cNvPr id="5" name="TextBox 4">
+              <a:extLst>
+                <a:ext uri="{FF2B5EF4-FFF2-40B4-BE49-F238E27FC236}">
+                  <a16:creationId xmlns:a16="http://schemas.microsoft.com/office/drawing/2014/main" id="{EBB307C6-CD8E-A0BE-F92E-FBFC0373D618}"/>
+                </a:ext>
+              </a:extLst>
+            </p:cNvPr>
+            <p:cNvSpPr txBox="1"/>
+            <p:nvPr/>
+          </p:nvSpPr>
+          <p:spPr>
+            <a:xfrm>
+              <a:off x="2371518" y="5519879"/>
+              <a:ext cx="831272" cy="369460"/>
+            </a:xfrm>
+            <a:prstGeom prst="rect">
+              <a:avLst/>
+            </a:prstGeom>
+            <a:noFill/>
+          </p:spPr>
+          <p:txBody>
+            <a:bodyPr wrap="square" rtlCol="0">
+              <a:spAutoFit/>
+            </a:bodyPr>
+            <a:lstStyle/>
+            <a:p>
+              <a:r>
+                <a:rPr lang="en-CA" dirty="0">
+                  <a:hlinkClick r:id="rId3"/>
+                </a:rPr>
+                <a:t>Source</a:t>
+              </a:r>
+              <a:endParaRPr lang="en-CA" dirty="0"/>
+            </a:p>
+          </p:txBody>
+        </p:sp>
+      </p:grpSp>
     </p:spTree>
     <p:extLst>
       <p:ext uri="{BB962C8B-B14F-4D97-AF65-F5344CB8AC3E}">
-        <p14:creationId xmlns:p14="http://schemas.microsoft.com/office/powerpoint/2010/main" val="3567545301"/>
+        <p14:creationId xmlns:p14="http://schemas.microsoft.com/office/powerpoint/2010/main" val="998501193"/>
       </p:ext>
     </p:extLst>
   </p:cSld>

</xml_diff>

<commit_message>
Final edits to slides and exercise README files.
</commit_message>
<xml_diff>
--- a/Slides/RPackageDevelopment_Slides.pptx
+++ b/Slides/RPackageDevelopment_Slides.pptx
@@ -5,7 +5,7 @@
     <p:sldMasterId id="2147483660" r:id="rId1"/>
   </p:sldMasterIdLst>
   <p:notesMasterIdLst>
-    <p:notesMasterId r:id="rId52"/>
+    <p:notesMasterId r:id="rId53"/>
   </p:notesMasterIdLst>
   <p:sldIdLst>
     <p:sldId id="256" r:id="rId2"/>
@@ -18,8 +18,8 @@
     <p:sldId id="323" r:id="rId9"/>
     <p:sldId id="428" r:id="rId10"/>
     <p:sldId id="429" r:id="rId11"/>
-    <p:sldId id="450" r:id="rId12"/>
-    <p:sldId id="437" r:id="rId13"/>
+    <p:sldId id="437" r:id="rId12"/>
+    <p:sldId id="450" r:id="rId13"/>
     <p:sldId id="406" r:id="rId14"/>
     <p:sldId id="407" r:id="rId15"/>
     <p:sldId id="445" r:id="rId16"/>
@@ -54,10 +54,11 @@
     <p:sldId id="443" r:id="rId45"/>
     <p:sldId id="331" r:id="rId46"/>
     <p:sldId id="444" r:id="rId47"/>
-    <p:sldId id="433" r:id="rId48"/>
-    <p:sldId id="435" r:id="rId49"/>
-    <p:sldId id="411" r:id="rId50"/>
-    <p:sldId id="260" r:id="rId51"/>
+    <p:sldId id="451" r:id="rId48"/>
+    <p:sldId id="433" r:id="rId49"/>
+    <p:sldId id="435" r:id="rId50"/>
+    <p:sldId id="411" r:id="rId51"/>
+    <p:sldId id="260" r:id="rId52"/>
   </p:sldIdLst>
   <p:sldSz cx="9144000" cy="6858000" type="screen4x3"/>
   <p:notesSz cx="6858000" cy="9144000"/>
@@ -167,7 +168,7 @@
 <file path=ppt/revisionInfo.xml><?xml version="1.0" encoding="utf-8"?>
 <p1510:revInfo xmlns:a="http://schemas.openxmlformats.org/drawingml/2006/main" xmlns:r="http://schemas.openxmlformats.org/officeDocument/2006/relationships" xmlns:p1510="http://schemas.microsoft.com/office/powerpoint/2015/10/main">
   <p1510:revLst>
-    <p1510:client id="{7B91186F-AFD7-4556-9E93-756AA89B05D5}" v="65" dt="2026-08-14T14:52:08.480"/>
+    <p1510:client id="{7B91186F-AFD7-4556-9E93-756AA89B05D5}" v="2" dt="2026-08-18T13:19:47.145"/>
   </p1510:revLst>
 </p1510:revInfo>
 </file>
@@ -181,313 +182,61 @@
       <pc:docMkLst>
         <pc:docMk/>
       </pc:docMkLst>
-      <pc:sldChg chg="modSp add mod ord">
-        <pc:chgData name="Adrien Osakwe" userId="7a3e290c-eb83-484b-8e3d-d46ef2333477" providerId="ADAL" clId="{09ABE13D-32B9-4646-8B10-CB7999C84D02}" dt="2026-07-15T15:43:00.354" v="3307" actId="20577"/>
+    </pc:docChg>
+  </pc:docChgLst>
+  <pc:docChgLst>
+    <pc:chgData name="Adrien Osakwe" userId="7a3e290c-eb83-484b-8e3d-d46ef2333477" providerId="ADAL" clId="{516F4981-D9C8-4339-9685-B0B88EA45B28}"/>
+    <pc:docChg chg="undo custSel addSld delSld modSld sldOrd">
+      <pc:chgData name="Adrien Osakwe" userId="7a3e290c-eb83-484b-8e3d-d46ef2333477" providerId="ADAL" clId="{516F4981-D9C8-4339-9685-B0B88EA45B28}" dt="2026-08-18T14:44:11.560" v="9030"/>
+      <pc:docMkLst>
+        <pc:docMk/>
+      </pc:docMkLst>
+      <pc:sldChg chg="addSp delSp modSp mod">
+        <pc:chgData name="Adrien Osakwe" userId="7a3e290c-eb83-484b-8e3d-d46ef2333477" providerId="ADAL" clId="{516F4981-D9C8-4339-9685-B0B88EA45B28}" dt="2026-08-18T13:19:47.896" v="8513"/>
+        <pc:sldMkLst>
+          <pc:docMk/>
+          <pc:sldMk cId="3959237559" sldId="256"/>
+        </pc:sldMkLst>
+        <pc:spChg chg="add del mod">
+          <ac:chgData name="Adrien Osakwe" userId="7a3e290c-eb83-484b-8e3d-d46ef2333477" providerId="ADAL" clId="{516F4981-D9C8-4339-9685-B0B88EA45B28}" dt="2026-08-18T13:19:46.175" v="8510"/>
+          <ac:spMkLst>
+            <pc:docMk/>
+            <pc:sldMk cId="3959237559" sldId="256"/>
+            <ac:spMk id="5" creationId="{557AB8B0-BF59-1ADD-6AD2-DF60E60E1806}"/>
+          </ac:spMkLst>
+        </pc:spChg>
+        <pc:spChg chg="add del mod">
+          <ac:chgData name="Adrien Osakwe" userId="7a3e290c-eb83-484b-8e3d-d46ef2333477" providerId="ADAL" clId="{516F4981-D9C8-4339-9685-B0B88EA45B28}" dt="2026-08-18T13:19:47.896" v="8513"/>
+          <ac:spMkLst>
+            <pc:docMk/>
+            <pc:sldMk cId="3959237559" sldId="256"/>
+            <ac:spMk id="6" creationId="{27DB3380-7E41-3317-83D2-EBBB17A46FCA}"/>
+          </ac:spMkLst>
+        </pc:spChg>
+      </pc:sldChg>
+      <pc:sldChg chg="modSp mod">
+        <pc:chgData name="Adrien Osakwe" userId="7a3e290c-eb83-484b-8e3d-d46ef2333477" providerId="ADAL" clId="{516F4981-D9C8-4339-9685-B0B88EA45B28}" dt="2026-08-18T13:19:32.236" v="8507" actId="1076"/>
         <pc:sldMkLst>
           <pc:docMk/>
           <pc:sldMk cId="597855376" sldId="259"/>
         </pc:sldMkLst>
         <pc:spChg chg="mod">
-          <ac:chgData name="Adrien Osakwe" userId="7a3e290c-eb83-484b-8e3d-d46ef2333477" providerId="ADAL" clId="{09ABE13D-32B9-4646-8B10-CB7999C84D02}" dt="2026-07-15T15:43:00.354" v="3307" actId="20577"/>
+          <ac:chgData name="Adrien Osakwe" userId="7a3e290c-eb83-484b-8e3d-d46ef2333477" providerId="ADAL" clId="{516F4981-D9C8-4339-9685-B0B88EA45B28}" dt="2026-08-18T13:19:32.236" v="8507" actId="1076"/>
           <ac:spMkLst>
             <pc:docMk/>
             <pc:sldMk cId="597855376" sldId="259"/>
             <ac:spMk id="2" creationId="{10C0557F-5508-20BC-7CF6-DF79F9930C8B}"/>
           </ac:spMkLst>
         </pc:spChg>
-      </pc:sldChg>
-      <pc:sldChg chg="modSp add mod ord">
-        <pc:chgData name="Adrien Osakwe" userId="7a3e290c-eb83-484b-8e3d-d46ef2333477" providerId="ADAL" clId="{09ABE13D-32B9-4646-8B10-CB7999C84D02}" dt="2026-07-15T18:05:22.921" v="3312" actId="20577"/>
-        <pc:sldMkLst>
-          <pc:docMk/>
-          <pc:sldMk cId="4072911522" sldId="318"/>
-        </pc:sldMkLst>
         <pc:spChg chg="mod">
-          <ac:chgData name="Adrien Osakwe" userId="7a3e290c-eb83-484b-8e3d-d46ef2333477" providerId="ADAL" clId="{09ABE13D-32B9-4646-8B10-CB7999C84D02}" dt="2026-07-15T18:05:22.921" v="3312" actId="20577"/>
+          <ac:chgData name="Adrien Osakwe" userId="7a3e290c-eb83-484b-8e3d-d46ef2333477" providerId="ADAL" clId="{516F4981-D9C8-4339-9685-B0B88EA45B28}" dt="2026-08-18T13:19:22.640" v="8506" actId="6549"/>
           <ac:spMkLst>
             <pc:docMk/>
-            <pc:sldMk cId="4072911522" sldId="318"/>
-            <ac:spMk id="2" creationId="{2B830F0B-3D18-9732-3108-323F8DEEBA14}"/>
+            <pc:sldMk cId="597855376" sldId="259"/>
+            <ac:spMk id="3" creationId="{0FB63238-044F-8105-921A-4FF9DAABC623}"/>
           </ac:spMkLst>
         </pc:spChg>
       </pc:sldChg>
-      <pc:sldChg chg="addSp delSp modSp new mod">
-        <pc:chgData name="Adrien Osakwe" userId="7a3e290c-eb83-484b-8e3d-d46ef2333477" providerId="ADAL" clId="{09ABE13D-32B9-4646-8B10-CB7999C84D02}" dt="2026-07-15T15:46:41.284" v="3310" actId="14100"/>
-        <pc:sldMkLst>
-          <pc:docMk/>
-          <pc:sldMk cId="3587535936" sldId="320"/>
-        </pc:sldMkLst>
-        <pc:picChg chg="add mod">
-          <ac:chgData name="Adrien Osakwe" userId="7a3e290c-eb83-484b-8e3d-d46ef2333477" providerId="ADAL" clId="{09ABE13D-32B9-4646-8B10-CB7999C84D02}" dt="2026-07-15T15:46:41.284" v="3310" actId="14100"/>
-          <ac:picMkLst>
-            <pc:docMk/>
-            <pc:sldMk cId="3587535936" sldId="320"/>
-            <ac:picMk id="2" creationId="{2B557A83-72AC-9342-6D18-444AE41A1DB0}"/>
-          </ac:picMkLst>
-        </pc:picChg>
-      </pc:sldChg>
-      <pc:sldChg chg="modSp new mod">
-        <pc:chgData name="Adrien Osakwe" userId="7a3e290c-eb83-484b-8e3d-d46ef2333477" providerId="ADAL" clId="{09ABE13D-32B9-4646-8B10-CB7999C84D02}" dt="2026-07-15T14:51:10.692" v="1997" actId="20577"/>
-        <pc:sldMkLst>
-          <pc:docMk/>
-          <pc:sldMk cId="775350422" sldId="327"/>
-        </pc:sldMkLst>
-        <pc:spChg chg="mod">
-          <ac:chgData name="Adrien Osakwe" userId="7a3e290c-eb83-484b-8e3d-d46ef2333477" providerId="ADAL" clId="{09ABE13D-32B9-4646-8B10-CB7999C84D02}" dt="2026-07-15T14:51:10.692" v="1997" actId="20577"/>
-          <ac:spMkLst>
-            <pc:docMk/>
-            <pc:sldMk cId="775350422" sldId="327"/>
-            <ac:spMk id="3" creationId="{84AF7830-BAE2-3180-F8C1-9C534AA700C8}"/>
-          </ac:spMkLst>
-        </pc:spChg>
-      </pc:sldChg>
-      <pc:sldChg chg="addSp modSp new mod">
-        <pc:chgData name="Adrien Osakwe" userId="7a3e290c-eb83-484b-8e3d-d46ef2333477" providerId="ADAL" clId="{09ABE13D-32B9-4646-8B10-CB7999C84D02}" dt="2026-07-15T15:30:10.952" v="2730" actId="1037"/>
-        <pc:sldMkLst>
-          <pc:docMk/>
-          <pc:sldMk cId="393444062" sldId="329"/>
-        </pc:sldMkLst>
-        <pc:spChg chg="mod">
-          <ac:chgData name="Adrien Osakwe" userId="7a3e290c-eb83-484b-8e3d-d46ef2333477" providerId="ADAL" clId="{09ABE13D-32B9-4646-8B10-CB7999C84D02}" dt="2026-07-15T15:29:43.647" v="2719" actId="14100"/>
-          <ac:spMkLst>
-            <pc:docMk/>
-            <pc:sldMk cId="393444062" sldId="329"/>
-            <ac:spMk id="3" creationId="{7A8B01C4-F07D-5AFC-E80E-CFFC6E8449AA}"/>
-          </ac:spMkLst>
-        </pc:spChg>
-        <pc:picChg chg="add mod">
-          <ac:chgData name="Adrien Osakwe" userId="7a3e290c-eb83-484b-8e3d-d46ef2333477" providerId="ADAL" clId="{09ABE13D-32B9-4646-8B10-CB7999C84D02}" dt="2026-07-15T15:30:10.952" v="2730" actId="1037"/>
-          <ac:picMkLst>
-            <pc:docMk/>
-            <pc:sldMk cId="393444062" sldId="329"/>
-            <ac:picMk id="3074" creationId="{1BF0D96D-2C04-31BD-E443-6DBBF624B2A9}"/>
-          </ac:picMkLst>
-        </pc:picChg>
-      </pc:sldChg>
-      <pc:sldChg chg="modSp new mod">
-        <pc:chgData name="Adrien Osakwe" userId="7a3e290c-eb83-484b-8e3d-d46ef2333477" providerId="ADAL" clId="{09ABE13D-32B9-4646-8B10-CB7999C84D02}" dt="2026-07-15T15:34:33.295" v="3154" actId="5793"/>
-        <pc:sldMkLst>
-          <pc:docMk/>
-          <pc:sldMk cId="3227588993" sldId="330"/>
-        </pc:sldMkLst>
-        <pc:spChg chg="mod">
-          <ac:chgData name="Adrien Osakwe" userId="7a3e290c-eb83-484b-8e3d-d46ef2333477" providerId="ADAL" clId="{09ABE13D-32B9-4646-8B10-CB7999C84D02}" dt="2026-07-15T15:34:33.295" v="3154" actId="5793"/>
-          <ac:spMkLst>
-            <pc:docMk/>
-            <pc:sldMk cId="3227588993" sldId="330"/>
-            <ac:spMk id="3" creationId="{7DCCE7DF-BA51-40A0-87CD-24710734241B}"/>
-          </ac:spMkLst>
-        </pc:spChg>
-      </pc:sldChg>
-      <pc:sldChg chg="modSp new mod">
-        <pc:chgData name="Adrien Osakwe" userId="7a3e290c-eb83-484b-8e3d-d46ef2333477" providerId="ADAL" clId="{09ABE13D-32B9-4646-8B10-CB7999C84D02}" dt="2026-07-15T15:31:46.805" v="3059" actId="20577"/>
-        <pc:sldMkLst>
-          <pc:docMk/>
-          <pc:sldMk cId="3482164999" sldId="331"/>
-        </pc:sldMkLst>
-        <pc:spChg chg="mod">
-          <ac:chgData name="Adrien Osakwe" userId="7a3e290c-eb83-484b-8e3d-d46ef2333477" providerId="ADAL" clId="{09ABE13D-32B9-4646-8B10-CB7999C84D02}" dt="2026-07-15T15:31:46.805" v="3059" actId="20577"/>
-          <ac:spMkLst>
-            <pc:docMk/>
-            <pc:sldMk cId="3482164999" sldId="331"/>
-            <ac:spMk id="3" creationId="{EDBEC63F-928F-16B3-F9AA-1A86345569A5}"/>
-          </ac:spMkLst>
-        </pc:spChg>
-      </pc:sldChg>
-      <pc:sldChg chg="addSp delSp modSp new mod modClrScheme chgLayout">
-        <pc:chgData name="Adrien Osakwe" userId="7a3e290c-eb83-484b-8e3d-d46ef2333477" providerId="ADAL" clId="{09ABE13D-32B9-4646-8B10-CB7999C84D02}" dt="2026-07-15T15:39:56.190" v="3285" actId="1037"/>
-        <pc:sldMkLst>
-          <pc:docMk/>
-          <pc:sldMk cId="4107645974" sldId="406"/>
-        </pc:sldMkLst>
-        <pc:spChg chg="mod">
-          <ac:chgData name="Adrien Osakwe" userId="7a3e290c-eb83-484b-8e3d-d46ef2333477" providerId="ADAL" clId="{09ABE13D-32B9-4646-8B10-CB7999C84D02}" dt="2026-07-15T15:26:03.463" v="2536" actId="26606"/>
-          <ac:spMkLst>
-            <pc:docMk/>
-            <pc:sldMk cId="4107645974" sldId="406"/>
-            <ac:spMk id="2" creationId="{22643326-375A-A79A-4BC9-E08429337A85}"/>
-          </ac:spMkLst>
-        </pc:spChg>
-        <pc:spChg chg="add del">
-          <ac:chgData name="Adrien Osakwe" userId="7a3e290c-eb83-484b-8e3d-d46ef2333477" providerId="ADAL" clId="{09ABE13D-32B9-4646-8B10-CB7999C84D02}" dt="2026-07-15T15:26:03.463" v="2536" actId="26606"/>
-          <ac:spMkLst>
-            <pc:docMk/>
-            <pc:sldMk cId="4107645974" sldId="406"/>
-            <ac:spMk id="3" creationId="{ACB875C8-BD73-F266-4045-06FC436A35AA}"/>
-          </ac:spMkLst>
-        </pc:spChg>
-        <pc:picChg chg="add mod">
-          <ac:chgData name="Adrien Osakwe" userId="7a3e290c-eb83-484b-8e3d-d46ef2333477" providerId="ADAL" clId="{09ABE13D-32B9-4646-8B10-CB7999C84D02}" dt="2026-07-15T15:39:56.190" v="3285" actId="1037"/>
-          <ac:picMkLst>
-            <pc:docMk/>
-            <pc:sldMk cId="4107645974" sldId="406"/>
-            <ac:picMk id="1028" creationId="{C0119C7F-7394-3714-73BC-BFB0C9254886}"/>
-          </ac:picMkLst>
-        </pc:picChg>
-      </pc:sldChg>
-      <pc:sldChg chg="addSp delSp modSp new mod">
-        <pc:chgData name="Adrien Osakwe" userId="7a3e290c-eb83-484b-8e3d-d46ef2333477" providerId="ADAL" clId="{09ABE13D-32B9-4646-8B10-CB7999C84D02}" dt="2026-07-15T15:27:34.088" v="2550" actId="1076"/>
-        <pc:sldMkLst>
-          <pc:docMk/>
-          <pc:sldMk cId="159122328" sldId="407"/>
-        </pc:sldMkLst>
-        <pc:spChg chg="mod">
-          <ac:chgData name="Adrien Osakwe" userId="7a3e290c-eb83-484b-8e3d-d46ef2333477" providerId="ADAL" clId="{09ABE13D-32B9-4646-8B10-CB7999C84D02}" dt="2026-07-15T14:44:40.199" v="1647" actId="20577"/>
-          <ac:spMkLst>
-            <pc:docMk/>
-            <pc:sldMk cId="159122328" sldId="407"/>
-            <ac:spMk id="2" creationId="{FB0A71D6-6839-5BF1-8658-F5434E944637}"/>
-          </ac:spMkLst>
-        </pc:spChg>
-        <pc:picChg chg="add mod">
-          <ac:chgData name="Adrien Osakwe" userId="7a3e290c-eb83-484b-8e3d-d46ef2333477" providerId="ADAL" clId="{09ABE13D-32B9-4646-8B10-CB7999C84D02}" dt="2026-07-15T15:27:34.088" v="2550" actId="1076"/>
-          <ac:picMkLst>
-            <pc:docMk/>
-            <pc:sldMk cId="159122328" sldId="407"/>
-            <ac:picMk id="2050" creationId="{9CF5CCEC-6197-2DAD-9421-BAA0EB1C11E7}"/>
-          </ac:picMkLst>
-        </pc:picChg>
-      </pc:sldChg>
-      <pc:sldChg chg="modSp new mod">
-        <pc:chgData name="Adrien Osakwe" userId="7a3e290c-eb83-484b-8e3d-d46ef2333477" providerId="ADAL" clId="{09ABE13D-32B9-4646-8B10-CB7999C84D02}" dt="2026-07-15T14:45:04.695" v="1693" actId="20577"/>
-        <pc:sldMkLst>
-          <pc:docMk/>
-          <pc:sldMk cId="604635962" sldId="409"/>
-        </pc:sldMkLst>
-        <pc:spChg chg="mod">
-          <ac:chgData name="Adrien Osakwe" userId="7a3e290c-eb83-484b-8e3d-d46ef2333477" providerId="ADAL" clId="{09ABE13D-32B9-4646-8B10-CB7999C84D02}" dt="2026-07-15T14:45:04.695" v="1693" actId="20577"/>
-          <ac:spMkLst>
-            <pc:docMk/>
-            <pc:sldMk cId="604635962" sldId="409"/>
-            <ac:spMk id="2" creationId="{87B2031C-7CAB-319D-E348-1DE323D36DC9}"/>
-          </ac:spMkLst>
-        </pc:spChg>
-      </pc:sldChg>
-      <pc:sldChg chg="modSp new mod">
-        <pc:chgData name="Adrien Osakwe" userId="7a3e290c-eb83-484b-8e3d-d46ef2333477" providerId="ADAL" clId="{09ABE13D-32B9-4646-8B10-CB7999C84D02}" dt="2026-07-15T15:03:59.144" v="2526" actId="20577"/>
-        <pc:sldMkLst>
-          <pc:docMk/>
-          <pc:sldMk cId="981103045" sldId="410"/>
-        </pc:sldMkLst>
-        <pc:spChg chg="mod">
-          <ac:chgData name="Adrien Osakwe" userId="7a3e290c-eb83-484b-8e3d-d46ef2333477" providerId="ADAL" clId="{09ABE13D-32B9-4646-8B10-CB7999C84D02}" dt="2026-07-15T14:45:09.510" v="1707" actId="20577"/>
-          <ac:spMkLst>
-            <pc:docMk/>
-            <pc:sldMk cId="981103045" sldId="410"/>
-            <ac:spMk id="2" creationId="{0E3F8D0A-0BEA-604C-3AAC-1AB4A8B4EBF5}"/>
-          </ac:spMkLst>
-        </pc:spChg>
-        <pc:spChg chg="mod">
-          <ac:chgData name="Adrien Osakwe" userId="7a3e290c-eb83-484b-8e3d-d46ef2333477" providerId="ADAL" clId="{09ABE13D-32B9-4646-8B10-CB7999C84D02}" dt="2026-07-15T15:03:59.144" v="2526" actId="20577"/>
-          <ac:spMkLst>
-            <pc:docMk/>
-            <pc:sldMk cId="981103045" sldId="410"/>
-            <ac:spMk id="3" creationId="{311A497D-7B3A-420F-9347-CF4D7D0528AA}"/>
-          </ac:spMkLst>
-        </pc:spChg>
-      </pc:sldChg>
-      <pc:sldChg chg="addSp modSp new mod">
-        <pc:chgData name="Adrien Osakwe" userId="7a3e290c-eb83-484b-8e3d-d46ef2333477" providerId="ADAL" clId="{09ABE13D-32B9-4646-8B10-CB7999C84D02}" dt="2026-07-15T15:34:01.976" v="3152" actId="1076"/>
-        <pc:sldMkLst>
-          <pc:docMk/>
-          <pc:sldMk cId="2803926213" sldId="411"/>
-        </pc:sldMkLst>
-        <pc:spChg chg="mod">
-          <ac:chgData name="Adrien Osakwe" userId="7a3e290c-eb83-484b-8e3d-d46ef2333477" providerId="ADAL" clId="{09ABE13D-32B9-4646-8B10-CB7999C84D02}" dt="2026-07-15T14:58:35.748" v="2017" actId="1076"/>
-          <ac:spMkLst>
-            <pc:docMk/>
-            <pc:sldMk cId="2803926213" sldId="411"/>
-            <ac:spMk id="2" creationId="{AD828D01-6295-9CD0-A2A8-D520CA4A343F}"/>
-          </ac:spMkLst>
-        </pc:spChg>
-        <pc:spChg chg="add mod">
-          <ac:chgData name="Adrien Osakwe" userId="7a3e290c-eb83-484b-8e3d-d46ef2333477" providerId="ADAL" clId="{09ABE13D-32B9-4646-8B10-CB7999C84D02}" dt="2026-07-15T15:33:13.462" v="3127" actId="1076"/>
-          <ac:spMkLst>
-            <pc:docMk/>
-            <pc:sldMk cId="2803926213" sldId="411"/>
-            <ac:spMk id="5" creationId="{1186AD2E-30E2-4066-0067-9E12E0C232DB}"/>
-          </ac:spMkLst>
-        </pc:spChg>
-        <pc:spChg chg="add mod">
-          <ac:chgData name="Adrien Osakwe" userId="7a3e290c-eb83-484b-8e3d-d46ef2333477" providerId="ADAL" clId="{09ABE13D-32B9-4646-8B10-CB7999C84D02}" dt="2026-07-15T15:34:01.976" v="3152" actId="1076"/>
-          <ac:spMkLst>
-            <pc:docMk/>
-            <pc:sldMk cId="2803926213" sldId="411"/>
-            <ac:spMk id="7" creationId="{D2045168-AFC9-111D-EFD6-E702AAED7BC9}"/>
-          </ac:spMkLst>
-        </pc:spChg>
-        <pc:picChg chg="add mod">
-          <ac:chgData name="Adrien Osakwe" userId="7a3e290c-eb83-484b-8e3d-d46ef2333477" providerId="ADAL" clId="{09ABE13D-32B9-4646-8B10-CB7999C84D02}" dt="2026-07-15T14:58:38.410" v="2018" actId="1076"/>
-          <ac:picMkLst>
-            <pc:docMk/>
-            <pc:sldMk cId="2803926213" sldId="411"/>
-            <ac:picMk id="3" creationId="{D2BAEF11-DF57-F87B-0DE1-C7BE3199774C}"/>
-          </ac:picMkLst>
-        </pc:picChg>
-        <pc:picChg chg="add mod">
-          <ac:chgData name="Adrien Osakwe" userId="7a3e290c-eb83-484b-8e3d-d46ef2333477" providerId="ADAL" clId="{09ABE13D-32B9-4646-8B10-CB7999C84D02}" dt="2026-07-15T15:32:30.157" v="3064" actId="1076"/>
-          <ac:picMkLst>
-            <pc:docMk/>
-            <pc:sldMk cId="2803926213" sldId="411"/>
-            <ac:picMk id="4" creationId="{0A32D887-B248-C56F-D4CD-C76954C2A5EA}"/>
-          </ac:picMkLst>
-        </pc:picChg>
-        <pc:picChg chg="add mod">
-          <ac:chgData name="Adrien Osakwe" userId="7a3e290c-eb83-484b-8e3d-d46ef2333477" providerId="ADAL" clId="{09ABE13D-32B9-4646-8B10-CB7999C84D02}" dt="2026-07-15T15:33:41.462" v="3131" actId="1076"/>
-          <ac:picMkLst>
-            <pc:docMk/>
-            <pc:sldMk cId="2803926213" sldId="411"/>
-            <ac:picMk id="6" creationId="{2CF9868A-40A2-5F1C-8D2F-7B17D97E4850}"/>
-          </ac:picMkLst>
-        </pc:picChg>
-      </pc:sldChg>
-      <pc:sldChg chg="modSp new mod">
-        <pc:chgData name="Adrien Osakwe" userId="7a3e290c-eb83-484b-8e3d-d46ef2333477" providerId="ADAL" clId="{09ABE13D-32B9-4646-8B10-CB7999C84D02}" dt="2026-07-15T15:03:43.966" v="2516" actId="14100"/>
-        <pc:sldMkLst>
-          <pc:docMk/>
-          <pc:sldMk cId="3344907461" sldId="412"/>
-        </pc:sldMkLst>
-        <pc:spChg chg="mod">
-          <ac:chgData name="Adrien Osakwe" userId="7a3e290c-eb83-484b-8e3d-d46ef2333477" providerId="ADAL" clId="{09ABE13D-32B9-4646-8B10-CB7999C84D02}" dt="2026-07-15T15:03:43.966" v="2516" actId="14100"/>
-          <ac:spMkLst>
-            <pc:docMk/>
-            <pc:sldMk cId="3344907461" sldId="412"/>
-            <ac:spMk id="2" creationId="{4B34AF01-8823-1607-7201-0F853B265FB2}"/>
-          </ac:spMkLst>
-        </pc:spChg>
-        <pc:spChg chg="mod">
-          <ac:chgData name="Adrien Osakwe" userId="7a3e290c-eb83-484b-8e3d-d46ef2333477" providerId="ADAL" clId="{09ABE13D-32B9-4646-8B10-CB7999C84D02}" dt="2026-07-15T15:03:09.550" v="2477" actId="27636"/>
-          <ac:spMkLst>
-            <pc:docMk/>
-            <pc:sldMk cId="3344907461" sldId="412"/>
-            <ac:spMk id="3" creationId="{BE993682-CC01-929C-3DB9-F1AD75588C23}"/>
-          </ac:spMkLst>
-        </pc:spChg>
-      </pc:sldChg>
-      <pc:sldChg chg="modSp new mod">
-        <pc:chgData name="Adrien Osakwe" userId="7a3e290c-eb83-484b-8e3d-d46ef2333477" providerId="ADAL" clId="{09ABE13D-32B9-4646-8B10-CB7999C84D02}" dt="2026-07-15T15:00:00.348" v="2137" actId="20577"/>
-        <pc:sldMkLst>
-          <pc:docMk/>
-          <pc:sldMk cId="37029868" sldId="413"/>
-        </pc:sldMkLst>
-        <pc:spChg chg="mod">
-          <ac:chgData name="Adrien Osakwe" userId="7a3e290c-eb83-484b-8e3d-d46ef2333477" providerId="ADAL" clId="{09ABE13D-32B9-4646-8B10-CB7999C84D02}" dt="2026-07-15T15:00:00.348" v="2137" actId="20577"/>
-          <ac:spMkLst>
-            <pc:docMk/>
-            <pc:sldMk cId="37029868" sldId="413"/>
-            <ac:spMk id="2" creationId="{95DD492F-F80E-B379-EDEF-4B91DA7FE6C1}"/>
-          </ac:spMkLst>
-        </pc:spChg>
-      </pc:sldChg>
-    </pc:docChg>
-  </pc:docChgLst>
-  <pc:docChgLst>
-    <pc:chgData name="Adrien Osakwe" userId="7a3e290c-eb83-484b-8e3d-d46ef2333477" providerId="ADAL" clId="{516F4981-D9C8-4339-9685-B0B88EA45B28}"/>
-    <pc:docChg chg="undo custSel addSld delSld modSld sldOrd">
-      <pc:chgData name="Adrien Osakwe" userId="7a3e290c-eb83-484b-8e3d-d46ef2333477" providerId="ADAL" clId="{516F4981-D9C8-4339-9685-B0B88EA45B28}" dt="2026-08-14T15:07:57.734" v="8505" actId="313"/>
-      <pc:docMkLst>
-        <pc:docMk/>
-      </pc:docMkLst>
       <pc:sldChg chg="addSp delSp modSp mod">
         <pc:chgData name="Adrien Osakwe" userId="7a3e290c-eb83-484b-8e3d-d46ef2333477" providerId="ADAL" clId="{516F4981-D9C8-4339-9685-B0B88EA45B28}" dt="2026-08-11T03:41:06.934" v="695" actId="6549"/>
         <pc:sldMkLst>
@@ -729,13 +478,13 @@
         </pc:sldMkLst>
       </pc:sldChg>
       <pc:sldChg chg="addSp modSp mod">
-        <pc:chgData name="Adrien Osakwe" userId="7a3e290c-eb83-484b-8e3d-d46ef2333477" providerId="ADAL" clId="{516F4981-D9C8-4339-9685-B0B88EA45B28}" dt="2026-08-14T14:30:23.839" v="8452" actId="1076"/>
+        <pc:chgData name="Adrien Osakwe" userId="7a3e290c-eb83-484b-8e3d-d46ef2333477" providerId="ADAL" clId="{516F4981-D9C8-4339-9685-B0B88EA45B28}" dt="2026-08-18T13:31:09.856" v="8519" actId="113"/>
         <pc:sldMkLst>
           <pc:docMk/>
           <pc:sldMk cId="4107645974" sldId="406"/>
         </pc:sldMkLst>
         <pc:spChg chg="mod">
-          <ac:chgData name="Adrien Osakwe" userId="7a3e290c-eb83-484b-8e3d-d46ef2333477" providerId="ADAL" clId="{516F4981-D9C8-4339-9685-B0B88EA45B28}" dt="2026-08-14T14:30:19.854" v="8451" actId="14100"/>
+          <ac:chgData name="Adrien Osakwe" userId="7a3e290c-eb83-484b-8e3d-d46ef2333477" providerId="ADAL" clId="{516F4981-D9C8-4339-9685-B0B88EA45B28}" dt="2026-08-18T13:31:09.856" v="8519" actId="113"/>
           <ac:spMkLst>
             <pc:docMk/>
             <pc:sldMk cId="4107645974" sldId="406"/>
@@ -1193,8 +942,8 @@
           </ac:picMkLst>
         </pc:picChg>
       </pc:sldChg>
-      <pc:sldChg chg="addSp modSp new mod">
-        <pc:chgData name="Adrien Osakwe" userId="7a3e290c-eb83-484b-8e3d-d46ef2333477" providerId="ADAL" clId="{516F4981-D9C8-4339-9685-B0B88EA45B28}" dt="2026-08-14T13:56:29.847" v="8343" actId="114"/>
+      <pc:sldChg chg="addSp modSp new mod ord">
+        <pc:chgData name="Adrien Osakwe" userId="7a3e290c-eb83-484b-8e3d-d46ef2333477" providerId="ADAL" clId="{516F4981-D9C8-4339-9685-B0B88EA45B28}" dt="2026-08-18T13:24:21.082" v="8515"/>
         <pc:sldMkLst>
           <pc:docMk/>
           <pc:sldMk cId="680839714" sldId="437"/>
@@ -1285,13 +1034,13 @@
         </pc:spChg>
       </pc:sldChg>
       <pc:sldChg chg="modSp add mod">
-        <pc:chgData name="Adrien Osakwe" userId="7a3e290c-eb83-484b-8e3d-d46ef2333477" providerId="ADAL" clId="{516F4981-D9C8-4339-9685-B0B88EA45B28}" dt="2026-08-11T20:03:30.234" v="7051" actId="20577"/>
+        <pc:chgData name="Adrien Osakwe" userId="7a3e290c-eb83-484b-8e3d-d46ef2333477" providerId="ADAL" clId="{516F4981-D9C8-4339-9685-B0B88EA45B28}" dt="2026-08-18T14:27:41.175" v="8608" actId="20577"/>
         <pc:sldMkLst>
           <pc:docMk/>
           <pc:sldMk cId="2482499284" sldId="442"/>
         </pc:sldMkLst>
         <pc:spChg chg="mod">
-          <ac:chgData name="Adrien Osakwe" userId="7a3e290c-eb83-484b-8e3d-d46ef2333477" providerId="ADAL" clId="{516F4981-D9C8-4339-9685-B0B88EA45B28}" dt="2026-08-11T20:03:30.234" v="7051" actId="20577"/>
+          <ac:chgData name="Adrien Osakwe" userId="7a3e290c-eb83-484b-8e3d-d46ef2333477" providerId="ADAL" clId="{516F4981-D9C8-4339-9685-B0B88EA45B28}" dt="2026-08-18T14:27:41.175" v="8608" actId="20577"/>
           <ac:spMkLst>
             <pc:docMk/>
             <pc:sldMk cId="2482499284" sldId="442"/>
@@ -1413,6 +1162,29 @@
           </ac:spMkLst>
         </pc:spChg>
       </pc:sldChg>
+      <pc:sldChg chg="modSp new mod ord">
+        <pc:chgData name="Adrien Osakwe" userId="7a3e290c-eb83-484b-8e3d-d46ef2333477" providerId="ADAL" clId="{516F4981-D9C8-4339-9685-B0B88EA45B28}" dt="2026-08-18T14:44:11.560" v="9030"/>
+        <pc:sldMkLst>
+          <pc:docMk/>
+          <pc:sldMk cId="1171437104" sldId="451"/>
+        </pc:sldMkLst>
+        <pc:spChg chg="mod">
+          <ac:chgData name="Adrien Osakwe" userId="7a3e290c-eb83-484b-8e3d-d46ef2333477" providerId="ADAL" clId="{516F4981-D9C8-4339-9685-B0B88EA45B28}" dt="2026-08-18T14:42:23.330" v="8616" actId="20577"/>
+          <ac:spMkLst>
+            <pc:docMk/>
+            <pc:sldMk cId="1171437104" sldId="451"/>
+            <ac:spMk id="2" creationId="{02C00D68-F1C3-212D-8170-BA5F24E37452}"/>
+          </ac:spMkLst>
+        </pc:spChg>
+        <pc:spChg chg="mod">
+          <ac:chgData name="Adrien Osakwe" userId="7a3e290c-eb83-484b-8e3d-d46ef2333477" providerId="ADAL" clId="{516F4981-D9C8-4339-9685-B0B88EA45B28}" dt="2026-08-18T14:44:01.266" v="9028" actId="27636"/>
+          <ac:spMkLst>
+            <pc:docMk/>
+            <pc:sldMk cId="1171437104" sldId="451"/>
+            <ac:spMk id="3" creationId="{DF96A6F8-7B65-2672-7BE0-132DDF0CB76C}"/>
+          </ac:spMkLst>
+        </pc:spChg>
+      </pc:sldChg>
     </pc:docChg>
   </pc:docChgLst>
 </pc:chgInfo>
@@ -1500,7 +1272,7 @@
           <a:p>
             <a:fld id="{217E5156-1B5D-054E-B5B2-E1B1BA160252}" type="datetimeFigureOut">
               <a:rPr lang="fr-FR" smtClean="0"/>
-              <a:t>14/08/2026</a:t>
+              <a:t>18/08/2026</a:t>
             </a:fld>
             <a:endParaRPr lang="fr-FR"/>
           </a:p>
@@ -3628,7 +3400,7 @@
           <a:p>
             <a:fld id="{287C9ABC-0C1C-4801-85B9-12829D42DDA4}" type="datetimeFigureOut">
               <a:rPr lang="en-AU" smtClean="0"/>
-              <a:t>14/08/2026</a:t>
+              <a:t>18/08/2026</a:t>
             </a:fld>
             <a:endParaRPr lang="en-AU"/>
           </a:p>
@@ -6040,6 +5812,152 @@
       </p:grpSpPr>
       <p:sp>
         <p:nvSpPr>
+          <p:cNvPr id="2" name="Text Placeholder 1">
+            <a:extLst>
+              <a:ext uri="{FF2B5EF4-FFF2-40B4-BE49-F238E27FC236}">
+                <a16:creationId xmlns:a16="http://schemas.microsoft.com/office/drawing/2014/main" id="{9B245876-087E-37FF-2A45-491803B93EF5}"/>
+              </a:ext>
+            </a:extLst>
+          </p:cNvPr>
+          <p:cNvSpPr>
+            <a:spLocks noGrp="1"/>
+          </p:cNvSpPr>
+          <p:nvPr>
+            <p:ph type="body" sz="quarter" idx="10"/>
+          </p:nvPr>
+        </p:nvSpPr>
+        <p:spPr>
+          <a:xfrm>
+            <a:off x="242372" y="2940626"/>
+            <a:ext cx="8658743" cy="3437951"/>
+          </a:xfrm>
+        </p:spPr>
+        <p:txBody>
+          <a:bodyPr>
+            <a:normAutofit/>
+          </a:bodyPr>
+          <a:lstStyle/>
+          <a:p>
+            <a:r>
+              <a:rPr lang="en-CA" dirty="0"/>
+              <a:t>Explore the 1_Simple_Scripts folder 			     (open the project with the </a:t>
+            </a:r>
+            <a:r>
+              <a:rPr lang="en-CA" i="1" dirty="0"/>
+              <a:t>1_Simple_Scripts.Rproj</a:t>
+            </a:r>
+            <a:r>
+              <a:rPr lang="en-CA" dirty="0"/>
+              <a:t> file)</a:t>
+            </a:r>
+          </a:p>
+          <a:p>
+            <a:endParaRPr lang="en-CA" dirty="0"/>
+          </a:p>
+          <a:p>
+            <a:r>
+              <a:rPr lang="en-CA" dirty="0"/>
+              <a:t>Try running the code</a:t>
+            </a:r>
+          </a:p>
+          <a:p>
+            <a:endParaRPr lang="en-CA" dirty="0"/>
+          </a:p>
+          <a:p>
+            <a:r>
+              <a:rPr lang="en-CA" dirty="0"/>
+              <a:t>What would happen if you wanted to run this in a different folder?</a:t>
+            </a:r>
+          </a:p>
+        </p:txBody>
+      </p:sp>
+      <p:sp>
+        <p:nvSpPr>
+          <p:cNvPr id="3" name="Title 1">
+            <a:extLst>
+              <a:ext uri="{FF2B5EF4-FFF2-40B4-BE49-F238E27FC236}">
+                <a16:creationId xmlns:a16="http://schemas.microsoft.com/office/drawing/2014/main" id="{D0AE3FC0-C652-C431-6A10-987A06B22130}"/>
+              </a:ext>
+            </a:extLst>
+          </p:cNvPr>
+          <p:cNvSpPr txBox="1">
+            <a:spLocks/>
+          </p:cNvSpPr>
+          <p:nvPr/>
+        </p:nvSpPr>
+        <p:spPr>
+          <a:xfrm>
+            <a:off x="242372" y="1558637"/>
+            <a:ext cx="8658743" cy="1007918"/>
+          </a:xfrm>
+          <a:prstGeom prst="rect">
+            <a:avLst/>
+          </a:prstGeom>
+        </p:spPr>
+        <p:txBody>
+          <a:bodyPr>
+            <a:noAutofit/>
+          </a:bodyPr>
+          <a:lstStyle>
+            <a:lvl1pPr algn="l" defTabSz="914175" rtl="0" eaLnBrk="1" latinLnBrk="0" hangingPunct="1">
+              <a:lnSpc>
+                <a:spcPct val="90000"/>
+              </a:lnSpc>
+              <a:spcBef>
+                <a:spcPct val="0"/>
+              </a:spcBef>
+              <a:buNone/>
+              <a:defRPr sz="4403" kern="1200">
+                <a:solidFill>
+                  <a:schemeClr val="tx1"/>
+                </a:solidFill>
+                <a:latin typeface="+mj-lt"/>
+                <a:ea typeface="+mj-ea"/>
+                <a:cs typeface="+mj-cs"/>
+              </a:defRPr>
+            </a:lvl1pPr>
+          </a:lstStyle>
+          <a:p>
+            <a:pPr algn="ctr"/>
+            <a:r>
+              <a:rPr lang="en-CA" sz="7200" dirty="0"/>
+              <a:t>Exercise</a:t>
+            </a:r>
+          </a:p>
+        </p:txBody>
+      </p:sp>
+    </p:spTree>
+    <p:extLst>
+      <p:ext uri="{BB962C8B-B14F-4D97-AF65-F5344CB8AC3E}">
+        <p14:creationId xmlns:p14="http://schemas.microsoft.com/office/powerpoint/2010/main" val="680839714"/>
+      </p:ext>
+    </p:extLst>
+  </p:cSld>
+  <p:clrMapOvr>
+    <a:masterClrMapping/>
+  </p:clrMapOvr>
+</p:sld>
+</file>
+
+<file path=ppt/slides/slide12.xml><?xml version="1.0" encoding="utf-8"?>
+<p:sld xmlns:a="http://schemas.openxmlformats.org/drawingml/2006/main" xmlns:r="http://schemas.openxmlformats.org/officeDocument/2006/relationships" xmlns:p="http://schemas.openxmlformats.org/presentationml/2006/main">
+  <p:cSld>
+    <p:spTree>
+      <p:nvGrpSpPr>
+        <p:cNvPr id="1" name=""/>
+        <p:cNvGrpSpPr/>
+        <p:nvPr/>
+      </p:nvGrpSpPr>
+      <p:grpSpPr>
+        <a:xfrm>
+          <a:off x="0" y="0"/>
+          <a:ext cx="0" cy="0"/>
+          <a:chOff x="0" y="0"/>
+          <a:chExt cx="0" cy="0"/>
+        </a:xfrm>
+      </p:grpSpPr>
+      <p:sp>
+        <p:nvSpPr>
           <p:cNvPr id="2" name="Title 1">
             <a:extLst>
               <a:ext uri="{FF2B5EF4-FFF2-40B4-BE49-F238E27FC236}">
@@ -6397,152 +6315,6 @@
 </p:sld>
 </file>
 
-<file path=ppt/slides/slide12.xml><?xml version="1.0" encoding="utf-8"?>
-<p:sld xmlns:a="http://schemas.openxmlformats.org/drawingml/2006/main" xmlns:r="http://schemas.openxmlformats.org/officeDocument/2006/relationships" xmlns:p="http://schemas.openxmlformats.org/presentationml/2006/main">
-  <p:cSld>
-    <p:spTree>
-      <p:nvGrpSpPr>
-        <p:cNvPr id="1" name=""/>
-        <p:cNvGrpSpPr/>
-        <p:nvPr/>
-      </p:nvGrpSpPr>
-      <p:grpSpPr>
-        <a:xfrm>
-          <a:off x="0" y="0"/>
-          <a:ext cx="0" cy="0"/>
-          <a:chOff x="0" y="0"/>
-          <a:chExt cx="0" cy="0"/>
-        </a:xfrm>
-      </p:grpSpPr>
-      <p:sp>
-        <p:nvSpPr>
-          <p:cNvPr id="2" name="Text Placeholder 1">
-            <a:extLst>
-              <a:ext uri="{FF2B5EF4-FFF2-40B4-BE49-F238E27FC236}">
-                <a16:creationId xmlns:a16="http://schemas.microsoft.com/office/drawing/2014/main" id="{9B245876-087E-37FF-2A45-491803B93EF5}"/>
-              </a:ext>
-            </a:extLst>
-          </p:cNvPr>
-          <p:cNvSpPr>
-            <a:spLocks noGrp="1"/>
-          </p:cNvSpPr>
-          <p:nvPr>
-            <p:ph type="body" sz="quarter" idx="10"/>
-          </p:nvPr>
-        </p:nvSpPr>
-        <p:spPr>
-          <a:xfrm>
-            <a:off x="242372" y="2940626"/>
-            <a:ext cx="8658743" cy="3437951"/>
-          </a:xfrm>
-        </p:spPr>
-        <p:txBody>
-          <a:bodyPr>
-            <a:normAutofit/>
-          </a:bodyPr>
-          <a:lstStyle/>
-          <a:p>
-            <a:r>
-              <a:rPr lang="en-CA" dirty="0"/>
-              <a:t>Explore the 1_Simple_Scripts folder 			     (open the project with the </a:t>
-            </a:r>
-            <a:r>
-              <a:rPr lang="en-CA" i="1" dirty="0"/>
-              <a:t>1_Simple_Scripts.Rproj</a:t>
-            </a:r>
-            <a:r>
-              <a:rPr lang="en-CA" dirty="0"/>
-              <a:t> file)</a:t>
-            </a:r>
-          </a:p>
-          <a:p>
-            <a:endParaRPr lang="en-CA" dirty="0"/>
-          </a:p>
-          <a:p>
-            <a:r>
-              <a:rPr lang="en-CA" dirty="0"/>
-              <a:t>Try running the code</a:t>
-            </a:r>
-          </a:p>
-          <a:p>
-            <a:endParaRPr lang="en-CA" dirty="0"/>
-          </a:p>
-          <a:p>
-            <a:r>
-              <a:rPr lang="en-CA" dirty="0"/>
-              <a:t>What would happen if you wanted to run this in a different folder?</a:t>
-            </a:r>
-          </a:p>
-        </p:txBody>
-      </p:sp>
-      <p:sp>
-        <p:nvSpPr>
-          <p:cNvPr id="3" name="Title 1">
-            <a:extLst>
-              <a:ext uri="{FF2B5EF4-FFF2-40B4-BE49-F238E27FC236}">
-                <a16:creationId xmlns:a16="http://schemas.microsoft.com/office/drawing/2014/main" id="{D0AE3FC0-C652-C431-6A10-987A06B22130}"/>
-              </a:ext>
-            </a:extLst>
-          </p:cNvPr>
-          <p:cNvSpPr txBox="1">
-            <a:spLocks/>
-          </p:cNvSpPr>
-          <p:nvPr/>
-        </p:nvSpPr>
-        <p:spPr>
-          <a:xfrm>
-            <a:off x="242372" y="1558637"/>
-            <a:ext cx="8658743" cy="1007918"/>
-          </a:xfrm>
-          <a:prstGeom prst="rect">
-            <a:avLst/>
-          </a:prstGeom>
-        </p:spPr>
-        <p:txBody>
-          <a:bodyPr>
-            <a:noAutofit/>
-          </a:bodyPr>
-          <a:lstStyle>
-            <a:lvl1pPr algn="l" defTabSz="914175" rtl="0" eaLnBrk="1" latinLnBrk="0" hangingPunct="1">
-              <a:lnSpc>
-                <a:spcPct val="90000"/>
-              </a:lnSpc>
-              <a:spcBef>
-                <a:spcPct val="0"/>
-              </a:spcBef>
-              <a:buNone/>
-              <a:defRPr sz="4403" kern="1200">
-                <a:solidFill>
-                  <a:schemeClr val="tx1"/>
-                </a:solidFill>
-                <a:latin typeface="+mj-lt"/>
-                <a:ea typeface="+mj-ea"/>
-                <a:cs typeface="+mj-cs"/>
-              </a:defRPr>
-            </a:lvl1pPr>
-          </a:lstStyle>
-          <a:p>
-            <a:pPr algn="ctr"/>
-            <a:r>
-              <a:rPr lang="en-CA" sz="7200" dirty="0"/>
-              <a:t>Exercise</a:t>
-            </a:r>
-          </a:p>
-        </p:txBody>
-      </p:sp>
-    </p:spTree>
-    <p:extLst>
-      <p:ext uri="{BB962C8B-B14F-4D97-AF65-F5344CB8AC3E}">
-        <p14:creationId xmlns:p14="http://schemas.microsoft.com/office/powerpoint/2010/main" val="680839714"/>
-      </p:ext>
-    </p:extLst>
-  </p:cSld>
-  <p:clrMapOvr>
-    <a:masterClrMapping/>
-  </p:clrMapOvr>
-</p:sld>
-</file>
-
 <file path=ppt/slides/slide13.xml><?xml version="1.0" encoding="utf-8"?>
 <p:sld xmlns:a="http://schemas.openxmlformats.org/drawingml/2006/main" xmlns:r="http://schemas.openxmlformats.org/officeDocument/2006/relationships" xmlns:p="http://schemas.openxmlformats.org/presentationml/2006/main">
   <p:cSld>
@@ -6607,7 +6379,7 @@
         <p:spPr>
           <a:xfrm>
             <a:off x="628649" y="1825627"/>
-            <a:ext cx="4743451" cy="4907682"/>
+            <a:ext cx="5447298" cy="4907682"/>
           </a:xfrm>
         </p:spPr>
         <p:txBody>
@@ -6632,7 +6404,7 @@
           </a:p>
           <a:p>
             <a:r>
-              <a:rPr lang="en-CA" dirty="0"/>
+              <a:rPr lang="en-CA" b="1" dirty="0"/>
               <a:t>No file path needed</a:t>
             </a:r>
           </a:p>
@@ -6641,7 +6413,7 @@
           </a:p>
           <a:p>
             <a:r>
-              <a:rPr lang="en-CA" dirty="0"/>
+              <a:rPr lang="en-CA" b="1" dirty="0"/>
               <a:t>Facilitates installation</a:t>
             </a:r>
           </a:p>
@@ -6653,7 +6425,7 @@
           </a:p>
           <a:p>
             <a:r>
-              <a:rPr lang="en-CA" dirty="0"/>
+              <a:rPr lang="en-CA" b="1" dirty="0"/>
               <a:t>Easy documentation interface</a:t>
             </a:r>
           </a:p>
@@ -7934,7 +7706,7 @@
         </p:nvSpPr>
         <p:spPr>
           <a:xfrm>
-            <a:off x="195574" y="1394848"/>
+            <a:off x="195574" y="2383978"/>
             <a:ext cx="8499764" cy="1241822"/>
           </a:xfrm>
         </p:spPr>
@@ -7981,12 +7753,9 @@
           </a:bodyPr>
           <a:lstStyle/>
           <a:p>
-            <a:r>
-              <a:rPr lang="en-AU" sz="2700" dirty="0">
-                <a:latin typeface="Montserrat SemiBold" panose="00000700000000000000" pitchFamily="50" charset="0"/>
-              </a:rPr>
-              <a:t>Session #: Session Name</a:t>
-            </a:r>
+            <a:endParaRPr lang="en-AU" sz="2700" dirty="0">
+              <a:latin typeface="Montserrat SemiBold" panose="00000700000000000000" pitchFamily="50" charset="0"/>
+            </a:endParaRPr>
           </a:p>
         </p:txBody>
       </p:sp>
@@ -9789,6 +9558,29 @@
             <a:r>
               <a:rPr lang="en-CA" dirty="0"/>
               <a:t>() to update the function manual</a:t>
+            </a:r>
+          </a:p>
+          <a:p>
+            <a:pPr lvl="1"/>
+            <a:r>
+              <a:rPr lang="en-CA" dirty="0"/>
+              <a:t>Run </a:t>
+            </a:r>
+            <a:r>
+              <a:rPr lang="en-CA" dirty="0" err="1"/>
+              <a:t>devtools</a:t>
+            </a:r>
+            <a:r>
+              <a:rPr lang="en-CA" dirty="0"/>
+              <a:t>::</a:t>
+            </a:r>
+            <a:r>
+              <a:rPr lang="en-CA" dirty="0" err="1"/>
+              <a:t>build_manual</a:t>
+            </a:r>
+            <a:r>
+              <a:rPr lang="en-CA" dirty="0"/>
+              <a:t>() to render the pdf</a:t>
             </a:r>
           </a:p>
           <a:p>
@@ -20560,6 +20352,156 @@
           <p:cNvPr id="2" name="Title 1">
             <a:extLst>
               <a:ext uri="{FF2B5EF4-FFF2-40B4-BE49-F238E27FC236}">
+                <a16:creationId xmlns:a16="http://schemas.microsoft.com/office/drawing/2014/main" id="{02C00D68-F1C3-212D-8170-BA5F24E37452}"/>
+              </a:ext>
+            </a:extLst>
+          </p:cNvPr>
+          <p:cNvSpPr>
+            <a:spLocks noGrp="1"/>
+          </p:cNvSpPr>
+          <p:nvPr>
+            <p:ph type="title"/>
+          </p:nvPr>
+        </p:nvSpPr>
+        <p:spPr/>
+        <p:txBody>
+          <a:bodyPr/>
+          <a:lstStyle/>
+          <a:p>
+            <a:r>
+              <a:rPr lang="en-CA" dirty="0"/>
+              <a:t>Summary</a:t>
+            </a:r>
+          </a:p>
+        </p:txBody>
+      </p:sp>
+      <p:sp>
+        <p:nvSpPr>
+          <p:cNvPr id="3" name="Content Placeholder 2">
+            <a:extLst>
+              <a:ext uri="{FF2B5EF4-FFF2-40B4-BE49-F238E27FC236}">
+                <a16:creationId xmlns:a16="http://schemas.microsoft.com/office/drawing/2014/main" id="{DF96A6F8-7B65-2672-7BE0-132DDF0CB76C}"/>
+              </a:ext>
+            </a:extLst>
+          </p:cNvPr>
+          <p:cNvSpPr>
+            <a:spLocks noGrp="1"/>
+          </p:cNvSpPr>
+          <p:nvPr>
+            <p:ph idx="1"/>
+          </p:nvPr>
+        </p:nvSpPr>
+        <p:spPr/>
+        <p:txBody>
+          <a:bodyPr>
+            <a:normAutofit lnSpcReduction="10000"/>
+          </a:bodyPr>
+          <a:lstStyle/>
+          <a:p>
+            <a:r>
+              <a:rPr lang="en-CA" dirty="0"/>
+              <a:t>Packages facilitate tool access for users</a:t>
+            </a:r>
+          </a:p>
+          <a:p>
+            <a:pPr lvl="1"/>
+            <a:r>
+              <a:rPr lang="en-CA" dirty="0"/>
+              <a:t>Easier installation</a:t>
+            </a:r>
+          </a:p>
+          <a:p>
+            <a:pPr lvl="1"/>
+            <a:r>
+              <a:rPr lang="en-CA" dirty="0"/>
+              <a:t>Intuitive documentation interface</a:t>
+            </a:r>
+          </a:p>
+          <a:p>
+            <a:pPr lvl="1"/>
+            <a:endParaRPr lang="en-CA" dirty="0"/>
+          </a:p>
+          <a:p>
+            <a:r>
+              <a:rPr lang="en-CA" dirty="0"/>
+              <a:t>Packages facilitate tool development</a:t>
+            </a:r>
+          </a:p>
+          <a:p>
+            <a:pPr lvl="1"/>
+            <a:r>
+              <a:rPr lang="en-CA" dirty="0"/>
+              <a:t>Testing and documentation check pipeline</a:t>
+            </a:r>
+          </a:p>
+          <a:p>
+            <a:pPr lvl="1"/>
+            <a:r>
+              <a:rPr lang="en-CA" dirty="0"/>
+              <a:t>Automated documentation tools</a:t>
+            </a:r>
+          </a:p>
+          <a:p>
+            <a:pPr lvl="1"/>
+            <a:r>
+              <a:rPr lang="en-CA" dirty="0"/>
+              <a:t>Structured formatting</a:t>
+            </a:r>
+          </a:p>
+          <a:p>
+            <a:pPr lvl="1"/>
+            <a:endParaRPr lang="en-CA" dirty="0"/>
+          </a:p>
+          <a:p>
+            <a:r>
+              <a:rPr lang="en-CA" dirty="0"/>
+              <a:t>GitHub Actions can facilitate maintenance</a:t>
+            </a:r>
+          </a:p>
+          <a:p>
+            <a:pPr lvl="1"/>
+            <a:r>
+              <a:rPr lang="en-CA" dirty="0"/>
+              <a:t>Scenario-specific automation</a:t>
+            </a:r>
+          </a:p>
+        </p:txBody>
+      </p:sp>
+    </p:spTree>
+    <p:extLst>
+      <p:ext uri="{BB962C8B-B14F-4D97-AF65-F5344CB8AC3E}">
+        <p14:creationId xmlns:p14="http://schemas.microsoft.com/office/powerpoint/2010/main" val="1171437104"/>
+      </p:ext>
+    </p:extLst>
+  </p:cSld>
+  <p:clrMapOvr>
+    <a:masterClrMapping/>
+  </p:clrMapOvr>
+</p:sld>
+</file>
+
+<file path=ppt/slides/slide48.xml><?xml version="1.0" encoding="utf-8"?>
+<p:sld xmlns:a="http://schemas.openxmlformats.org/drawingml/2006/main" xmlns:r="http://schemas.openxmlformats.org/officeDocument/2006/relationships" xmlns:p="http://schemas.openxmlformats.org/presentationml/2006/main">
+  <p:cSld>
+    <p:spTree>
+      <p:nvGrpSpPr>
+        <p:cNvPr id="1" name=""/>
+        <p:cNvGrpSpPr/>
+        <p:nvPr/>
+      </p:nvGrpSpPr>
+      <p:grpSpPr>
+        <a:xfrm>
+          <a:off x="0" y="0"/>
+          <a:ext cx="0" cy="0"/>
+          <a:chOff x="0" y="0"/>
+          <a:chExt cx="0" cy="0"/>
+        </a:xfrm>
+      </p:grpSpPr>
+      <p:sp>
+        <p:nvSpPr>
+          <p:cNvPr id="2" name="Title 1">
+            <a:extLst>
+              <a:ext uri="{FF2B5EF4-FFF2-40B4-BE49-F238E27FC236}">
                 <a16:creationId xmlns:a16="http://schemas.microsoft.com/office/drawing/2014/main" id="{53D5D50F-4F28-B4DF-B643-598DE496FEDD}"/>
               </a:ext>
             </a:extLst>
@@ -20596,7 +20538,7 @@
 </p:sld>
 </file>
 
-<file path=ppt/slides/slide48.xml><?xml version="1.0" encoding="utf-8"?>
+<file path=ppt/slides/slide49.xml><?xml version="1.0" encoding="utf-8"?>
 <p:sld xmlns:a="http://schemas.openxmlformats.org/drawingml/2006/main" xmlns:r="http://schemas.openxmlformats.org/officeDocument/2006/relationships" xmlns:p="http://schemas.openxmlformats.org/presentationml/2006/main">
   <p:cSld>
     <p:spTree>
@@ -20755,239 +20697,6 @@
 </p:sld>
 </file>
 
-<file path=ppt/slides/slide49.xml><?xml version="1.0" encoding="utf-8"?>
-<p:sld xmlns:a="http://schemas.openxmlformats.org/drawingml/2006/main" xmlns:r="http://schemas.openxmlformats.org/officeDocument/2006/relationships" xmlns:p="http://schemas.openxmlformats.org/presentationml/2006/main">
-  <p:cSld>
-    <p:spTree>
-      <p:nvGrpSpPr>
-        <p:cNvPr id="1" name=""/>
-        <p:cNvGrpSpPr/>
-        <p:nvPr/>
-      </p:nvGrpSpPr>
-      <p:grpSpPr>
-        <a:xfrm>
-          <a:off x="0" y="0"/>
-          <a:ext cx="0" cy="0"/>
-          <a:chOff x="0" y="0"/>
-          <a:chExt cx="0" cy="0"/>
-        </a:xfrm>
-      </p:grpSpPr>
-      <p:sp>
-        <p:nvSpPr>
-          <p:cNvPr id="2" name="Title 1">
-            <a:extLst>
-              <a:ext uri="{FF2B5EF4-FFF2-40B4-BE49-F238E27FC236}">
-                <a16:creationId xmlns:a16="http://schemas.microsoft.com/office/drawing/2014/main" id="{AD828D01-6295-9CD0-A2A8-D520CA4A343F}"/>
-              </a:ext>
-            </a:extLst>
-          </p:cNvPr>
-          <p:cNvSpPr>
-            <a:spLocks noGrp="1"/>
-          </p:cNvSpPr>
-          <p:nvPr>
-            <p:ph type="title"/>
-          </p:nvPr>
-        </p:nvSpPr>
-        <p:spPr>
-          <a:xfrm>
-            <a:off x="2750344" y="1603021"/>
-            <a:ext cx="3643312" cy="1006479"/>
-          </a:xfrm>
-        </p:spPr>
-        <p:txBody>
-          <a:bodyPr/>
-          <a:lstStyle/>
-          <a:p>
-            <a:r>
-              <a:rPr lang="en-US" dirty="0"/>
-              <a:t>Thank you!</a:t>
-            </a:r>
-          </a:p>
-        </p:txBody>
-      </p:sp>
-      <p:pic>
-        <p:nvPicPr>
-          <p:cNvPr id="3" name="Content Placeholder 4">
-            <a:extLst>
-              <a:ext uri="{FF2B5EF4-FFF2-40B4-BE49-F238E27FC236}">
-                <a16:creationId xmlns:a16="http://schemas.microsoft.com/office/drawing/2014/main" id="{D2BAEF11-DF57-F87B-0DE1-C7BE3199774C}"/>
-              </a:ext>
-            </a:extLst>
-          </p:cNvPr>
-          <p:cNvPicPr>
-            <a:picLocks noChangeAspect="1"/>
-          </p:cNvPicPr>
-          <p:nvPr/>
-        </p:nvPicPr>
-        <p:blipFill>
-          <a:blip r:embed="rId2">
-            <a:extLst>
-              <a:ext uri="{28A0092B-C50C-407E-A947-70E740481C1C}">
-                <a14:useLocalDpi xmlns:a14="http://schemas.microsoft.com/office/drawing/2010/main" val="0"/>
-              </a:ext>
-            </a:extLst>
-          </a:blip>
-          <a:stretch>
-            <a:fillRect/>
-          </a:stretch>
-        </p:blipFill>
-        <p:spPr>
-          <a:xfrm>
-            <a:off x="90311" y="5938598"/>
-            <a:ext cx="2878667" cy="741794"/>
-          </a:xfrm>
-          <a:prstGeom prst="rect">
-            <a:avLst/>
-          </a:prstGeom>
-        </p:spPr>
-      </p:pic>
-      <p:pic>
-        <p:nvPicPr>
-          <p:cNvPr id="4" name="Picture 3">
-            <a:extLst>
-              <a:ext uri="{FF2B5EF4-FFF2-40B4-BE49-F238E27FC236}">
-                <a16:creationId xmlns:a16="http://schemas.microsoft.com/office/drawing/2014/main" id="{0A32D887-B248-C56F-D4CD-C76954C2A5EA}"/>
-              </a:ext>
-            </a:extLst>
-          </p:cNvPr>
-          <p:cNvPicPr>
-            <a:picLocks noChangeAspect="1"/>
-          </p:cNvPicPr>
-          <p:nvPr/>
-        </p:nvPicPr>
-        <p:blipFill>
-          <a:blip r:embed="rId3"/>
-          <a:stretch>
-            <a:fillRect/>
-          </a:stretch>
-        </p:blipFill>
-        <p:spPr>
-          <a:xfrm>
-            <a:off x="5635977" y="3004898"/>
-            <a:ext cx="2933700" cy="2933700"/>
-          </a:xfrm>
-          <a:prstGeom prst="rect">
-            <a:avLst/>
-          </a:prstGeom>
-        </p:spPr>
-      </p:pic>
-      <p:sp>
-        <p:nvSpPr>
-          <p:cNvPr id="5" name="TextBox 4">
-            <a:extLst>
-              <a:ext uri="{FF2B5EF4-FFF2-40B4-BE49-F238E27FC236}">
-                <a16:creationId xmlns:a16="http://schemas.microsoft.com/office/drawing/2014/main" id="{1186AD2E-30E2-4066-0067-9E12E0C232DB}"/>
-              </a:ext>
-            </a:extLst>
-          </p:cNvPr>
-          <p:cNvSpPr txBox="1"/>
-          <p:nvPr/>
-        </p:nvSpPr>
-        <p:spPr>
-          <a:xfrm>
-            <a:off x="5814836" y="2820168"/>
-            <a:ext cx="2575982" cy="369460"/>
-          </a:xfrm>
-          <a:prstGeom prst="rect">
-            <a:avLst/>
-          </a:prstGeom>
-          <a:noFill/>
-        </p:spPr>
-        <p:txBody>
-          <a:bodyPr wrap="square" rtlCol="0">
-            <a:spAutoFit/>
-          </a:bodyPr>
-          <a:lstStyle/>
-          <a:p>
-            <a:r>
-              <a:rPr lang="en-US" dirty="0"/>
-              <a:t>Biostatistics Section – SSC</a:t>
-            </a:r>
-          </a:p>
-        </p:txBody>
-      </p:sp>
-      <p:pic>
-        <p:nvPicPr>
-          <p:cNvPr id="6" name="Picture 5">
-            <a:extLst>
-              <a:ext uri="{FF2B5EF4-FFF2-40B4-BE49-F238E27FC236}">
-                <a16:creationId xmlns:a16="http://schemas.microsoft.com/office/drawing/2014/main" id="{2CF9868A-40A2-5F1C-8D2F-7B17D97E4850}"/>
-              </a:ext>
-            </a:extLst>
-          </p:cNvPr>
-          <p:cNvPicPr>
-            <a:picLocks noChangeAspect="1"/>
-          </p:cNvPicPr>
-          <p:nvPr/>
-        </p:nvPicPr>
-        <p:blipFill>
-          <a:blip r:embed="rId4"/>
-          <a:stretch>
-            <a:fillRect/>
-          </a:stretch>
-        </p:blipFill>
-        <p:spPr>
-          <a:xfrm>
-            <a:off x="574324" y="3004898"/>
-            <a:ext cx="2933700" cy="2933700"/>
-          </a:xfrm>
-          <a:prstGeom prst="rect">
-            <a:avLst/>
-          </a:prstGeom>
-        </p:spPr>
-      </p:pic>
-      <p:sp>
-        <p:nvSpPr>
-          <p:cNvPr id="7" name="TextBox 6">
-            <a:extLst>
-              <a:ext uri="{FF2B5EF4-FFF2-40B4-BE49-F238E27FC236}">
-                <a16:creationId xmlns:a16="http://schemas.microsoft.com/office/drawing/2014/main" id="{D2045168-AFC9-111D-EFD6-E702AAED7BC9}"/>
-              </a:ext>
-            </a:extLst>
-          </p:cNvPr>
-          <p:cNvSpPr txBox="1"/>
-          <p:nvPr/>
-        </p:nvSpPr>
-        <p:spPr>
-          <a:xfrm>
-            <a:off x="1102610" y="2829403"/>
-            <a:ext cx="1877128" cy="369460"/>
-          </a:xfrm>
-          <a:prstGeom prst="rect">
-            <a:avLst/>
-          </a:prstGeom>
-          <a:noFill/>
-        </p:spPr>
-        <p:txBody>
-          <a:bodyPr wrap="square" rtlCol="0">
-            <a:spAutoFit/>
-          </a:bodyPr>
-          <a:lstStyle/>
-          <a:p>
-            <a:r>
-              <a:rPr lang="en-US" dirty="0" err="1"/>
-              <a:t>MiCM</a:t>
-            </a:r>
-            <a:r>
-              <a:rPr lang="en-US" dirty="0"/>
-              <a:t> Mailing List</a:t>
-            </a:r>
-          </a:p>
-        </p:txBody>
-      </p:sp>
-    </p:spTree>
-    <p:extLst>
-      <p:ext uri="{BB962C8B-B14F-4D97-AF65-F5344CB8AC3E}">
-        <p14:creationId xmlns:p14="http://schemas.microsoft.com/office/powerpoint/2010/main" val="2803926213"/>
-      </p:ext>
-    </p:extLst>
-  </p:cSld>
-  <p:clrMapOvr>
-    <a:masterClrMapping/>
-  </p:clrMapOvr>
-</p:sld>
-</file>
-
 <file path=ppt/slides/slide5.xml><?xml version="1.0" encoding="utf-8"?>
 <p:sld xmlns:a="http://schemas.openxmlformats.org/drawingml/2006/main" xmlns:r="http://schemas.openxmlformats.org/officeDocument/2006/relationships" xmlns:p="http://schemas.openxmlformats.org/presentationml/2006/main">
   <p:cSld>
@@ -21230,6 +20939,239 @@
 </file>
 
 <file path=ppt/slides/slide50.xml><?xml version="1.0" encoding="utf-8"?>
+<p:sld xmlns:a="http://schemas.openxmlformats.org/drawingml/2006/main" xmlns:r="http://schemas.openxmlformats.org/officeDocument/2006/relationships" xmlns:p="http://schemas.openxmlformats.org/presentationml/2006/main">
+  <p:cSld>
+    <p:spTree>
+      <p:nvGrpSpPr>
+        <p:cNvPr id="1" name=""/>
+        <p:cNvGrpSpPr/>
+        <p:nvPr/>
+      </p:nvGrpSpPr>
+      <p:grpSpPr>
+        <a:xfrm>
+          <a:off x="0" y="0"/>
+          <a:ext cx="0" cy="0"/>
+          <a:chOff x="0" y="0"/>
+          <a:chExt cx="0" cy="0"/>
+        </a:xfrm>
+      </p:grpSpPr>
+      <p:sp>
+        <p:nvSpPr>
+          <p:cNvPr id="2" name="Title 1">
+            <a:extLst>
+              <a:ext uri="{FF2B5EF4-FFF2-40B4-BE49-F238E27FC236}">
+                <a16:creationId xmlns:a16="http://schemas.microsoft.com/office/drawing/2014/main" id="{AD828D01-6295-9CD0-A2A8-D520CA4A343F}"/>
+              </a:ext>
+            </a:extLst>
+          </p:cNvPr>
+          <p:cNvSpPr>
+            <a:spLocks noGrp="1"/>
+          </p:cNvSpPr>
+          <p:nvPr>
+            <p:ph type="title"/>
+          </p:nvPr>
+        </p:nvSpPr>
+        <p:spPr>
+          <a:xfrm>
+            <a:off x="2750344" y="1603021"/>
+            <a:ext cx="3643312" cy="1006479"/>
+          </a:xfrm>
+        </p:spPr>
+        <p:txBody>
+          <a:bodyPr/>
+          <a:lstStyle/>
+          <a:p>
+            <a:r>
+              <a:rPr lang="en-US" dirty="0"/>
+              <a:t>Thank you!</a:t>
+            </a:r>
+          </a:p>
+        </p:txBody>
+      </p:sp>
+      <p:pic>
+        <p:nvPicPr>
+          <p:cNvPr id="3" name="Content Placeholder 4">
+            <a:extLst>
+              <a:ext uri="{FF2B5EF4-FFF2-40B4-BE49-F238E27FC236}">
+                <a16:creationId xmlns:a16="http://schemas.microsoft.com/office/drawing/2014/main" id="{D2BAEF11-DF57-F87B-0DE1-C7BE3199774C}"/>
+              </a:ext>
+            </a:extLst>
+          </p:cNvPr>
+          <p:cNvPicPr>
+            <a:picLocks noChangeAspect="1"/>
+          </p:cNvPicPr>
+          <p:nvPr/>
+        </p:nvPicPr>
+        <p:blipFill>
+          <a:blip r:embed="rId2">
+            <a:extLst>
+              <a:ext uri="{28A0092B-C50C-407E-A947-70E740481C1C}">
+                <a14:useLocalDpi xmlns:a14="http://schemas.microsoft.com/office/drawing/2010/main" val="0"/>
+              </a:ext>
+            </a:extLst>
+          </a:blip>
+          <a:stretch>
+            <a:fillRect/>
+          </a:stretch>
+        </p:blipFill>
+        <p:spPr>
+          <a:xfrm>
+            <a:off x="90311" y="5938598"/>
+            <a:ext cx="2878667" cy="741794"/>
+          </a:xfrm>
+          <a:prstGeom prst="rect">
+            <a:avLst/>
+          </a:prstGeom>
+        </p:spPr>
+      </p:pic>
+      <p:pic>
+        <p:nvPicPr>
+          <p:cNvPr id="4" name="Picture 3">
+            <a:extLst>
+              <a:ext uri="{FF2B5EF4-FFF2-40B4-BE49-F238E27FC236}">
+                <a16:creationId xmlns:a16="http://schemas.microsoft.com/office/drawing/2014/main" id="{0A32D887-B248-C56F-D4CD-C76954C2A5EA}"/>
+              </a:ext>
+            </a:extLst>
+          </p:cNvPr>
+          <p:cNvPicPr>
+            <a:picLocks noChangeAspect="1"/>
+          </p:cNvPicPr>
+          <p:nvPr/>
+        </p:nvPicPr>
+        <p:blipFill>
+          <a:blip r:embed="rId3"/>
+          <a:stretch>
+            <a:fillRect/>
+          </a:stretch>
+        </p:blipFill>
+        <p:spPr>
+          <a:xfrm>
+            <a:off x="5635977" y="3004898"/>
+            <a:ext cx="2933700" cy="2933700"/>
+          </a:xfrm>
+          <a:prstGeom prst="rect">
+            <a:avLst/>
+          </a:prstGeom>
+        </p:spPr>
+      </p:pic>
+      <p:sp>
+        <p:nvSpPr>
+          <p:cNvPr id="5" name="TextBox 4">
+            <a:extLst>
+              <a:ext uri="{FF2B5EF4-FFF2-40B4-BE49-F238E27FC236}">
+                <a16:creationId xmlns:a16="http://schemas.microsoft.com/office/drawing/2014/main" id="{1186AD2E-30E2-4066-0067-9E12E0C232DB}"/>
+              </a:ext>
+            </a:extLst>
+          </p:cNvPr>
+          <p:cNvSpPr txBox="1"/>
+          <p:nvPr/>
+        </p:nvSpPr>
+        <p:spPr>
+          <a:xfrm>
+            <a:off x="5814836" y="2820168"/>
+            <a:ext cx="2575982" cy="369460"/>
+          </a:xfrm>
+          <a:prstGeom prst="rect">
+            <a:avLst/>
+          </a:prstGeom>
+          <a:noFill/>
+        </p:spPr>
+        <p:txBody>
+          <a:bodyPr wrap="square" rtlCol="0">
+            <a:spAutoFit/>
+          </a:bodyPr>
+          <a:lstStyle/>
+          <a:p>
+            <a:r>
+              <a:rPr lang="en-US" dirty="0"/>
+              <a:t>Biostatistics Section – SSC</a:t>
+            </a:r>
+          </a:p>
+        </p:txBody>
+      </p:sp>
+      <p:pic>
+        <p:nvPicPr>
+          <p:cNvPr id="6" name="Picture 5">
+            <a:extLst>
+              <a:ext uri="{FF2B5EF4-FFF2-40B4-BE49-F238E27FC236}">
+                <a16:creationId xmlns:a16="http://schemas.microsoft.com/office/drawing/2014/main" id="{2CF9868A-40A2-5F1C-8D2F-7B17D97E4850}"/>
+              </a:ext>
+            </a:extLst>
+          </p:cNvPr>
+          <p:cNvPicPr>
+            <a:picLocks noChangeAspect="1"/>
+          </p:cNvPicPr>
+          <p:nvPr/>
+        </p:nvPicPr>
+        <p:blipFill>
+          <a:blip r:embed="rId4"/>
+          <a:stretch>
+            <a:fillRect/>
+          </a:stretch>
+        </p:blipFill>
+        <p:spPr>
+          <a:xfrm>
+            <a:off x="574324" y="3004898"/>
+            <a:ext cx="2933700" cy="2933700"/>
+          </a:xfrm>
+          <a:prstGeom prst="rect">
+            <a:avLst/>
+          </a:prstGeom>
+        </p:spPr>
+      </p:pic>
+      <p:sp>
+        <p:nvSpPr>
+          <p:cNvPr id="7" name="TextBox 6">
+            <a:extLst>
+              <a:ext uri="{FF2B5EF4-FFF2-40B4-BE49-F238E27FC236}">
+                <a16:creationId xmlns:a16="http://schemas.microsoft.com/office/drawing/2014/main" id="{D2045168-AFC9-111D-EFD6-E702AAED7BC9}"/>
+              </a:ext>
+            </a:extLst>
+          </p:cNvPr>
+          <p:cNvSpPr txBox="1"/>
+          <p:nvPr/>
+        </p:nvSpPr>
+        <p:spPr>
+          <a:xfrm>
+            <a:off x="1102610" y="2829403"/>
+            <a:ext cx="1877128" cy="369460"/>
+          </a:xfrm>
+          <a:prstGeom prst="rect">
+            <a:avLst/>
+          </a:prstGeom>
+          <a:noFill/>
+        </p:spPr>
+        <p:txBody>
+          <a:bodyPr wrap="square" rtlCol="0">
+            <a:spAutoFit/>
+          </a:bodyPr>
+          <a:lstStyle/>
+          <a:p>
+            <a:r>
+              <a:rPr lang="en-US" dirty="0" err="1"/>
+              <a:t>MiCM</a:t>
+            </a:r>
+            <a:r>
+              <a:rPr lang="en-US" dirty="0"/>
+              <a:t> Mailing List</a:t>
+            </a:r>
+          </a:p>
+        </p:txBody>
+      </p:sp>
+    </p:spTree>
+    <p:extLst>
+      <p:ext uri="{BB962C8B-B14F-4D97-AF65-F5344CB8AC3E}">
+        <p14:creationId xmlns:p14="http://schemas.microsoft.com/office/powerpoint/2010/main" val="2803926213"/>
+      </p:ext>
+    </p:extLst>
+  </p:cSld>
+  <p:clrMapOvr>
+    <a:masterClrMapping/>
+  </p:clrMapOvr>
+</p:sld>
+</file>
+
+<file path=ppt/slides/slide51.xml><?xml version="1.0" encoding="utf-8"?>
 <p:sld xmlns:a="http://schemas.openxmlformats.org/drawingml/2006/main" xmlns:r="http://schemas.openxmlformats.org/officeDocument/2006/relationships" xmlns:p="http://schemas.openxmlformats.org/presentationml/2006/main">
   <p:cSld>
     <p:spTree>

</xml_diff>